<commit_message>
Ship Sobha demo control polish
</commit_message>
<xml_diff>
--- a/artifacts/pitch-packs/sobha-realty/sobha_4c360_executive_pitch_deck.pptx
+++ b/artifacts/pitch-packs/sobha-realty/sobha_4c360_executive_pitch_deck.pptx
@@ -2,22 +2,22 @@
 <file path=ppt/presentation.xml><?xml version="1.0" encoding="utf-8"?>
 <p:presentation xmlns:p="http://schemas.openxmlformats.org/presentationml/2006/main">
   <p:sldMasterIdLst>
-    <p:sldMasterId xmlns:r="http://schemas.openxmlformats.org/officeDocument/2006/relationships" id="2147483648" r:id="Rca80252cfb524f92"/>
+    <p:sldMasterId xmlns:r="http://schemas.openxmlformats.org/officeDocument/2006/relationships" id="2147483648" r:id="R7a6355be2cd74b31"/>
   </p:sldMasterIdLst>
   <p:notesMasterIdLst>
-    <p:notesMasterId xmlns:r="http://schemas.openxmlformats.org/officeDocument/2006/relationships" r:id="Raf86d34b6db64676"/>
+    <p:notesMasterId xmlns:r="http://schemas.openxmlformats.org/officeDocument/2006/relationships" r:id="Rc609190412f34ccb"/>
   </p:notesMasterIdLst>
   <p:sldIdLst>
-    <p:sldId xmlns:r="http://schemas.openxmlformats.org/officeDocument/2006/relationships" id="256" r:id="R00eef52fc2334716"/>
-    <p:sldId xmlns:r="http://schemas.openxmlformats.org/officeDocument/2006/relationships" id="257" r:id="R9e1427bea3d64a0c"/>
-    <p:sldId xmlns:r="http://schemas.openxmlformats.org/officeDocument/2006/relationships" id="258" r:id="R2bd4e380caaa431f"/>
-    <p:sldId xmlns:r="http://schemas.openxmlformats.org/officeDocument/2006/relationships" id="259" r:id="Rdb388a8745e743d3"/>
-    <p:sldId xmlns:r="http://schemas.openxmlformats.org/officeDocument/2006/relationships" id="260" r:id="Rc88424461bcd4fd8"/>
-    <p:sldId xmlns:r="http://schemas.openxmlformats.org/officeDocument/2006/relationships" id="261" r:id="R9521932465e64ff7"/>
-    <p:sldId xmlns:r="http://schemas.openxmlformats.org/officeDocument/2006/relationships" id="262" r:id="R5f743f1d36cc499c"/>
-    <p:sldId xmlns:r="http://schemas.openxmlformats.org/officeDocument/2006/relationships" id="263" r:id="R2a1630f04a4e4146"/>
-    <p:sldId xmlns:r="http://schemas.openxmlformats.org/officeDocument/2006/relationships" id="264" r:id="R86b2743495fc47f1"/>
-    <p:sldId xmlns:r="http://schemas.openxmlformats.org/officeDocument/2006/relationships" id="265" r:id="Rded2fa7403c54f3b"/>
+    <p:sldId xmlns:r="http://schemas.openxmlformats.org/officeDocument/2006/relationships" id="256" r:id="Rbc69b1e56fc94dd0"/>
+    <p:sldId xmlns:r="http://schemas.openxmlformats.org/officeDocument/2006/relationships" id="257" r:id="R302c97764ae348d7"/>
+    <p:sldId xmlns:r="http://schemas.openxmlformats.org/officeDocument/2006/relationships" id="258" r:id="Re59ee45d6c9e4b27"/>
+    <p:sldId xmlns:r="http://schemas.openxmlformats.org/officeDocument/2006/relationships" id="259" r:id="R7b441fe1be1e4390"/>
+    <p:sldId xmlns:r="http://schemas.openxmlformats.org/officeDocument/2006/relationships" id="260" r:id="Ref2923d9670249d9"/>
+    <p:sldId xmlns:r="http://schemas.openxmlformats.org/officeDocument/2006/relationships" id="261" r:id="R3a9867477fb4448b"/>
+    <p:sldId xmlns:r="http://schemas.openxmlformats.org/officeDocument/2006/relationships" id="262" r:id="R8ed9858676d84adf"/>
+    <p:sldId xmlns:r="http://schemas.openxmlformats.org/officeDocument/2006/relationships" id="263" r:id="R8a1d96b664dc4c87"/>
+    <p:sldId xmlns:r="http://schemas.openxmlformats.org/officeDocument/2006/relationships" id="264" r:id="R1816ac3fa5334347"/>
+    <p:sldId xmlns:r="http://schemas.openxmlformats.org/officeDocument/2006/relationships" id="265" r:id="R12bfdebaf57a43ff"/>
   </p:sldIdLst>
   <p:sldSz cx="18288000" cy="10287000"/>
   <p:notesSz cx="6858000" cy="9144000"/>
@@ -1198,7 +1198,7 @@
   </p:cSld>
   <p:clrMap bg1="lt1" tx1="dk1" bg2="lt2" tx2="dk2" accent1="accent1" accent2="accent2" accent3="accent3" accent4="accent4" accent5="accent5" accent6="accent6" hlink="hlink" folHlink="folHlink"/>
   <p:sldLayoutIdLst>
-    <p:sldLayoutId xmlns:r="http://schemas.openxmlformats.org/officeDocument/2006/relationships" id="2147483649" r:id="R958ea976fd2449c7"/>
+    <p:sldLayoutId xmlns:r="http://schemas.openxmlformats.org/officeDocument/2006/relationships" id="2147483649" r:id="R2e5dc1bfd2e9482c"/>
   </p:sldLayoutIdLst>
   <p:txStyles>
     <p:titleStyle>
@@ -1497,7 +1497,7 @@
           <p:cNvPr id="1" name="">
             <a:extLst xmlns:a="http://schemas.openxmlformats.org/drawingml/2006/main">
               <a:ext uri="{FF2B5EF4-FFF2-40B4-BE49-F238E27FC236}">
-                <a16:creationId xmlns:a16="http://schemas.microsoft.com/office/drawing/2014/main" id="{A83EA885-5D6C-4739-9C45-92CFD1AF4BBD}"/>
+                <a16:creationId xmlns:a16="http://schemas.microsoft.com/office/drawing/2014/main" id="{B2221315-07BC-438F-BC1E-F070D05DA43A}"/>
               </a:ext>
             </a:extLst>
           </p:cNvPr>
@@ -1524,7 +1524,7 @@
           <p:cNvPr id="2" name="">
             <a:extLst xmlns:a="http://schemas.openxmlformats.org/drawingml/2006/main">
               <a:ext uri="{FF2B5EF4-FFF2-40B4-BE49-F238E27FC236}">
-                <a16:creationId xmlns:a16="http://schemas.microsoft.com/office/drawing/2014/main" id="{388B8CAB-62D7-4F2F-8209-A7ECAEBAB763}"/>
+                <a16:creationId xmlns:a16="http://schemas.microsoft.com/office/drawing/2014/main" id="{61634B99-B8AF-4DFF-94F4-6221FF6B7368}"/>
               </a:ext>
             </a:extLst>
           </p:cNvPr>
@@ -1555,7 +1555,7 @@
           <p:cNvPr id="3" name="">
             <a:extLst xmlns:a="http://schemas.openxmlformats.org/drawingml/2006/main">
               <a:ext uri="{FF2B5EF4-FFF2-40B4-BE49-F238E27FC236}">
-                <a16:creationId xmlns:a16="http://schemas.microsoft.com/office/drawing/2014/main" id="{9622C56F-EE00-46C3-B4A0-8BD884A58136}"/>
+                <a16:creationId xmlns:a16="http://schemas.microsoft.com/office/drawing/2014/main" id="{15819CE6-74C2-472E-9F10-657B302DFD21}"/>
               </a:ext>
             </a:extLst>
           </p:cNvPr>
@@ -1600,7 +1600,7 @@
           <p:cNvPr id="4" name="">
             <a:extLst xmlns:a="http://schemas.openxmlformats.org/drawingml/2006/main">
               <a:ext uri="{FF2B5EF4-FFF2-40B4-BE49-F238E27FC236}">
-                <a16:creationId xmlns:a16="http://schemas.microsoft.com/office/drawing/2014/main" id="{A2B562E7-8B8F-482B-BA3D-E15C91A35CE4}"/>
+                <a16:creationId xmlns:a16="http://schemas.microsoft.com/office/drawing/2014/main" id="{DA4DA8FA-CB28-4346-8915-063F68682E2E}"/>
               </a:ext>
             </a:extLst>
           </p:cNvPr>
@@ -1631,7 +1631,7 @@
           <p:cNvPr id="5" name="">
             <a:extLst xmlns:a="http://schemas.openxmlformats.org/drawingml/2006/main">
               <a:ext uri="{FF2B5EF4-FFF2-40B4-BE49-F238E27FC236}">
-                <a16:creationId xmlns:a16="http://schemas.microsoft.com/office/drawing/2014/main" id="{DE2496EF-2149-47FB-A651-B2D08C332835}"/>
+                <a16:creationId xmlns:a16="http://schemas.microsoft.com/office/drawing/2014/main" id="{9FBFDEA7-BAA4-4F2D-89E0-C3B8FA7F57E9}"/>
               </a:ext>
             </a:extLst>
           </p:cNvPr>
@@ -1676,7 +1676,7 @@
           <p:cNvPr id="6" name="">
             <a:extLst xmlns:a="http://schemas.openxmlformats.org/drawingml/2006/main">
               <a:ext uri="{FF2B5EF4-FFF2-40B4-BE49-F238E27FC236}">
-                <a16:creationId xmlns:a16="http://schemas.microsoft.com/office/drawing/2014/main" id="{3F9E4D74-2594-48B3-BFC0-0A3AA471D2F8}"/>
+                <a16:creationId xmlns:a16="http://schemas.microsoft.com/office/drawing/2014/main" id="{3CABFB4A-0DFA-49FB-BFDF-E795A1A809CD}"/>
               </a:ext>
             </a:extLst>
           </p:cNvPr>
@@ -1721,7 +1721,7 @@
           <p:cNvPr id="7" name="">
             <a:extLst xmlns:a="http://schemas.openxmlformats.org/drawingml/2006/main">
               <a:ext uri="{FF2B5EF4-FFF2-40B4-BE49-F238E27FC236}">
-                <a16:creationId xmlns:a16="http://schemas.microsoft.com/office/drawing/2014/main" id="{D6036363-6F20-430C-B808-18A3BE3E87E6}"/>
+                <a16:creationId xmlns:a16="http://schemas.microsoft.com/office/drawing/2014/main" id="{2AFA500E-7E05-4FF8-8A05-374216000AF8}"/>
               </a:ext>
             </a:extLst>
           </p:cNvPr>
@@ -1766,7 +1766,7 @@
           <p:cNvPr id="8" name="">
             <a:extLst xmlns:a="http://schemas.openxmlformats.org/drawingml/2006/main">
               <a:ext uri="{FF2B5EF4-FFF2-40B4-BE49-F238E27FC236}">
-                <a16:creationId xmlns:a16="http://schemas.microsoft.com/office/drawing/2014/main" id="{1F4EED56-751D-41AC-8AB3-3FB23D97073B}"/>
+                <a16:creationId xmlns:a16="http://schemas.microsoft.com/office/drawing/2014/main" id="{886DB6E0-C870-47C4-8F3C-5AD776818F84}"/>
               </a:ext>
             </a:extLst>
           </p:cNvPr>
@@ -1799,7 +1799,7 @@
           <p:cNvPr id="9" name="">
             <a:extLst xmlns:a="http://schemas.openxmlformats.org/drawingml/2006/main">
               <a:ext uri="{FF2B5EF4-FFF2-40B4-BE49-F238E27FC236}">
-                <a16:creationId xmlns:a16="http://schemas.microsoft.com/office/drawing/2014/main" id="{D264CE59-B705-4644-989D-73C8BCE7966F}"/>
+                <a16:creationId xmlns:a16="http://schemas.microsoft.com/office/drawing/2014/main" id="{E58F5639-00B5-4E31-879E-879853E08D0F}"/>
               </a:ext>
             </a:extLst>
           </p:cNvPr>
@@ -1844,7 +1844,7 @@
           <p:cNvPr id="10" name="">
             <a:extLst xmlns:a="http://schemas.openxmlformats.org/drawingml/2006/main">
               <a:ext uri="{FF2B5EF4-FFF2-40B4-BE49-F238E27FC236}">
-                <a16:creationId xmlns:a16="http://schemas.microsoft.com/office/drawing/2014/main" id="{E0EF0D94-E540-42F6-81BF-A45980B0EB03}"/>
+                <a16:creationId xmlns:a16="http://schemas.microsoft.com/office/drawing/2014/main" id="{21D9B03F-D607-4663-85C6-318D5D5E007C}"/>
               </a:ext>
             </a:extLst>
           </p:cNvPr>
@@ -1873,7 +1873,7 @@
           <p:cNvPr id="11" name="">
             <a:extLst xmlns:a="http://schemas.openxmlformats.org/drawingml/2006/main">
               <a:ext uri="{FF2B5EF4-FFF2-40B4-BE49-F238E27FC236}">
-                <a16:creationId xmlns:a16="http://schemas.microsoft.com/office/drawing/2014/main" id="{E895ABB9-9BA7-4392-84C2-11040ABBF642}"/>
+                <a16:creationId xmlns:a16="http://schemas.microsoft.com/office/drawing/2014/main" id="{4D219F42-B308-4D9F-A8FE-193DFF634278}"/>
               </a:ext>
             </a:extLst>
           </p:cNvPr>
@@ -1902,7 +1902,7 @@
           <p:cNvPr id="12" name="">
             <a:extLst xmlns:a="http://schemas.openxmlformats.org/drawingml/2006/main">
               <a:ext uri="{FF2B5EF4-FFF2-40B4-BE49-F238E27FC236}">
-                <a16:creationId xmlns:a16="http://schemas.microsoft.com/office/drawing/2014/main" id="{698D4010-8F1D-42D5-ABAB-3728E2156641}"/>
+                <a16:creationId xmlns:a16="http://schemas.microsoft.com/office/drawing/2014/main" id="{7016F8F7-FFE2-4FCA-8D65-54238E765E09}"/>
               </a:ext>
             </a:extLst>
           </p:cNvPr>
@@ -1931,7 +1931,7 @@
           <p:cNvPr id="13" name="">
             <a:extLst xmlns:a="http://schemas.openxmlformats.org/drawingml/2006/main">
               <a:ext uri="{FF2B5EF4-FFF2-40B4-BE49-F238E27FC236}">
-                <a16:creationId xmlns:a16="http://schemas.microsoft.com/office/drawing/2014/main" id="{0BA6DB4F-6B4C-4BEF-9AD6-96547F4B2264}"/>
+                <a16:creationId xmlns:a16="http://schemas.microsoft.com/office/drawing/2014/main" id="{4F97DC05-8C50-4F93-9FFD-D02FDED8F7B4}"/>
               </a:ext>
             </a:extLst>
           </p:cNvPr>
@@ -1976,7 +1976,7 @@
           <p:cNvPr id="14" name="">
             <a:extLst xmlns:a="http://schemas.openxmlformats.org/drawingml/2006/main">
               <a:ext uri="{FF2B5EF4-FFF2-40B4-BE49-F238E27FC236}">
-                <a16:creationId xmlns:a16="http://schemas.microsoft.com/office/drawing/2014/main" id="{1247F9B0-1511-4011-8E4C-5C9BA823A240}"/>
+                <a16:creationId xmlns:a16="http://schemas.microsoft.com/office/drawing/2014/main" id="{F9E4C029-B674-4CB7-963D-AE443675FDBE}"/>
               </a:ext>
             </a:extLst>
           </p:cNvPr>
@@ -2021,7 +2021,7 @@
           <p:cNvPr id="15" name="">
             <a:extLst xmlns:a="http://schemas.openxmlformats.org/drawingml/2006/main">
               <a:ext uri="{FF2B5EF4-FFF2-40B4-BE49-F238E27FC236}">
-                <a16:creationId xmlns:a16="http://schemas.microsoft.com/office/drawing/2014/main" id="{61044152-09B4-4937-8FE8-17E4763F7A7A}"/>
+                <a16:creationId xmlns:a16="http://schemas.microsoft.com/office/drawing/2014/main" id="{7A1D6BD3-ADC5-441E-9EE2-50626493A722}"/>
               </a:ext>
             </a:extLst>
           </p:cNvPr>
@@ -2066,7 +2066,7 @@
           <p:cNvPr id="16" name="">
             <a:extLst xmlns:a="http://schemas.openxmlformats.org/drawingml/2006/main">
               <a:ext uri="{FF2B5EF4-FFF2-40B4-BE49-F238E27FC236}">
-                <a16:creationId xmlns:a16="http://schemas.microsoft.com/office/drawing/2014/main" id="{A1780129-C80A-4C66-A08F-EE6E7D448D4E}"/>
+                <a16:creationId xmlns:a16="http://schemas.microsoft.com/office/drawing/2014/main" id="{A51362E5-BCC7-4A64-8A2F-B56EDBCC8C65}"/>
               </a:ext>
             </a:extLst>
           </p:cNvPr>
@@ -2111,7 +2111,7 @@
           <p:cNvPr id="17" name="">
             <a:extLst xmlns:a="http://schemas.openxmlformats.org/drawingml/2006/main">
               <a:ext uri="{FF2B5EF4-FFF2-40B4-BE49-F238E27FC236}">
-                <a16:creationId xmlns:a16="http://schemas.microsoft.com/office/drawing/2014/main" id="{C3AF1D17-49BD-4BA4-93F2-EBF70EB49B5F}"/>
+                <a16:creationId xmlns:a16="http://schemas.microsoft.com/office/drawing/2014/main" id="{C748CF13-7F52-4C48-990D-9849BC487022}"/>
               </a:ext>
             </a:extLst>
           </p:cNvPr>
@@ -2154,7 +2154,7 @@
     </p:spTree>
     <p:extLst>
       <p:ext uri="{BB962C8B-B14F-4D97-AF65-F5344CB8AC3E}">
-        <p14:creationId xmlns:p14="http://schemas.microsoft.com/office/powerpoint/2010/main" val="942820640"/>
+        <p14:creationId xmlns:p14="http://schemas.microsoft.com/office/powerpoint/2010/main" val="540395823"/>
       </p:ext>
     </p:extLst>
   </p:cSld>
@@ -2178,7 +2178,7 @@
           <p:cNvPr id="1" name="bg">
             <a:extLst xmlns:a="http://schemas.openxmlformats.org/drawingml/2006/main">
               <a:ext uri="{FF2B5EF4-FFF2-40B4-BE49-F238E27FC236}">
-                <a16:creationId xmlns:a16="http://schemas.microsoft.com/office/drawing/2014/main" id="{761215DC-6CC4-4917-AD27-8AE34F224CFC}"/>
+                <a16:creationId xmlns:a16="http://schemas.microsoft.com/office/drawing/2014/main" id="{06A664D7-84E4-42D6-B75A-E2BCBCF4BFBC}"/>
               </a:ext>
             </a:extLst>
           </p:cNvPr>
@@ -2205,7 +2205,7 @@
           <p:cNvPr id="2" name="top-field">
             <a:extLst xmlns:a="http://schemas.openxmlformats.org/drawingml/2006/main">
               <a:ext uri="{FF2B5EF4-FFF2-40B4-BE49-F238E27FC236}">
-                <a16:creationId xmlns:a16="http://schemas.microsoft.com/office/drawing/2014/main" id="{021FB036-B50A-4574-A232-40BC79E68D6C}"/>
+                <a16:creationId xmlns:a16="http://schemas.microsoft.com/office/drawing/2014/main" id="{C04D28C2-3C40-4938-8201-173BEB86AB50}"/>
               </a:ext>
             </a:extLst>
           </p:cNvPr>
@@ -2232,7 +2232,7 @@
           <p:cNvPr id="3" name="">
             <a:extLst xmlns:a="http://schemas.openxmlformats.org/drawingml/2006/main">
               <a:ext uri="{FF2B5EF4-FFF2-40B4-BE49-F238E27FC236}">
-                <a16:creationId xmlns:a16="http://schemas.microsoft.com/office/drawing/2014/main" id="{63FC526C-7826-4D81-9965-C97D19A481AD}"/>
+                <a16:creationId xmlns:a16="http://schemas.microsoft.com/office/drawing/2014/main" id="{2D996707-40CD-4C19-9249-6720ADF4B499}"/>
               </a:ext>
             </a:extLst>
           </p:cNvPr>
@@ -2263,7 +2263,7 @@
           <p:cNvPr id="4" name="">
             <a:extLst xmlns:a="http://schemas.openxmlformats.org/drawingml/2006/main">
               <a:ext uri="{FF2B5EF4-FFF2-40B4-BE49-F238E27FC236}">
-                <a16:creationId xmlns:a16="http://schemas.microsoft.com/office/drawing/2014/main" id="{ECE61294-4600-4BBF-8280-4D6E557A6AEA}"/>
+                <a16:creationId xmlns:a16="http://schemas.microsoft.com/office/drawing/2014/main" id="{C3F2DF23-7FB3-4724-9B12-3E7B5BE1627D}"/>
               </a:ext>
             </a:extLst>
           </p:cNvPr>
@@ -2308,7 +2308,7 @@
           <p:cNvPr id="5" name="">
             <a:extLst xmlns:a="http://schemas.openxmlformats.org/drawingml/2006/main">
               <a:ext uri="{FF2B5EF4-FFF2-40B4-BE49-F238E27FC236}">
-                <a16:creationId xmlns:a16="http://schemas.microsoft.com/office/drawing/2014/main" id="{9D56060E-FF5A-47DD-B8F0-6BA4350F1AAC}"/>
+                <a16:creationId xmlns:a16="http://schemas.microsoft.com/office/drawing/2014/main" id="{857681FC-34E8-4DB5-BD33-68EF8AAF7891}"/>
               </a:ext>
             </a:extLst>
           </p:cNvPr>
@@ -2339,7 +2339,7 @@
           <p:cNvPr id="6" name="">
             <a:extLst xmlns:a="http://schemas.openxmlformats.org/drawingml/2006/main">
               <a:ext uri="{FF2B5EF4-FFF2-40B4-BE49-F238E27FC236}">
-                <a16:creationId xmlns:a16="http://schemas.microsoft.com/office/drawing/2014/main" id="{10348021-D059-4E8D-99EE-3F76F68F523A}"/>
+                <a16:creationId xmlns:a16="http://schemas.microsoft.com/office/drawing/2014/main" id="{7433CC0C-1E4F-45B5-B76B-F8CCD6CC8F91}"/>
               </a:ext>
             </a:extLst>
           </p:cNvPr>
@@ -2384,7 +2384,7 @@
           <p:cNvPr id="7" name="">
             <a:extLst xmlns:a="http://schemas.openxmlformats.org/drawingml/2006/main">
               <a:ext uri="{FF2B5EF4-FFF2-40B4-BE49-F238E27FC236}">
-                <a16:creationId xmlns:a16="http://schemas.microsoft.com/office/drawing/2014/main" id="{9913D8D6-FF24-40FF-B7E6-EB850ABE4A62}"/>
+                <a16:creationId xmlns:a16="http://schemas.microsoft.com/office/drawing/2014/main" id="{75C30ED0-2137-4DDE-99A2-B3ED5147732F}"/>
               </a:ext>
             </a:extLst>
           </p:cNvPr>
@@ -2429,7 +2429,7 @@
           <p:cNvPr id="8" name="">
             <a:extLst xmlns:a="http://schemas.openxmlformats.org/drawingml/2006/main">
               <a:ext uri="{FF2B5EF4-FFF2-40B4-BE49-F238E27FC236}">
-                <a16:creationId xmlns:a16="http://schemas.microsoft.com/office/drawing/2014/main" id="{9E5622B4-7277-426D-AD2F-BAB0621C4AC6}"/>
+                <a16:creationId xmlns:a16="http://schemas.microsoft.com/office/drawing/2014/main" id="{B1C13603-50FD-44D1-A417-A4B6514BBBC4}"/>
               </a:ext>
             </a:extLst>
           </p:cNvPr>
@@ -2474,7 +2474,7 @@
           <p:cNvPr id="9" name="">
             <a:extLst xmlns:a="http://schemas.openxmlformats.org/drawingml/2006/main">
               <a:ext uri="{FF2B5EF4-FFF2-40B4-BE49-F238E27FC236}">
-                <a16:creationId xmlns:a16="http://schemas.microsoft.com/office/drawing/2014/main" id="{BB82246E-5CD7-4A0F-84FE-1B74539CA9A1}"/>
+                <a16:creationId xmlns:a16="http://schemas.microsoft.com/office/drawing/2014/main" id="{09B076C6-80C9-42EB-B1D0-197FF3E6FAA3}"/>
               </a:ext>
             </a:extLst>
           </p:cNvPr>
@@ -2519,7 +2519,7 @@
           <p:cNvPr id="10" name="">
             <a:extLst xmlns:a="http://schemas.openxmlformats.org/drawingml/2006/main">
               <a:ext uri="{FF2B5EF4-FFF2-40B4-BE49-F238E27FC236}">
-                <a16:creationId xmlns:a16="http://schemas.microsoft.com/office/drawing/2014/main" id="{2599F849-1E71-4DD3-B9FA-99DF424EDEF1}"/>
+                <a16:creationId xmlns:a16="http://schemas.microsoft.com/office/drawing/2014/main" id="{F4D3720C-F0E0-47B8-9544-31881120609F}"/>
               </a:ext>
             </a:extLst>
           </p:cNvPr>
@@ -2564,7 +2564,7 @@
           <p:cNvPr id="11" name="">
             <a:extLst xmlns:a="http://schemas.openxmlformats.org/drawingml/2006/main">
               <a:ext uri="{FF2B5EF4-FFF2-40B4-BE49-F238E27FC236}">
-                <a16:creationId xmlns:a16="http://schemas.microsoft.com/office/drawing/2014/main" id="{BF07301F-FBEF-48F6-A61F-A2E8110068DB}"/>
+                <a16:creationId xmlns:a16="http://schemas.microsoft.com/office/drawing/2014/main" id="{841D37AE-374D-4F6D-A157-21901DA1301D}"/>
               </a:ext>
             </a:extLst>
           </p:cNvPr>
@@ -2609,7 +2609,7 @@
           <p:cNvPr id="12" name="">
             <a:extLst xmlns:a="http://schemas.openxmlformats.org/drawingml/2006/main">
               <a:ext uri="{FF2B5EF4-FFF2-40B4-BE49-F238E27FC236}">
-                <a16:creationId xmlns:a16="http://schemas.microsoft.com/office/drawing/2014/main" id="{ECB829A9-6965-4E2A-AE75-C00D3FB3BB36}"/>
+                <a16:creationId xmlns:a16="http://schemas.microsoft.com/office/drawing/2014/main" id="{86EB3541-F9C3-4A34-84B5-C8C70D2A8BAD}"/>
               </a:ext>
             </a:extLst>
           </p:cNvPr>
@@ -2654,7 +2654,7 @@
           <p:cNvPr id="13" name="">
             <a:extLst xmlns:a="http://schemas.openxmlformats.org/drawingml/2006/main">
               <a:ext uri="{FF2B5EF4-FFF2-40B4-BE49-F238E27FC236}">
-                <a16:creationId xmlns:a16="http://schemas.microsoft.com/office/drawing/2014/main" id="{4082F5A1-618C-44C7-A0E0-F1EEC7D1771F}"/>
+                <a16:creationId xmlns:a16="http://schemas.microsoft.com/office/drawing/2014/main" id="{2C96EBEB-F19E-449F-86E3-7D4CE9A0AD41}"/>
               </a:ext>
             </a:extLst>
           </p:cNvPr>
@@ -2685,7 +2685,7 @@
           <p:cNvPr id="14" name="">
             <a:extLst xmlns:a="http://schemas.openxmlformats.org/drawingml/2006/main">
               <a:ext uri="{FF2B5EF4-FFF2-40B4-BE49-F238E27FC236}">
-                <a16:creationId xmlns:a16="http://schemas.microsoft.com/office/drawing/2014/main" id="{72DFD5B4-9F0B-43B0-94EB-C95682EE3AA1}"/>
+                <a16:creationId xmlns:a16="http://schemas.microsoft.com/office/drawing/2014/main" id="{031A0CC5-9650-4D83-9EA6-C4379B37D21F}"/>
               </a:ext>
             </a:extLst>
           </p:cNvPr>
@@ -2730,7 +2730,7 @@
           <p:cNvPr id="15" name="">
             <a:extLst xmlns:a="http://schemas.openxmlformats.org/drawingml/2006/main">
               <a:ext uri="{FF2B5EF4-FFF2-40B4-BE49-F238E27FC236}">
-                <a16:creationId xmlns:a16="http://schemas.microsoft.com/office/drawing/2014/main" id="{FE78B705-A2BB-4F3C-AEF4-AF84CCDA8341}"/>
+                <a16:creationId xmlns:a16="http://schemas.microsoft.com/office/drawing/2014/main" id="{98E65D3C-8F29-48DD-A374-C267980595C8}"/>
               </a:ext>
             </a:extLst>
           </p:cNvPr>
@@ -2775,7 +2775,7 @@
           <p:cNvPr id="16" name="">
             <a:extLst xmlns:a="http://schemas.openxmlformats.org/drawingml/2006/main">
               <a:ext uri="{FF2B5EF4-FFF2-40B4-BE49-F238E27FC236}">
-                <a16:creationId xmlns:a16="http://schemas.microsoft.com/office/drawing/2014/main" id="{DD5A7ECC-57A3-4855-8C0A-242BD7CA4FD7}"/>
+                <a16:creationId xmlns:a16="http://schemas.microsoft.com/office/drawing/2014/main" id="{9A3D46F8-3632-4448-AAD9-6CE8882FF302}"/>
               </a:ext>
             </a:extLst>
           </p:cNvPr>
@@ -2820,7 +2820,7 @@
           <p:cNvPr id="17" name="">
             <a:extLst xmlns:a="http://schemas.openxmlformats.org/drawingml/2006/main">
               <a:ext uri="{FF2B5EF4-FFF2-40B4-BE49-F238E27FC236}">
-                <a16:creationId xmlns:a16="http://schemas.microsoft.com/office/drawing/2014/main" id="{EF2D8460-F923-4665-8DA3-E9820BCAB832}"/>
+                <a16:creationId xmlns:a16="http://schemas.microsoft.com/office/drawing/2014/main" id="{1F79D17F-33E2-415F-97E4-355F20814F97}"/>
               </a:ext>
             </a:extLst>
           </p:cNvPr>
@@ -2851,7 +2851,7 @@
           <p:cNvPr id="18" name="">
             <a:extLst xmlns:a="http://schemas.openxmlformats.org/drawingml/2006/main">
               <a:ext uri="{FF2B5EF4-FFF2-40B4-BE49-F238E27FC236}">
-                <a16:creationId xmlns:a16="http://schemas.microsoft.com/office/drawing/2014/main" id="{F40F0177-00E1-42ED-AC65-7581CD7D759F}"/>
+                <a16:creationId xmlns:a16="http://schemas.microsoft.com/office/drawing/2014/main" id="{569E4604-A6F4-4A19-81C9-528A946FD18A}"/>
               </a:ext>
             </a:extLst>
           </p:cNvPr>
@@ -2896,7 +2896,7 @@
           <p:cNvPr id="19" name="">
             <a:extLst xmlns:a="http://schemas.openxmlformats.org/drawingml/2006/main">
               <a:ext uri="{FF2B5EF4-FFF2-40B4-BE49-F238E27FC236}">
-                <a16:creationId xmlns:a16="http://schemas.microsoft.com/office/drawing/2014/main" id="{83B5030C-39AD-48DB-8B2D-272368367C82}"/>
+                <a16:creationId xmlns:a16="http://schemas.microsoft.com/office/drawing/2014/main" id="{DAA4D59C-6ED5-40C6-9AE9-814952B6A0CF}"/>
               </a:ext>
             </a:extLst>
           </p:cNvPr>
@@ -2941,7 +2941,7 @@
           <p:cNvPr id="20" name="">
             <a:extLst xmlns:a="http://schemas.openxmlformats.org/drawingml/2006/main">
               <a:ext uri="{FF2B5EF4-FFF2-40B4-BE49-F238E27FC236}">
-                <a16:creationId xmlns:a16="http://schemas.microsoft.com/office/drawing/2014/main" id="{3B88C080-A787-4B58-BB22-86EE119E2D01}"/>
+                <a16:creationId xmlns:a16="http://schemas.microsoft.com/office/drawing/2014/main" id="{D79E74A9-F67D-48C4-80CF-E5D506FD9B98}"/>
               </a:ext>
             </a:extLst>
           </p:cNvPr>
@@ -2986,7 +2986,7 @@
           <p:cNvPr id="21" name="">
             <a:extLst xmlns:a="http://schemas.openxmlformats.org/drawingml/2006/main">
               <a:ext uri="{FF2B5EF4-FFF2-40B4-BE49-F238E27FC236}">
-                <a16:creationId xmlns:a16="http://schemas.microsoft.com/office/drawing/2014/main" id="{196B6BDC-5C2F-4269-9B3A-115951C943A1}"/>
+                <a16:creationId xmlns:a16="http://schemas.microsoft.com/office/drawing/2014/main" id="{E022E255-5D50-4068-8A43-89B0C6CFA620}"/>
               </a:ext>
             </a:extLst>
           </p:cNvPr>
@@ -3017,7 +3017,7 @@
           <p:cNvPr id="22" name="">
             <a:extLst xmlns:a="http://schemas.openxmlformats.org/drawingml/2006/main">
               <a:ext uri="{FF2B5EF4-FFF2-40B4-BE49-F238E27FC236}">
-                <a16:creationId xmlns:a16="http://schemas.microsoft.com/office/drawing/2014/main" id="{3BBA2A3B-0849-45C2-93C4-EFF64FFA9C40}"/>
+                <a16:creationId xmlns:a16="http://schemas.microsoft.com/office/drawing/2014/main" id="{549F4A33-B30A-4FA8-A0A7-D77A5D1029D0}"/>
               </a:ext>
             </a:extLst>
           </p:cNvPr>
@@ -3062,7 +3062,7 @@
           <p:cNvPr id="23" name="">
             <a:extLst xmlns:a="http://schemas.openxmlformats.org/drawingml/2006/main">
               <a:ext uri="{FF2B5EF4-FFF2-40B4-BE49-F238E27FC236}">
-                <a16:creationId xmlns:a16="http://schemas.microsoft.com/office/drawing/2014/main" id="{07F3B47E-3E8E-493E-BDCD-7BDD54C115E2}"/>
+                <a16:creationId xmlns:a16="http://schemas.microsoft.com/office/drawing/2014/main" id="{B7C90A79-0795-4553-86DD-5FA02EC2EA0D}"/>
               </a:ext>
             </a:extLst>
           </p:cNvPr>
@@ -3107,7 +3107,7 @@
           <p:cNvPr id="24" name="">
             <a:extLst xmlns:a="http://schemas.openxmlformats.org/drawingml/2006/main">
               <a:ext uri="{FF2B5EF4-FFF2-40B4-BE49-F238E27FC236}">
-                <a16:creationId xmlns:a16="http://schemas.microsoft.com/office/drawing/2014/main" id="{741823A9-07ED-4C47-9919-FA6D27110806}"/>
+                <a16:creationId xmlns:a16="http://schemas.microsoft.com/office/drawing/2014/main" id="{A31B206B-7A7E-4283-B432-F5E1E4967C02}"/>
               </a:ext>
             </a:extLst>
           </p:cNvPr>
@@ -3152,7 +3152,7 @@
           <p:cNvPr id="25" name="">
             <a:extLst xmlns:a="http://schemas.openxmlformats.org/drawingml/2006/main">
               <a:ext uri="{FF2B5EF4-FFF2-40B4-BE49-F238E27FC236}">
-                <a16:creationId xmlns:a16="http://schemas.microsoft.com/office/drawing/2014/main" id="{4FD27579-C1C9-4699-AAFE-E67FEAF54F12}"/>
+                <a16:creationId xmlns:a16="http://schemas.microsoft.com/office/drawing/2014/main" id="{B5475CF5-086B-473A-9760-8AA7A8E6A795}"/>
               </a:ext>
             </a:extLst>
           </p:cNvPr>
@@ -3183,7 +3183,7 @@
           <p:cNvPr id="26" name="">
             <a:extLst xmlns:a="http://schemas.openxmlformats.org/drawingml/2006/main">
               <a:ext uri="{FF2B5EF4-FFF2-40B4-BE49-F238E27FC236}">
-                <a16:creationId xmlns:a16="http://schemas.microsoft.com/office/drawing/2014/main" id="{9D043DD9-96FE-4A95-B10A-79A47C72FE99}"/>
+                <a16:creationId xmlns:a16="http://schemas.microsoft.com/office/drawing/2014/main" id="{1B33244F-35B3-4AAF-B015-DF312AD924E1}"/>
               </a:ext>
             </a:extLst>
           </p:cNvPr>
@@ -3228,7 +3228,7 @@
           <p:cNvPr id="27" name="">
             <a:extLst xmlns:a="http://schemas.openxmlformats.org/drawingml/2006/main">
               <a:ext uri="{FF2B5EF4-FFF2-40B4-BE49-F238E27FC236}">
-                <a16:creationId xmlns:a16="http://schemas.microsoft.com/office/drawing/2014/main" id="{AF716553-FEDF-4505-920F-4BB5C0B4F63B}"/>
+                <a16:creationId xmlns:a16="http://schemas.microsoft.com/office/drawing/2014/main" id="{34603F4E-23FF-47DA-9101-9704A3284DC3}"/>
               </a:ext>
             </a:extLst>
           </p:cNvPr>
@@ -3273,7 +3273,7 @@
           <p:cNvPr id="28" name="">
             <a:extLst xmlns:a="http://schemas.openxmlformats.org/drawingml/2006/main">
               <a:ext uri="{FF2B5EF4-FFF2-40B4-BE49-F238E27FC236}">
-                <a16:creationId xmlns:a16="http://schemas.microsoft.com/office/drawing/2014/main" id="{699367FB-B5C5-46CA-8DC7-A937CE572FFD}"/>
+                <a16:creationId xmlns:a16="http://schemas.microsoft.com/office/drawing/2014/main" id="{A4836C31-BB98-48EF-99E6-ED636360073D}"/>
               </a:ext>
             </a:extLst>
           </p:cNvPr>
@@ -3318,7 +3318,7 @@
           <p:cNvPr id="29" name="">
             <a:extLst xmlns:a="http://schemas.openxmlformats.org/drawingml/2006/main">
               <a:ext uri="{FF2B5EF4-FFF2-40B4-BE49-F238E27FC236}">
-                <a16:creationId xmlns:a16="http://schemas.microsoft.com/office/drawing/2014/main" id="{8C937381-8AD4-4BC2-BA5D-029106CD302E}"/>
+                <a16:creationId xmlns:a16="http://schemas.microsoft.com/office/drawing/2014/main" id="{381F720A-000B-40A6-BC77-CE3F2B1A6A0D}"/>
               </a:ext>
             </a:extLst>
           </p:cNvPr>
@@ -3363,7 +3363,7 @@
           <p:cNvPr id="30" name="">
             <a:extLst xmlns:a="http://schemas.openxmlformats.org/drawingml/2006/main">
               <a:ext uri="{FF2B5EF4-FFF2-40B4-BE49-F238E27FC236}">
-                <a16:creationId xmlns:a16="http://schemas.microsoft.com/office/drawing/2014/main" id="{F104ED08-F5C8-4DF1-BE90-C1C32E3D492C}"/>
+                <a16:creationId xmlns:a16="http://schemas.microsoft.com/office/drawing/2014/main" id="{EB38F985-23A4-4672-872D-AEEFE1FD5CEB}"/>
               </a:ext>
             </a:extLst>
           </p:cNvPr>
@@ -3406,7 +3406,7 @@
     </p:spTree>
     <p:extLst>
       <p:ext uri="{BB962C8B-B14F-4D97-AF65-F5344CB8AC3E}">
-        <p14:creationId xmlns:p14="http://schemas.microsoft.com/office/powerpoint/2010/main" val="793186453"/>
+        <p14:creationId xmlns:p14="http://schemas.microsoft.com/office/powerpoint/2010/main" val="1476409956"/>
       </p:ext>
     </p:extLst>
   </p:cSld>
@@ -3430,7 +3430,7 @@
           <p:cNvPr id="1" name="bg">
             <a:extLst xmlns:a="http://schemas.openxmlformats.org/drawingml/2006/main">
               <a:ext uri="{FF2B5EF4-FFF2-40B4-BE49-F238E27FC236}">
-                <a16:creationId xmlns:a16="http://schemas.microsoft.com/office/drawing/2014/main" id="{793F51AE-1D81-4961-A7CB-6D4A92931993}"/>
+                <a16:creationId xmlns:a16="http://schemas.microsoft.com/office/drawing/2014/main" id="{5157C86D-2D88-4A43-A933-F8E9AC53EF33}"/>
               </a:ext>
             </a:extLst>
           </p:cNvPr>
@@ -3457,7 +3457,7 @@
           <p:cNvPr id="2" name="top-field">
             <a:extLst xmlns:a="http://schemas.openxmlformats.org/drawingml/2006/main">
               <a:ext uri="{FF2B5EF4-FFF2-40B4-BE49-F238E27FC236}">
-                <a16:creationId xmlns:a16="http://schemas.microsoft.com/office/drawing/2014/main" id="{18DC5F03-6F61-4C57-9D7C-F90347DD3254}"/>
+                <a16:creationId xmlns:a16="http://schemas.microsoft.com/office/drawing/2014/main" id="{1632E157-C69A-44AC-8993-8B448CB55BF1}"/>
               </a:ext>
             </a:extLst>
           </p:cNvPr>
@@ -3484,7 +3484,7 @@
           <p:cNvPr id="3" name="">
             <a:extLst xmlns:a="http://schemas.openxmlformats.org/drawingml/2006/main">
               <a:ext uri="{FF2B5EF4-FFF2-40B4-BE49-F238E27FC236}">
-                <a16:creationId xmlns:a16="http://schemas.microsoft.com/office/drawing/2014/main" id="{B3CC3246-4DDD-41EF-BF1A-0C3676C0958A}"/>
+                <a16:creationId xmlns:a16="http://schemas.microsoft.com/office/drawing/2014/main" id="{731F9BE8-21DB-48DA-8C41-9791B52684E0}"/>
               </a:ext>
             </a:extLst>
           </p:cNvPr>
@@ -3515,7 +3515,7 @@
           <p:cNvPr id="4" name="">
             <a:extLst xmlns:a="http://schemas.openxmlformats.org/drawingml/2006/main">
               <a:ext uri="{FF2B5EF4-FFF2-40B4-BE49-F238E27FC236}">
-                <a16:creationId xmlns:a16="http://schemas.microsoft.com/office/drawing/2014/main" id="{5D2DDA0E-FE72-4CAC-9252-94B0D8B922A7}"/>
+                <a16:creationId xmlns:a16="http://schemas.microsoft.com/office/drawing/2014/main" id="{80DAB6BE-13FC-4A7A-B771-AEA579778E13}"/>
               </a:ext>
             </a:extLst>
           </p:cNvPr>
@@ -3560,7 +3560,7 @@
           <p:cNvPr id="5" name="">
             <a:extLst xmlns:a="http://schemas.openxmlformats.org/drawingml/2006/main">
               <a:ext uri="{FF2B5EF4-FFF2-40B4-BE49-F238E27FC236}">
-                <a16:creationId xmlns:a16="http://schemas.microsoft.com/office/drawing/2014/main" id="{FC94A756-307C-491F-88FB-3ED36236F760}"/>
+                <a16:creationId xmlns:a16="http://schemas.microsoft.com/office/drawing/2014/main" id="{AB8D4DE9-3744-419C-9204-14D77D70BE86}"/>
               </a:ext>
             </a:extLst>
           </p:cNvPr>
@@ -3591,7 +3591,7 @@
           <p:cNvPr id="6" name="">
             <a:extLst xmlns:a="http://schemas.openxmlformats.org/drawingml/2006/main">
               <a:ext uri="{FF2B5EF4-FFF2-40B4-BE49-F238E27FC236}">
-                <a16:creationId xmlns:a16="http://schemas.microsoft.com/office/drawing/2014/main" id="{5CFAE7F5-1F68-47B9-B313-23E5EE3867A1}"/>
+                <a16:creationId xmlns:a16="http://schemas.microsoft.com/office/drawing/2014/main" id="{300E2B33-3D23-4513-8123-01CB07B084B0}"/>
               </a:ext>
             </a:extLst>
           </p:cNvPr>
@@ -3636,7 +3636,7 @@
           <p:cNvPr id="7" name="">
             <a:extLst xmlns:a="http://schemas.openxmlformats.org/drawingml/2006/main">
               <a:ext uri="{FF2B5EF4-FFF2-40B4-BE49-F238E27FC236}">
-                <a16:creationId xmlns:a16="http://schemas.microsoft.com/office/drawing/2014/main" id="{456DC4DA-4EEC-40C8-9411-1F7D742B9B28}"/>
+                <a16:creationId xmlns:a16="http://schemas.microsoft.com/office/drawing/2014/main" id="{3CE9CE54-D741-48D4-B508-E738F0905FDA}"/>
               </a:ext>
             </a:extLst>
           </p:cNvPr>
@@ -3681,7 +3681,7 @@
           <p:cNvPr id="8" name="">
             <a:extLst xmlns:a="http://schemas.openxmlformats.org/drawingml/2006/main">
               <a:ext uri="{FF2B5EF4-FFF2-40B4-BE49-F238E27FC236}">
-                <a16:creationId xmlns:a16="http://schemas.microsoft.com/office/drawing/2014/main" id="{97C369DF-ECE2-453B-86B4-6081672C9DD1}"/>
+                <a16:creationId xmlns:a16="http://schemas.microsoft.com/office/drawing/2014/main" id="{E667F3BB-53E1-4752-B336-78E9D971AF02}"/>
               </a:ext>
             </a:extLst>
           </p:cNvPr>
@@ -3726,7 +3726,7 @@
           <p:cNvPr id="9" name="">
             <a:extLst xmlns:a="http://schemas.openxmlformats.org/drawingml/2006/main">
               <a:ext uri="{FF2B5EF4-FFF2-40B4-BE49-F238E27FC236}">
-                <a16:creationId xmlns:a16="http://schemas.microsoft.com/office/drawing/2014/main" id="{60936DC1-37CF-41E0-9632-E34F3304EA6B}"/>
+                <a16:creationId xmlns:a16="http://schemas.microsoft.com/office/drawing/2014/main" id="{5A2A89DA-503A-4573-80C4-733A46BA145F}"/>
               </a:ext>
             </a:extLst>
           </p:cNvPr>
@@ -3771,7 +3771,7 @@
           <p:cNvPr id="10" name="">
             <a:extLst xmlns:a="http://schemas.openxmlformats.org/drawingml/2006/main">
               <a:ext uri="{FF2B5EF4-FFF2-40B4-BE49-F238E27FC236}">
-                <a16:creationId xmlns:a16="http://schemas.microsoft.com/office/drawing/2014/main" id="{4FE4D7D7-3733-43C0-BEC9-7E60BF84D148}"/>
+                <a16:creationId xmlns:a16="http://schemas.microsoft.com/office/drawing/2014/main" id="{041D97AA-A955-46AE-B985-65B5295CA5CF}"/>
               </a:ext>
             </a:extLst>
           </p:cNvPr>
@@ -3816,7 +3816,7 @@
           <p:cNvPr id="11" name="">
             <a:extLst xmlns:a="http://schemas.openxmlformats.org/drawingml/2006/main">
               <a:ext uri="{FF2B5EF4-FFF2-40B4-BE49-F238E27FC236}">
-                <a16:creationId xmlns:a16="http://schemas.microsoft.com/office/drawing/2014/main" id="{5D873DCE-4BA0-4914-B325-F931FCD61AEA}"/>
+                <a16:creationId xmlns:a16="http://schemas.microsoft.com/office/drawing/2014/main" id="{CCAD9A0B-F1E7-4547-9F0E-9032D3D8DDE6}"/>
               </a:ext>
             </a:extLst>
           </p:cNvPr>
@@ -3861,7 +3861,7 @@
           <p:cNvPr id="12" name="">
             <a:extLst xmlns:a="http://schemas.openxmlformats.org/drawingml/2006/main">
               <a:ext uri="{FF2B5EF4-FFF2-40B4-BE49-F238E27FC236}">
-                <a16:creationId xmlns:a16="http://schemas.microsoft.com/office/drawing/2014/main" id="{B59E5BE3-4739-4464-B9B0-558195813A68}"/>
+                <a16:creationId xmlns:a16="http://schemas.microsoft.com/office/drawing/2014/main" id="{BD5D2896-0C6C-433D-B4E4-9A4F0DA3C2AD}"/>
               </a:ext>
             </a:extLst>
           </p:cNvPr>
@@ -3894,7 +3894,7 @@
           <p:cNvPr id="13" name="">
             <a:extLst xmlns:a="http://schemas.openxmlformats.org/drawingml/2006/main">
               <a:ext uri="{FF2B5EF4-FFF2-40B4-BE49-F238E27FC236}">
-                <a16:creationId xmlns:a16="http://schemas.microsoft.com/office/drawing/2014/main" id="{10909134-2910-4145-B48B-27496D9D3AE3}"/>
+                <a16:creationId xmlns:a16="http://schemas.microsoft.com/office/drawing/2014/main" id="{4BD859F8-5E82-4009-9CB1-53035BDC69B6}"/>
               </a:ext>
             </a:extLst>
           </p:cNvPr>
@@ -3939,7 +3939,7 @@
           <p:cNvPr id="14" name="">
             <a:extLst xmlns:a="http://schemas.openxmlformats.org/drawingml/2006/main">
               <a:ext uri="{FF2B5EF4-FFF2-40B4-BE49-F238E27FC236}">
-                <a16:creationId xmlns:a16="http://schemas.microsoft.com/office/drawing/2014/main" id="{25EF1267-043D-4534-BDEB-400AADDD778F}"/>
+                <a16:creationId xmlns:a16="http://schemas.microsoft.com/office/drawing/2014/main" id="{7D4BE678-37F2-470A-8DCC-E7BCB2993F7C}"/>
               </a:ext>
             </a:extLst>
           </p:cNvPr>
@@ -3984,7 +3984,7 @@
           <p:cNvPr id="15" name="">
             <a:extLst xmlns:a="http://schemas.openxmlformats.org/drawingml/2006/main">
               <a:ext uri="{FF2B5EF4-FFF2-40B4-BE49-F238E27FC236}">
-                <a16:creationId xmlns:a16="http://schemas.microsoft.com/office/drawing/2014/main" id="{19F3189F-BEF4-4D83-8FDC-ABEDC8121851}"/>
+                <a16:creationId xmlns:a16="http://schemas.microsoft.com/office/drawing/2014/main" id="{5A37F034-C72D-4916-BAE4-9E2F0DF81B44}"/>
               </a:ext>
             </a:extLst>
           </p:cNvPr>
@@ -4029,7 +4029,7 @@
           <p:cNvPr id="16" name="">
             <a:extLst xmlns:a="http://schemas.openxmlformats.org/drawingml/2006/main">
               <a:ext uri="{FF2B5EF4-FFF2-40B4-BE49-F238E27FC236}">
-                <a16:creationId xmlns:a16="http://schemas.microsoft.com/office/drawing/2014/main" id="{C1B4CDBF-0157-4181-B1CB-9BCBB5EA8F8E}"/>
+                <a16:creationId xmlns:a16="http://schemas.microsoft.com/office/drawing/2014/main" id="{EA3AD25B-F463-410C-98AE-CA6F55D13CF5}"/>
               </a:ext>
             </a:extLst>
           </p:cNvPr>
@@ -4062,7 +4062,7 @@
           <p:cNvPr id="17" name="">
             <a:extLst xmlns:a="http://schemas.openxmlformats.org/drawingml/2006/main">
               <a:ext uri="{FF2B5EF4-FFF2-40B4-BE49-F238E27FC236}">
-                <a16:creationId xmlns:a16="http://schemas.microsoft.com/office/drawing/2014/main" id="{E7CE771A-4D26-451C-9A5D-9135C3C8FAE8}"/>
+                <a16:creationId xmlns:a16="http://schemas.microsoft.com/office/drawing/2014/main" id="{E8EF846C-521D-445C-93D3-EFDD0FA47529}"/>
               </a:ext>
             </a:extLst>
           </p:cNvPr>
@@ -4107,7 +4107,7 @@
           <p:cNvPr id="18" name="">
             <a:extLst xmlns:a="http://schemas.openxmlformats.org/drawingml/2006/main">
               <a:ext uri="{FF2B5EF4-FFF2-40B4-BE49-F238E27FC236}">
-                <a16:creationId xmlns:a16="http://schemas.microsoft.com/office/drawing/2014/main" id="{A549FD59-573A-4411-A508-B981607A3F9E}"/>
+                <a16:creationId xmlns:a16="http://schemas.microsoft.com/office/drawing/2014/main" id="{703BF0D7-A050-4405-8001-0D877AB6D384}"/>
               </a:ext>
             </a:extLst>
           </p:cNvPr>
@@ -4152,7 +4152,7 @@
           <p:cNvPr id="19" name="">
             <a:extLst xmlns:a="http://schemas.openxmlformats.org/drawingml/2006/main">
               <a:ext uri="{FF2B5EF4-FFF2-40B4-BE49-F238E27FC236}">
-                <a16:creationId xmlns:a16="http://schemas.microsoft.com/office/drawing/2014/main" id="{36F3C51D-0F91-4871-AB91-CA20F8761EB9}"/>
+                <a16:creationId xmlns:a16="http://schemas.microsoft.com/office/drawing/2014/main" id="{AD761ADF-AF63-4553-A053-4894F9B4BE5E}"/>
               </a:ext>
             </a:extLst>
           </p:cNvPr>
@@ -4197,7 +4197,7 @@
           <p:cNvPr id="20" name="">
             <a:extLst xmlns:a="http://schemas.openxmlformats.org/drawingml/2006/main">
               <a:ext uri="{FF2B5EF4-FFF2-40B4-BE49-F238E27FC236}">
-                <a16:creationId xmlns:a16="http://schemas.microsoft.com/office/drawing/2014/main" id="{75AB3699-A028-455E-A0AA-88D948BB0896}"/>
+                <a16:creationId xmlns:a16="http://schemas.microsoft.com/office/drawing/2014/main" id="{853A224E-1751-402E-B403-AE8699B5E78F}"/>
               </a:ext>
             </a:extLst>
           </p:cNvPr>
@@ -4230,7 +4230,7 @@
           <p:cNvPr id="21" name="">
             <a:extLst xmlns:a="http://schemas.openxmlformats.org/drawingml/2006/main">
               <a:ext uri="{FF2B5EF4-FFF2-40B4-BE49-F238E27FC236}">
-                <a16:creationId xmlns:a16="http://schemas.microsoft.com/office/drawing/2014/main" id="{45F7B94B-5B50-43AD-89E2-B28ECB436EDC}"/>
+                <a16:creationId xmlns:a16="http://schemas.microsoft.com/office/drawing/2014/main" id="{D5A3D7FD-B1BC-41AE-97B3-30BB15F6C18C}"/>
               </a:ext>
             </a:extLst>
           </p:cNvPr>
@@ -4275,7 +4275,7 @@
           <p:cNvPr id="22" name="">
             <a:extLst xmlns:a="http://schemas.openxmlformats.org/drawingml/2006/main">
               <a:ext uri="{FF2B5EF4-FFF2-40B4-BE49-F238E27FC236}">
-                <a16:creationId xmlns:a16="http://schemas.microsoft.com/office/drawing/2014/main" id="{0F08B19C-4E62-4444-8B32-DD1D31AAD236}"/>
+                <a16:creationId xmlns:a16="http://schemas.microsoft.com/office/drawing/2014/main" id="{5CB0AA12-14FC-4825-9B77-6F79A946E37B}"/>
               </a:ext>
             </a:extLst>
           </p:cNvPr>
@@ -4320,7 +4320,7 @@
           <p:cNvPr id="23" name="">
             <a:extLst xmlns:a="http://schemas.openxmlformats.org/drawingml/2006/main">
               <a:ext uri="{FF2B5EF4-FFF2-40B4-BE49-F238E27FC236}">
-                <a16:creationId xmlns:a16="http://schemas.microsoft.com/office/drawing/2014/main" id="{953AD14E-13A5-4A38-BB1C-C80D4A1B87BD}"/>
+                <a16:creationId xmlns:a16="http://schemas.microsoft.com/office/drawing/2014/main" id="{6FDA8D68-77AB-46F4-8116-55F311DAD767}"/>
               </a:ext>
             </a:extLst>
           </p:cNvPr>
@@ -4363,7 +4363,7 @@
     </p:spTree>
     <p:extLst>
       <p:ext uri="{BB962C8B-B14F-4D97-AF65-F5344CB8AC3E}">
-        <p14:creationId xmlns:p14="http://schemas.microsoft.com/office/powerpoint/2010/main" val="307532857"/>
+        <p14:creationId xmlns:p14="http://schemas.microsoft.com/office/powerpoint/2010/main" val="2118045994"/>
       </p:ext>
     </p:extLst>
   </p:cSld>
@@ -4387,7 +4387,7 @@
           <p:cNvPr id="1" name="bg">
             <a:extLst xmlns:a="http://schemas.openxmlformats.org/drawingml/2006/main">
               <a:ext uri="{FF2B5EF4-FFF2-40B4-BE49-F238E27FC236}">
-                <a16:creationId xmlns:a16="http://schemas.microsoft.com/office/drawing/2014/main" id="{562DB7FA-5BED-4414-9798-A93B3268F206}"/>
+                <a16:creationId xmlns:a16="http://schemas.microsoft.com/office/drawing/2014/main" id="{B9090BCE-3036-46C3-9EA1-C86B292997B9}"/>
               </a:ext>
             </a:extLst>
           </p:cNvPr>
@@ -4414,7 +4414,7 @@
           <p:cNvPr id="2" name="top-field">
             <a:extLst xmlns:a="http://schemas.openxmlformats.org/drawingml/2006/main">
               <a:ext uri="{FF2B5EF4-FFF2-40B4-BE49-F238E27FC236}">
-                <a16:creationId xmlns:a16="http://schemas.microsoft.com/office/drawing/2014/main" id="{18DA80B2-6571-41E4-86FF-A366BDFD1942}"/>
+                <a16:creationId xmlns:a16="http://schemas.microsoft.com/office/drawing/2014/main" id="{C7180D98-8119-47BA-A6CC-237619D5E654}"/>
               </a:ext>
             </a:extLst>
           </p:cNvPr>
@@ -4441,7 +4441,7 @@
           <p:cNvPr id="3" name="">
             <a:extLst xmlns:a="http://schemas.openxmlformats.org/drawingml/2006/main">
               <a:ext uri="{FF2B5EF4-FFF2-40B4-BE49-F238E27FC236}">
-                <a16:creationId xmlns:a16="http://schemas.microsoft.com/office/drawing/2014/main" id="{053CD620-940A-417D-BFE7-EDCE0C1DBE75}"/>
+                <a16:creationId xmlns:a16="http://schemas.microsoft.com/office/drawing/2014/main" id="{DA0DEE5F-61BA-46C0-942A-BD4F8CF1F8BF}"/>
               </a:ext>
             </a:extLst>
           </p:cNvPr>
@@ -4472,7 +4472,7 @@
           <p:cNvPr id="4" name="">
             <a:extLst xmlns:a="http://schemas.openxmlformats.org/drawingml/2006/main">
               <a:ext uri="{FF2B5EF4-FFF2-40B4-BE49-F238E27FC236}">
-                <a16:creationId xmlns:a16="http://schemas.microsoft.com/office/drawing/2014/main" id="{23541581-BD75-42E4-97F5-F0A22ED8F486}"/>
+                <a16:creationId xmlns:a16="http://schemas.microsoft.com/office/drawing/2014/main" id="{9523D0F5-5327-4F84-A502-9433FCD0FBA3}"/>
               </a:ext>
             </a:extLst>
           </p:cNvPr>
@@ -4517,7 +4517,7 @@
           <p:cNvPr id="5" name="">
             <a:extLst xmlns:a="http://schemas.openxmlformats.org/drawingml/2006/main">
               <a:ext uri="{FF2B5EF4-FFF2-40B4-BE49-F238E27FC236}">
-                <a16:creationId xmlns:a16="http://schemas.microsoft.com/office/drawing/2014/main" id="{B6D78B2D-66E4-4F67-A382-8E1241EE1DC6}"/>
+                <a16:creationId xmlns:a16="http://schemas.microsoft.com/office/drawing/2014/main" id="{0017A082-757C-4BE1-86F4-6BD9D767108D}"/>
               </a:ext>
             </a:extLst>
           </p:cNvPr>
@@ -4548,7 +4548,7 @@
           <p:cNvPr id="6" name="">
             <a:extLst xmlns:a="http://schemas.openxmlformats.org/drawingml/2006/main">
               <a:ext uri="{FF2B5EF4-FFF2-40B4-BE49-F238E27FC236}">
-                <a16:creationId xmlns:a16="http://schemas.microsoft.com/office/drawing/2014/main" id="{B710AC84-DF2F-43DF-B2A2-11F9AD6FDACE}"/>
+                <a16:creationId xmlns:a16="http://schemas.microsoft.com/office/drawing/2014/main" id="{11A7CED8-0EF9-4818-98A2-13F39153B4AC}"/>
               </a:ext>
             </a:extLst>
           </p:cNvPr>
@@ -4593,7 +4593,7 @@
           <p:cNvPr id="7" name="">
             <a:extLst xmlns:a="http://schemas.openxmlformats.org/drawingml/2006/main">
               <a:ext uri="{FF2B5EF4-FFF2-40B4-BE49-F238E27FC236}">
-                <a16:creationId xmlns:a16="http://schemas.microsoft.com/office/drawing/2014/main" id="{70CC2EEE-415C-4EB3-90C0-AA6881FF2170}"/>
+                <a16:creationId xmlns:a16="http://schemas.microsoft.com/office/drawing/2014/main" id="{6CD7AF17-E578-4160-95B3-95F0CB4F833D}"/>
               </a:ext>
             </a:extLst>
           </p:cNvPr>
@@ -4638,7 +4638,7 @@
           <p:cNvPr id="8" name="">
             <a:extLst xmlns:a="http://schemas.openxmlformats.org/drawingml/2006/main">
               <a:ext uri="{FF2B5EF4-FFF2-40B4-BE49-F238E27FC236}">
-                <a16:creationId xmlns:a16="http://schemas.microsoft.com/office/drawing/2014/main" id="{96B4C7D3-AAC7-4356-A449-A01FA2BD1B40}"/>
+                <a16:creationId xmlns:a16="http://schemas.microsoft.com/office/drawing/2014/main" id="{E14671FB-16EA-4854-9470-B46052760318}"/>
               </a:ext>
             </a:extLst>
           </p:cNvPr>
@@ -4683,7 +4683,7 @@
           <p:cNvPr id="9" name="">
             <a:extLst xmlns:a="http://schemas.openxmlformats.org/drawingml/2006/main">
               <a:ext uri="{FF2B5EF4-FFF2-40B4-BE49-F238E27FC236}">
-                <a16:creationId xmlns:a16="http://schemas.microsoft.com/office/drawing/2014/main" id="{0255FD55-E504-448F-8116-2C54DB855E0B}"/>
+                <a16:creationId xmlns:a16="http://schemas.microsoft.com/office/drawing/2014/main" id="{543D920C-0174-4AA3-9C5A-FAE2F5DBB45D}"/>
               </a:ext>
             </a:extLst>
           </p:cNvPr>
@@ -4728,7 +4728,7 @@
           <p:cNvPr id="10" name="">
             <a:extLst xmlns:a="http://schemas.openxmlformats.org/drawingml/2006/main">
               <a:ext uri="{FF2B5EF4-FFF2-40B4-BE49-F238E27FC236}">
-                <a16:creationId xmlns:a16="http://schemas.microsoft.com/office/drawing/2014/main" id="{446FBCB1-F208-4378-9194-5D30824B4F8F}"/>
+                <a16:creationId xmlns:a16="http://schemas.microsoft.com/office/drawing/2014/main" id="{AF6C21B7-BA50-4C99-962E-786222E30164}"/>
               </a:ext>
             </a:extLst>
           </p:cNvPr>
@@ -4773,7 +4773,7 @@
           <p:cNvPr id="11" name="">
             <a:extLst xmlns:a="http://schemas.openxmlformats.org/drawingml/2006/main">
               <a:ext uri="{FF2B5EF4-FFF2-40B4-BE49-F238E27FC236}">
-                <a16:creationId xmlns:a16="http://schemas.microsoft.com/office/drawing/2014/main" id="{0A284033-2A64-4CB4-8678-E1BF54DDE70E}"/>
+                <a16:creationId xmlns:a16="http://schemas.microsoft.com/office/drawing/2014/main" id="{B0209A40-D8C6-40AE-BE83-A60F62DA8DCF}"/>
               </a:ext>
             </a:extLst>
           </p:cNvPr>
@@ -4818,7 +4818,7 @@
           <p:cNvPr id="12" name="">
             <a:extLst xmlns:a="http://schemas.openxmlformats.org/drawingml/2006/main">
               <a:ext uri="{FF2B5EF4-FFF2-40B4-BE49-F238E27FC236}">
-                <a16:creationId xmlns:a16="http://schemas.microsoft.com/office/drawing/2014/main" id="{0BFA8412-6272-4925-9F78-B653AB788070}"/>
+                <a16:creationId xmlns:a16="http://schemas.microsoft.com/office/drawing/2014/main" id="{4097E298-BDCC-4FDC-A2EE-8FBE4AED7B69}"/>
               </a:ext>
             </a:extLst>
           </p:cNvPr>
@@ -4863,7 +4863,7 @@
           <p:cNvPr id="13" name="">
             <a:extLst xmlns:a="http://schemas.openxmlformats.org/drawingml/2006/main">
               <a:ext uri="{FF2B5EF4-FFF2-40B4-BE49-F238E27FC236}">
-                <a16:creationId xmlns:a16="http://schemas.microsoft.com/office/drawing/2014/main" id="{6420DC41-4E11-4BAB-9FE0-C68886CEC770}"/>
+                <a16:creationId xmlns:a16="http://schemas.microsoft.com/office/drawing/2014/main" id="{9F4E35C6-8ACC-4477-9596-0AB54D787EBA}"/>
               </a:ext>
             </a:extLst>
           </p:cNvPr>
@@ -4896,7 +4896,7 @@
           <p:cNvPr id="14" name="">
             <a:extLst xmlns:a="http://schemas.openxmlformats.org/drawingml/2006/main">
               <a:ext uri="{FF2B5EF4-FFF2-40B4-BE49-F238E27FC236}">
-                <a16:creationId xmlns:a16="http://schemas.microsoft.com/office/drawing/2014/main" id="{70C36C50-2DD8-47DB-AF5D-F7F3FCB101E0}"/>
+                <a16:creationId xmlns:a16="http://schemas.microsoft.com/office/drawing/2014/main" id="{9D0BC51E-0CB0-45CB-89B8-77AD7B9A8BA2}"/>
               </a:ext>
             </a:extLst>
           </p:cNvPr>
@@ -4941,7 +4941,7 @@
           <p:cNvPr id="15" name="">
             <a:extLst xmlns:a="http://schemas.openxmlformats.org/drawingml/2006/main">
               <a:ext uri="{FF2B5EF4-FFF2-40B4-BE49-F238E27FC236}">
-                <a16:creationId xmlns:a16="http://schemas.microsoft.com/office/drawing/2014/main" id="{F2BB5B86-2C6B-46FD-9D00-9749CF01A4A0}"/>
+                <a16:creationId xmlns:a16="http://schemas.microsoft.com/office/drawing/2014/main" id="{598F6088-EF76-453A-A2BA-ADBD85187367}"/>
               </a:ext>
             </a:extLst>
           </p:cNvPr>
@@ -4986,7 +4986,7 @@
           <p:cNvPr id="16" name="">
             <a:extLst xmlns:a="http://schemas.openxmlformats.org/drawingml/2006/main">
               <a:ext uri="{FF2B5EF4-FFF2-40B4-BE49-F238E27FC236}">
-                <a16:creationId xmlns:a16="http://schemas.microsoft.com/office/drawing/2014/main" id="{82256414-A36E-4620-913A-91C4C18C035F}"/>
+                <a16:creationId xmlns:a16="http://schemas.microsoft.com/office/drawing/2014/main" id="{D904B757-805E-45C5-8780-070BFE62D3E0}"/>
               </a:ext>
             </a:extLst>
           </p:cNvPr>
@@ -5019,7 +5019,7 @@
           <p:cNvPr id="17" name="">
             <a:extLst xmlns:a="http://schemas.openxmlformats.org/drawingml/2006/main">
               <a:ext uri="{FF2B5EF4-FFF2-40B4-BE49-F238E27FC236}">
-                <a16:creationId xmlns:a16="http://schemas.microsoft.com/office/drawing/2014/main" id="{243FC941-8D71-458D-A4EF-2914445FFE4F}"/>
+                <a16:creationId xmlns:a16="http://schemas.microsoft.com/office/drawing/2014/main" id="{10EFA43B-E607-4813-9C5D-D94C0E91B196}"/>
               </a:ext>
             </a:extLst>
           </p:cNvPr>
@@ -5064,7 +5064,7 @@
           <p:cNvPr id="18" name="">
             <a:extLst xmlns:a="http://schemas.openxmlformats.org/drawingml/2006/main">
               <a:ext uri="{FF2B5EF4-FFF2-40B4-BE49-F238E27FC236}">
-                <a16:creationId xmlns:a16="http://schemas.microsoft.com/office/drawing/2014/main" id="{507AB482-C776-4C41-B148-3F74D1BED2F3}"/>
+                <a16:creationId xmlns:a16="http://schemas.microsoft.com/office/drawing/2014/main" id="{07D2504C-1FA5-4F20-B8D6-524B05DCF029}"/>
               </a:ext>
             </a:extLst>
           </p:cNvPr>
@@ -5109,7 +5109,7 @@
           <p:cNvPr id="19" name="">
             <a:extLst xmlns:a="http://schemas.openxmlformats.org/drawingml/2006/main">
               <a:ext uri="{FF2B5EF4-FFF2-40B4-BE49-F238E27FC236}">
-                <a16:creationId xmlns:a16="http://schemas.microsoft.com/office/drawing/2014/main" id="{845FF35A-F0BC-4AD9-A926-C0F409D8A8C5}"/>
+                <a16:creationId xmlns:a16="http://schemas.microsoft.com/office/drawing/2014/main" id="{CF3093D9-5FF1-481E-BE5E-5543F1DF8B99}"/>
               </a:ext>
             </a:extLst>
           </p:cNvPr>
@@ -5142,7 +5142,7 @@
           <p:cNvPr id="20" name="">
             <a:extLst xmlns:a="http://schemas.openxmlformats.org/drawingml/2006/main">
               <a:ext uri="{FF2B5EF4-FFF2-40B4-BE49-F238E27FC236}">
-                <a16:creationId xmlns:a16="http://schemas.microsoft.com/office/drawing/2014/main" id="{4234DF1E-968F-4EC3-A1AD-379CD2EF9F94}"/>
+                <a16:creationId xmlns:a16="http://schemas.microsoft.com/office/drawing/2014/main" id="{E5F4577E-73F6-42B9-9BF7-9161B3D6991B}"/>
               </a:ext>
             </a:extLst>
           </p:cNvPr>
@@ -5187,7 +5187,7 @@
           <p:cNvPr id="21" name="">
             <a:extLst xmlns:a="http://schemas.openxmlformats.org/drawingml/2006/main">
               <a:ext uri="{FF2B5EF4-FFF2-40B4-BE49-F238E27FC236}">
-                <a16:creationId xmlns:a16="http://schemas.microsoft.com/office/drawing/2014/main" id="{74BE0BCE-2A4E-414B-8512-4BE6FAA861C6}"/>
+                <a16:creationId xmlns:a16="http://schemas.microsoft.com/office/drawing/2014/main" id="{2DC47134-7968-4FFE-88BC-D2F43F546B19}"/>
               </a:ext>
             </a:extLst>
           </p:cNvPr>
@@ -5232,7 +5232,7 @@
           <p:cNvPr id="22" name="">
             <a:extLst xmlns:a="http://schemas.openxmlformats.org/drawingml/2006/main">
               <a:ext uri="{FF2B5EF4-FFF2-40B4-BE49-F238E27FC236}">
-                <a16:creationId xmlns:a16="http://schemas.microsoft.com/office/drawing/2014/main" id="{7B120329-4248-4D05-830B-BC2A7A8A5179}"/>
+                <a16:creationId xmlns:a16="http://schemas.microsoft.com/office/drawing/2014/main" id="{CCC58F0C-50F5-4925-BDEB-7E665CE423BE}"/>
               </a:ext>
             </a:extLst>
           </p:cNvPr>
@@ -5265,7 +5265,7 @@
           <p:cNvPr id="23" name="">
             <a:extLst xmlns:a="http://schemas.openxmlformats.org/drawingml/2006/main">
               <a:ext uri="{FF2B5EF4-FFF2-40B4-BE49-F238E27FC236}">
-                <a16:creationId xmlns:a16="http://schemas.microsoft.com/office/drawing/2014/main" id="{05E44661-3B6C-4CB0-B2B5-F9FDEB4A90A5}"/>
+                <a16:creationId xmlns:a16="http://schemas.microsoft.com/office/drawing/2014/main" id="{CCB4E19E-0F40-45F1-84DD-F072D4C89B46}"/>
               </a:ext>
             </a:extLst>
           </p:cNvPr>
@@ -5310,7 +5310,7 @@
           <p:cNvPr id="24" name="">
             <a:extLst xmlns:a="http://schemas.openxmlformats.org/drawingml/2006/main">
               <a:ext uri="{FF2B5EF4-FFF2-40B4-BE49-F238E27FC236}">
-                <a16:creationId xmlns:a16="http://schemas.microsoft.com/office/drawing/2014/main" id="{596AAABE-E75A-43C7-BA78-0F5ABA2B25B3}"/>
+                <a16:creationId xmlns:a16="http://schemas.microsoft.com/office/drawing/2014/main" id="{E491E0D6-8F9C-4A7D-B8BB-F1979C40078A}"/>
               </a:ext>
             </a:extLst>
           </p:cNvPr>
@@ -5355,7 +5355,7 @@
           <p:cNvPr id="25" name="">
             <a:extLst xmlns:a="http://schemas.openxmlformats.org/drawingml/2006/main">
               <a:ext uri="{FF2B5EF4-FFF2-40B4-BE49-F238E27FC236}">
-                <a16:creationId xmlns:a16="http://schemas.microsoft.com/office/drawing/2014/main" id="{6E9DE98C-8D4D-4274-B71E-37E609B20F2D}"/>
+                <a16:creationId xmlns:a16="http://schemas.microsoft.com/office/drawing/2014/main" id="{F24AFDF5-0BB6-46B7-8200-75269215B846}"/>
               </a:ext>
             </a:extLst>
           </p:cNvPr>
@@ -5388,7 +5388,7 @@
           <p:cNvPr id="26" name="">
             <a:extLst xmlns:a="http://schemas.openxmlformats.org/drawingml/2006/main">
               <a:ext uri="{FF2B5EF4-FFF2-40B4-BE49-F238E27FC236}">
-                <a16:creationId xmlns:a16="http://schemas.microsoft.com/office/drawing/2014/main" id="{DC4A0900-3CAF-4011-A05A-FF7B5830A457}"/>
+                <a16:creationId xmlns:a16="http://schemas.microsoft.com/office/drawing/2014/main" id="{0A03127C-5277-4189-A6E1-CE208F924FA5}"/>
               </a:ext>
             </a:extLst>
           </p:cNvPr>
@@ -5433,7 +5433,7 @@
           <p:cNvPr id="27" name="">
             <a:extLst xmlns:a="http://schemas.openxmlformats.org/drawingml/2006/main">
               <a:ext uri="{FF2B5EF4-FFF2-40B4-BE49-F238E27FC236}">
-                <a16:creationId xmlns:a16="http://schemas.microsoft.com/office/drawing/2014/main" id="{9EEE70F3-0A7A-4C24-957A-4AB1EEAAAB0D}"/>
+                <a16:creationId xmlns:a16="http://schemas.microsoft.com/office/drawing/2014/main" id="{350F6EE5-5F9E-41E0-9ED6-911759A71F8A}"/>
               </a:ext>
             </a:extLst>
           </p:cNvPr>
@@ -5478,7 +5478,7 @@
           <p:cNvPr id="28" name="">
             <a:extLst xmlns:a="http://schemas.openxmlformats.org/drawingml/2006/main">
               <a:ext uri="{FF2B5EF4-FFF2-40B4-BE49-F238E27FC236}">
-                <a16:creationId xmlns:a16="http://schemas.microsoft.com/office/drawing/2014/main" id="{2272455A-4A51-456B-ABA4-19DCDE527EE8}"/>
+                <a16:creationId xmlns:a16="http://schemas.microsoft.com/office/drawing/2014/main" id="{E2408FF2-B575-4583-B83B-D78EBB603C9A}"/>
               </a:ext>
             </a:extLst>
           </p:cNvPr>
@@ -5511,7 +5511,7 @@
           <p:cNvPr id="29" name="">
             <a:extLst xmlns:a="http://schemas.openxmlformats.org/drawingml/2006/main">
               <a:ext uri="{FF2B5EF4-FFF2-40B4-BE49-F238E27FC236}">
-                <a16:creationId xmlns:a16="http://schemas.microsoft.com/office/drawing/2014/main" id="{11C4AB9E-63EE-4818-B388-1662A23FB161}"/>
+                <a16:creationId xmlns:a16="http://schemas.microsoft.com/office/drawing/2014/main" id="{BB471442-E88A-49C2-9526-E1C50879E1F0}"/>
               </a:ext>
             </a:extLst>
           </p:cNvPr>
@@ -5556,7 +5556,7 @@
           <p:cNvPr id="30" name="">
             <a:extLst xmlns:a="http://schemas.openxmlformats.org/drawingml/2006/main">
               <a:ext uri="{FF2B5EF4-FFF2-40B4-BE49-F238E27FC236}">
-                <a16:creationId xmlns:a16="http://schemas.microsoft.com/office/drawing/2014/main" id="{B526AA62-327C-4A7F-9EF6-CC788E9710CA}"/>
+                <a16:creationId xmlns:a16="http://schemas.microsoft.com/office/drawing/2014/main" id="{8B382F8C-3815-4B4A-9436-401C41831D5E}"/>
               </a:ext>
             </a:extLst>
           </p:cNvPr>
@@ -5601,7 +5601,7 @@
           <p:cNvPr id="31" name="">
             <a:extLst xmlns:a="http://schemas.openxmlformats.org/drawingml/2006/main">
               <a:ext uri="{FF2B5EF4-FFF2-40B4-BE49-F238E27FC236}">
-                <a16:creationId xmlns:a16="http://schemas.microsoft.com/office/drawing/2014/main" id="{885800C7-6E94-48C6-A708-1D5E04AC557F}"/>
+                <a16:creationId xmlns:a16="http://schemas.microsoft.com/office/drawing/2014/main" id="{B9FE059C-8D0C-4C3C-8F8D-80998E94BD44}"/>
               </a:ext>
             </a:extLst>
           </p:cNvPr>
@@ -5634,7 +5634,7 @@
           <p:cNvPr id="32" name="">
             <a:extLst xmlns:a="http://schemas.openxmlformats.org/drawingml/2006/main">
               <a:ext uri="{FF2B5EF4-FFF2-40B4-BE49-F238E27FC236}">
-                <a16:creationId xmlns:a16="http://schemas.microsoft.com/office/drawing/2014/main" id="{ECA772D5-8470-4EA4-86BC-BFE07341A1F1}"/>
+                <a16:creationId xmlns:a16="http://schemas.microsoft.com/office/drawing/2014/main" id="{EB2E8B1F-9EAD-4FD3-A3AF-445D8E7EF461}"/>
               </a:ext>
             </a:extLst>
           </p:cNvPr>
@@ -5679,7 +5679,7 @@
           <p:cNvPr id="33" name="">
             <a:extLst xmlns:a="http://schemas.openxmlformats.org/drawingml/2006/main">
               <a:ext uri="{FF2B5EF4-FFF2-40B4-BE49-F238E27FC236}">
-                <a16:creationId xmlns:a16="http://schemas.microsoft.com/office/drawing/2014/main" id="{5FAE2147-134A-491B-95DB-BB8EC3300FAC}"/>
+                <a16:creationId xmlns:a16="http://schemas.microsoft.com/office/drawing/2014/main" id="{EBFD99DC-468E-4CB8-A226-25BF636D2829}"/>
               </a:ext>
             </a:extLst>
           </p:cNvPr>
@@ -5724,7 +5724,7 @@
           <p:cNvPr id="34" name="">
             <a:extLst xmlns:a="http://schemas.openxmlformats.org/drawingml/2006/main">
               <a:ext uri="{FF2B5EF4-FFF2-40B4-BE49-F238E27FC236}">
-                <a16:creationId xmlns:a16="http://schemas.microsoft.com/office/drawing/2014/main" id="{2AFAADB7-8B80-42D0-A2FF-7FC1D737197F}"/>
+                <a16:creationId xmlns:a16="http://schemas.microsoft.com/office/drawing/2014/main" id="{B677510B-3B7E-45B8-906D-45EEFAD4CA42}"/>
               </a:ext>
             </a:extLst>
           </p:cNvPr>
@@ -5757,7 +5757,7 @@
           <p:cNvPr id="35" name="">
             <a:extLst xmlns:a="http://schemas.openxmlformats.org/drawingml/2006/main">
               <a:ext uri="{FF2B5EF4-FFF2-40B4-BE49-F238E27FC236}">
-                <a16:creationId xmlns:a16="http://schemas.microsoft.com/office/drawing/2014/main" id="{E1A44AE6-C9C5-4D6C-8306-780C1CE471C0}"/>
+                <a16:creationId xmlns:a16="http://schemas.microsoft.com/office/drawing/2014/main" id="{42659D3B-0D6D-4E9C-AC8B-644C3D24D560}"/>
               </a:ext>
             </a:extLst>
           </p:cNvPr>
@@ -5802,7 +5802,7 @@
           <p:cNvPr id="36" name="">
             <a:extLst xmlns:a="http://schemas.openxmlformats.org/drawingml/2006/main">
               <a:ext uri="{FF2B5EF4-FFF2-40B4-BE49-F238E27FC236}">
-                <a16:creationId xmlns:a16="http://schemas.microsoft.com/office/drawing/2014/main" id="{93678B14-04DC-465D-AE5F-BD98C900FC85}"/>
+                <a16:creationId xmlns:a16="http://schemas.microsoft.com/office/drawing/2014/main" id="{C4E43C6E-AAFA-4263-AEEF-59BE618DB6CE}"/>
               </a:ext>
             </a:extLst>
           </p:cNvPr>
@@ -5847,7 +5847,7 @@
           <p:cNvPr id="37" name="">
             <a:extLst xmlns:a="http://schemas.openxmlformats.org/drawingml/2006/main">
               <a:ext uri="{FF2B5EF4-FFF2-40B4-BE49-F238E27FC236}">
-                <a16:creationId xmlns:a16="http://schemas.microsoft.com/office/drawing/2014/main" id="{EED32A7D-8F8B-4E43-BBDF-50FA51F81980}"/>
+                <a16:creationId xmlns:a16="http://schemas.microsoft.com/office/drawing/2014/main" id="{2AEA3F21-98E3-443F-A348-C46ECBA3A0C8}"/>
               </a:ext>
             </a:extLst>
           </p:cNvPr>
@@ -5890,7 +5890,7 @@
     </p:spTree>
     <p:extLst>
       <p:ext uri="{BB962C8B-B14F-4D97-AF65-F5344CB8AC3E}">
-        <p14:creationId xmlns:p14="http://schemas.microsoft.com/office/powerpoint/2010/main" val="422103654"/>
+        <p14:creationId xmlns:p14="http://schemas.microsoft.com/office/powerpoint/2010/main" val="1504993806"/>
       </p:ext>
     </p:extLst>
   </p:cSld>
@@ -5914,7 +5914,7 @@
           <p:cNvPr id="1" name="bg">
             <a:extLst xmlns:a="http://schemas.openxmlformats.org/drawingml/2006/main">
               <a:ext uri="{FF2B5EF4-FFF2-40B4-BE49-F238E27FC236}">
-                <a16:creationId xmlns:a16="http://schemas.microsoft.com/office/drawing/2014/main" id="{1AC31F5C-AF10-487E-BD8B-BD3C5474C211}"/>
+                <a16:creationId xmlns:a16="http://schemas.microsoft.com/office/drawing/2014/main" id="{CF79D209-33F7-4E9B-ADB7-F37582D33106}"/>
               </a:ext>
             </a:extLst>
           </p:cNvPr>
@@ -5941,7 +5941,7 @@
           <p:cNvPr id="2" name="top-field">
             <a:extLst xmlns:a="http://schemas.openxmlformats.org/drawingml/2006/main">
               <a:ext uri="{FF2B5EF4-FFF2-40B4-BE49-F238E27FC236}">
-                <a16:creationId xmlns:a16="http://schemas.microsoft.com/office/drawing/2014/main" id="{E19032CB-2C21-41BC-B49E-C285AB9AA7FF}"/>
+                <a16:creationId xmlns:a16="http://schemas.microsoft.com/office/drawing/2014/main" id="{56FC2926-9FDE-4314-A178-A4E67459DD44}"/>
               </a:ext>
             </a:extLst>
           </p:cNvPr>
@@ -5968,7 +5968,7 @@
           <p:cNvPr id="3" name="">
             <a:extLst xmlns:a="http://schemas.openxmlformats.org/drawingml/2006/main">
               <a:ext uri="{FF2B5EF4-FFF2-40B4-BE49-F238E27FC236}">
-                <a16:creationId xmlns:a16="http://schemas.microsoft.com/office/drawing/2014/main" id="{E72839D7-042F-4152-8621-BBCFDB717646}"/>
+                <a16:creationId xmlns:a16="http://schemas.microsoft.com/office/drawing/2014/main" id="{6C6F57F6-4FA8-4690-8E61-A9DDA9613C77}"/>
               </a:ext>
             </a:extLst>
           </p:cNvPr>
@@ -5999,7 +5999,7 @@
           <p:cNvPr id="4" name="">
             <a:extLst xmlns:a="http://schemas.openxmlformats.org/drawingml/2006/main">
               <a:ext uri="{FF2B5EF4-FFF2-40B4-BE49-F238E27FC236}">
-                <a16:creationId xmlns:a16="http://schemas.microsoft.com/office/drawing/2014/main" id="{9DAC1F05-41A3-4B2A-958B-CE6A8E218DB3}"/>
+                <a16:creationId xmlns:a16="http://schemas.microsoft.com/office/drawing/2014/main" id="{F68C49A7-89A6-488C-9C6D-5E7F774EF86F}"/>
               </a:ext>
             </a:extLst>
           </p:cNvPr>
@@ -6044,7 +6044,7 @@
           <p:cNvPr id="5" name="">
             <a:extLst xmlns:a="http://schemas.openxmlformats.org/drawingml/2006/main">
               <a:ext uri="{FF2B5EF4-FFF2-40B4-BE49-F238E27FC236}">
-                <a16:creationId xmlns:a16="http://schemas.microsoft.com/office/drawing/2014/main" id="{B97BBC5D-577E-45B8-A7D7-5E154574DDEE}"/>
+                <a16:creationId xmlns:a16="http://schemas.microsoft.com/office/drawing/2014/main" id="{2BF6948F-C350-425D-B84F-ADB42872E599}"/>
               </a:ext>
             </a:extLst>
           </p:cNvPr>
@@ -6075,7 +6075,7 @@
           <p:cNvPr id="6" name="">
             <a:extLst xmlns:a="http://schemas.openxmlformats.org/drawingml/2006/main">
               <a:ext uri="{FF2B5EF4-FFF2-40B4-BE49-F238E27FC236}">
-                <a16:creationId xmlns:a16="http://schemas.microsoft.com/office/drawing/2014/main" id="{589FA944-195D-4781-8C07-36616A6BF754}"/>
+                <a16:creationId xmlns:a16="http://schemas.microsoft.com/office/drawing/2014/main" id="{059CEBC7-BCCB-4D79-AA65-735FEAFF9AA2}"/>
               </a:ext>
             </a:extLst>
           </p:cNvPr>
@@ -6120,7 +6120,7 @@
           <p:cNvPr id="7" name="">
             <a:extLst xmlns:a="http://schemas.openxmlformats.org/drawingml/2006/main">
               <a:ext uri="{FF2B5EF4-FFF2-40B4-BE49-F238E27FC236}">
-                <a16:creationId xmlns:a16="http://schemas.microsoft.com/office/drawing/2014/main" id="{CEA4250B-7AD0-4B4B-8B63-21BB50295196}"/>
+                <a16:creationId xmlns:a16="http://schemas.microsoft.com/office/drawing/2014/main" id="{1C2195B1-CD62-4DAE-B603-CBC57976F7E0}"/>
               </a:ext>
             </a:extLst>
           </p:cNvPr>
@@ -6165,7 +6165,7 @@
           <p:cNvPr id="8" name="">
             <a:extLst xmlns:a="http://schemas.openxmlformats.org/drawingml/2006/main">
               <a:ext uri="{FF2B5EF4-FFF2-40B4-BE49-F238E27FC236}">
-                <a16:creationId xmlns:a16="http://schemas.microsoft.com/office/drawing/2014/main" id="{12F6B2BC-24D9-4A3C-ADC3-118E577F64C3}"/>
+                <a16:creationId xmlns:a16="http://schemas.microsoft.com/office/drawing/2014/main" id="{28DBF388-E649-48A4-B1D2-49F720B624B8}"/>
               </a:ext>
             </a:extLst>
           </p:cNvPr>
@@ -6210,7 +6210,7 @@
           <p:cNvPr id="9" name="">
             <a:extLst xmlns:a="http://schemas.openxmlformats.org/drawingml/2006/main">
               <a:ext uri="{FF2B5EF4-FFF2-40B4-BE49-F238E27FC236}">
-                <a16:creationId xmlns:a16="http://schemas.microsoft.com/office/drawing/2014/main" id="{A0782557-CADE-48B8-902B-576E57B492E7}"/>
+                <a16:creationId xmlns:a16="http://schemas.microsoft.com/office/drawing/2014/main" id="{2845D71F-0A43-417C-9EB6-55AFE7A2B0E7}"/>
               </a:ext>
             </a:extLst>
           </p:cNvPr>
@@ -6255,7 +6255,7 @@
           <p:cNvPr id="10" name="">
             <a:extLst xmlns:a="http://schemas.openxmlformats.org/drawingml/2006/main">
               <a:ext uri="{FF2B5EF4-FFF2-40B4-BE49-F238E27FC236}">
-                <a16:creationId xmlns:a16="http://schemas.microsoft.com/office/drawing/2014/main" id="{9788B76C-7503-4312-9403-CC8EFBD1A72C}"/>
+                <a16:creationId xmlns:a16="http://schemas.microsoft.com/office/drawing/2014/main" id="{6B8662DB-41C5-4C5A-ACE8-B4D85FF1E879}"/>
               </a:ext>
             </a:extLst>
           </p:cNvPr>
@@ -6300,7 +6300,7 @@
           <p:cNvPr id="11" name="">
             <a:extLst xmlns:a="http://schemas.openxmlformats.org/drawingml/2006/main">
               <a:ext uri="{FF2B5EF4-FFF2-40B4-BE49-F238E27FC236}">
-                <a16:creationId xmlns:a16="http://schemas.microsoft.com/office/drawing/2014/main" id="{B7CD65E2-1B43-4B44-A390-156BFACE5792}"/>
+                <a16:creationId xmlns:a16="http://schemas.microsoft.com/office/drawing/2014/main" id="{274C1F40-9713-4CF5-BD87-03EC6443DDAF}"/>
               </a:ext>
             </a:extLst>
           </p:cNvPr>
@@ -6345,7 +6345,7 @@
           <p:cNvPr id="12" name="">
             <a:extLst xmlns:a="http://schemas.openxmlformats.org/drawingml/2006/main">
               <a:ext uri="{FF2B5EF4-FFF2-40B4-BE49-F238E27FC236}">
-                <a16:creationId xmlns:a16="http://schemas.microsoft.com/office/drawing/2014/main" id="{D5CD7824-552F-4AEE-9E55-AAE27CCFCEFD}"/>
+                <a16:creationId xmlns:a16="http://schemas.microsoft.com/office/drawing/2014/main" id="{280F2006-1E53-436C-85C2-DD01CC08F9A5}"/>
               </a:ext>
             </a:extLst>
           </p:cNvPr>
@@ -6390,7 +6390,7 @@
           <p:cNvPr id="13" name="">
             <a:extLst xmlns:a="http://schemas.openxmlformats.org/drawingml/2006/main">
               <a:ext uri="{FF2B5EF4-FFF2-40B4-BE49-F238E27FC236}">
-                <a16:creationId xmlns:a16="http://schemas.microsoft.com/office/drawing/2014/main" id="{014719C4-8407-4973-ACEA-153544537DDB}"/>
+                <a16:creationId xmlns:a16="http://schemas.microsoft.com/office/drawing/2014/main" id="{DE6585AE-E957-4F67-994D-944F49442054}"/>
               </a:ext>
             </a:extLst>
           </p:cNvPr>
@@ -6435,7 +6435,7 @@
           <p:cNvPr id="14" name="">
             <a:extLst xmlns:a="http://schemas.openxmlformats.org/drawingml/2006/main">
               <a:ext uri="{FF2B5EF4-FFF2-40B4-BE49-F238E27FC236}">
-                <a16:creationId xmlns:a16="http://schemas.microsoft.com/office/drawing/2014/main" id="{821D7ACE-39DB-47DE-84A6-EE3B72DDE15B}"/>
+                <a16:creationId xmlns:a16="http://schemas.microsoft.com/office/drawing/2014/main" id="{95438571-7479-48A4-87D6-4663A3D4E501}"/>
               </a:ext>
             </a:extLst>
           </p:cNvPr>
@@ -6480,7 +6480,7 @@
           <p:cNvPr id="15" name="">
             <a:extLst xmlns:a="http://schemas.openxmlformats.org/drawingml/2006/main">
               <a:ext uri="{FF2B5EF4-FFF2-40B4-BE49-F238E27FC236}">
-                <a16:creationId xmlns:a16="http://schemas.microsoft.com/office/drawing/2014/main" id="{2F661BC8-8486-446A-A24B-2F81154A8D37}"/>
+                <a16:creationId xmlns:a16="http://schemas.microsoft.com/office/drawing/2014/main" id="{A347C523-D8D9-4950-9FE6-C3A44F22CFAB}"/>
               </a:ext>
             </a:extLst>
           </p:cNvPr>
@@ -6525,7 +6525,7 @@
           <p:cNvPr id="16" name="">
             <a:extLst xmlns:a="http://schemas.openxmlformats.org/drawingml/2006/main">
               <a:ext uri="{FF2B5EF4-FFF2-40B4-BE49-F238E27FC236}">
-                <a16:creationId xmlns:a16="http://schemas.microsoft.com/office/drawing/2014/main" id="{B79E282A-1CC8-45AB-9AA9-918A29D04D9A}"/>
+                <a16:creationId xmlns:a16="http://schemas.microsoft.com/office/drawing/2014/main" id="{456CF76A-7AE6-4C38-AA23-19A47038E65E}"/>
               </a:ext>
             </a:extLst>
           </p:cNvPr>
@@ -6570,7 +6570,7 @@
           <p:cNvPr id="17" name="">
             <a:extLst xmlns:a="http://schemas.openxmlformats.org/drawingml/2006/main">
               <a:ext uri="{FF2B5EF4-FFF2-40B4-BE49-F238E27FC236}">
-                <a16:creationId xmlns:a16="http://schemas.microsoft.com/office/drawing/2014/main" id="{DB0B59E6-E388-4C5D-A5AC-90448AE9F3BC}"/>
+                <a16:creationId xmlns:a16="http://schemas.microsoft.com/office/drawing/2014/main" id="{3EB8D645-F3AE-4417-AB30-B0D69E07D0F6}"/>
               </a:ext>
             </a:extLst>
           </p:cNvPr>
@@ -6615,7 +6615,7 @@
           <p:cNvPr id="18" name="">
             <a:extLst xmlns:a="http://schemas.openxmlformats.org/drawingml/2006/main">
               <a:ext uri="{FF2B5EF4-FFF2-40B4-BE49-F238E27FC236}">
-                <a16:creationId xmlns:a16="http://schemas.microsoft.com/office/drawing/2014/main" id="{057C113D-1BFB-48B3-82A2-433726409220}"/>
+                <a16:creationId xmlns:a16="http://schemas.microsoft.com/office/drawing/2014/main" id="{4155BC0C-2DFE-4E91-A9A4-F5EDD6E6283A}"/>
               </a:ext>
             </a:extLst>
           </p:cNvPr>
@@ -6660,7 +6660,7 @@
           <p:cNvPr id="19" name="">
             <a:extLst xmlns:a="http://schemas.openxmlformats.org/drawingml/2006/main">
               <a:ext uri="{FF2B5EF4-FFF2-40B4-BE49-F238E27FC236}">
-                <a16:creationId xmlns:a16="http://schemas.microsoft.com/office/drawing/2014/main" id="{48DA3E85-E191-4265-AB25-91D7081648A1}"/>
+                <a16:creationId xmlns:a16="http://schemas.microsoft.com/office/drawing/2014/main" id="{D0FF03B5-4D54-4AFD-80C5-4FCEA298224D}"/>
               </a:ext>
             </a:extLst>
           </p:cNvPr>
@@ -6705,7 +6705,7 @@
           <p:cNvPr id="20" name="">
             <a:extLst xmlns:a="http://schemas.openxmlformats.org/drawingml/2006/main">
               <a:ext uri="{FF2B5EF4-FFF2-40B4-BE49-F238E27FC236}">
-                <a16:creationId xmlns:a16="http://schemas.microsoft.com/office/drawing/2014/main" id="{ACCDE943-93E7-452A-BA37-73B86C099C46}"/>
+                <a16:creationId xmlns:a16="http://schemas.microsoft.com/office/drawing/2014/main" id="{A8700159-83A7-454E-9486-3DD27AD43C26}"/>
               </a:ext>
             </a:extLst>
           </p:cNvPr>
@@ -6750,7 +6750,7 @@
           <p:cNvPr id="21" name="">
             <a:extLst xmlns:a="http://schemas.openxmlformats.org/drawingml/2006/main">
               <a:ext uri="{FF2B5EF4-FFF2-40B4-BE49-F238E27FC236}">
-                <a16:creationId xmlns:a16="http://schemas.microsoft.com/office/drawing/2014/main" id="{32E5A37A-71E9-415D-B195-F4E6A580CCFE}"/>
+                <a16:creationId xmlns:a16="http://schemas.microsoft.com/office/drawing/2014/main" id="{7EEEB024-872F-4670-AD5F-BA2600D9EF98}"/>
               </a:ext>
             </a:extLst>
           </p:cNvPr>
@@ -6795,7 +6795,7 @@
           <p:cNvPr id="22" name="">
             <a:extLst xmlns:a="http://schemas.openxmlformats.org/drawingml/2006/main">
               <a:ext uri="{FF2B5EF4-FFF2-40B4-BE49-F238E27FC236}">
-                <a16:creationId xmlns:a16="http://schemas.microsoft.com/office/drawing/2014/main" id="{EE21A831-603F-4323-9316-406661D85E55}"/>
+                <a16:creationId xmlns:a16="http://schemas.microsoft.com/office/drawing/2014/main" id="{8F070F80-6E67-46D2-8B3F-7C789A0CCEDE}"/>
               </a:ext>
             </a:extLst>
           </p:cNvPr>
@@ -6840,7 +6840,7 @@
           <p:cNvPr id="23" name="">
             <a:extLst xmlns:a="http://schemas.openxmlformats.org/drawingml/2006/main">
               <a:ext uri="{FF2B5EF4-FFF2-40B4-BE49-F238E27FC236}">
-                <a16:creationId xmlns:a16="http://schemas.microsoft.com/office/drawing/2014/main" id="{CCB876F0-A3EA-40A7-8370-76FF5884C2A6}"/>
+                <a16:creationId xmlns:a16="http://schemas.microsoft.com/office/drawing/2014/main" id="{71032A63-9887-4834-BAA9-7B3573F1B9BF}"/>
               </a:ext>
             </a:extLst>
           </p:cNvPr>
@@ -6885,7 +6885,7 @@
           <p:cNvPr id="24" name="">
             <a:extLst xmlns:a="http://schemas.openxmlformats.org/drawingml/2006/main">
               <a:ext uri="{FF2B5EF4-FFF2-40B4-BE49-F238E27FC236}">
-                <a16:creationId xmlns:a16="http://schemas.microsoft.com/office/drawing/2014/main" id="{82259306-A89B-48C6-A15D-B86D20CA30CB}"/>
+                <a16:creationId xmlns:a16="http://schemas.microsoft.com/office/drawing/2014/main" id="{BBA152EF-54DC-40F2-B7F8-D577594FB8F2}"/>
               </a:ext>
             </a:extLst>
           </p:cNvPr>
@@ -6930,7 +6930,7 @@
           <p:cNvPr id="25" name="">
             <a:extLst xmlns:a="http://schemas.openxmlformats.org/drawingml/2006/main">
               <a:ext uri="{FF2B5EF4-FFF2-40B4-BE49-F238E27FC236}">
-                <a16:creationId xmlns:a16="http://schemas.microsoft.com/office/drawing/2014/main" id="{33643F2C-1885-4AFA-A771-8F800FCDB916}"/>
+                <a16:creationId xmlns:a16="http://schemas.microsoft.com/office/drawing/2014/main" id="{39026C7B-295F-4CE4-9B7E-9A9F0AFC4A90}"/>
               </a:ext>
             </a:extLst>
           </p:cNvPr>
@@ -6975,7 +6975,7 @@
           <p:cNvPr id="26" name="">
             <a:extLst xmlns:a="http://schemas.openxmlformats.org/drawingml/2006/main">
               <a:ext uri="{FF2B5EF4-FFF2-40B4-BE49-F238E27FC236}">
-                <a16:creationId xmlns:a16="http://schemas.microsoft.com/office/drawing/2014/main" id="{CBE2ADEA-0E1A-4126-B56C-E60A23ED84FC}"/>
+                <a16:creationId xmlns:a16="http://schemas.microsoft.com/office/drawing/2014/main" id="{AEEA0D11-60C5-4CD3-9092-D08E20B73B38}"/>
               </a:ext>
             </a:extLst>
           </p:cNvPr>
@@ -7018,7 +7018,7 @@
     </p:spTree>
     <p:extLst>
       <p:ext uri="{BB962C8B-B14F-4D97-AF65-F5344CB8AC3E}">
-        <p14:creationId xmlns:p14="http://schemas.microsoft.com/office/powerpoint/2010/main" val="1314131081"/>
+        <p14:creationId xmlns:p14="http://schemas.microsoft.com/office/powerpoint/2010/main" val="1194735040"/>
       </p:ext>
     </p:extLst>
   </p:cSld>
@@ -7042,7 +7042,7 @@
           <p:cNvPr id="1" name="bg">
             <a:extLst xmlns:a="http://schemas.openxmlformats.org/drawingml/2006/main">
               <a:ext uri="{FF2B5EF4-FFF2-40B4-BE49-F238E27FC236}">
-                <a16:creationId xmlns:a16="http://schemas.microsoft.com/office/drawing/2014/main" id="{B5B4AC4C-74FF-4C8C-8DD4-B6D0E7A1B7E2}"/>
+                <a16:creationId xmlns:a16="http://schemas.microsoft.com/office/drawing/2014/main" id="{4620193F-EED0-41A5-83E5-D5BBD45953B0}"/>
               </a:ext>
             </a:extLst>
           </p:cNvPr>
@@ -7069,7 +7069,7 @@
           <p:cNvPr id="2" name="top-field">
             <a:extLst xmlns:a="http://schemas.openxmlformats.org/drawingml/2006/main">
               <a:ext uri="{FF2B5EF4-FFF2-40B4-BE49-F238E27FC236}">
-                <a16:creationId xmlns:a16="http://schemas.microsoft.com/office/drawing/2014/main" id="{B68DDEDA-0BA2-4CD9-B637-4AF2257CAF5C}"/>
+                <a16:creationId xmlns:a16="http://schemas.microsoft.com/office/drawing/2014/main" id="{FC1BC97C-002A-4017-B8EC-81A31EE640E6}"/>
               </a:ext>
             </a:extLst>
           </p:cNvPr>
@@ -7096,7 +7096,7 @@
           <p:cNvPr id="3" name="">
             <a:extLst xmlns:a="http://schemas.openxmlformats.org/drawingml/2006/main">
               <a:ext uri="{FF2B5EF4-FFF2-40B4-BE49-F238E27FC236}">
-                <a16:creationId xmlns:a16="http://schemas.microsoft.com/office/drawing/2014/main" id="{642A9F62-457F-475B-8178-6FB6C7A52F82}"/>
+                <a16:creationId xmlns:a16="http://schemas.microsoft.com/office/drawing/2014/main" id="{F245A315-A365-437B-8ECA-A08EFFDD6182}"/>
               </a:ext>
             </a:extLst>
           </p:cNvPr>
@@ -7127,7 +7127,7 @@
           <p:cNvPr id="4" name="">
             <a:extLst xmlns:a="http://schemas.openxmlformats.org/drawingml/2006/main">
               <a:ext uri="{FF2B5EF4-FFF2-40B4-BE49-F238E27FC236}">
-                <a16:creationId xmlns:a16="http://schemas.microsoft.com/office/drawing/2014/main" id="{B7932DBD-BC6E-48BA-A7D0-452F2B41FA58}"/>
+                <a16:creationId xmlns:a16="http://schemas.microsoft.com/office/drawing/2014/main" id="{D7AA1F01-F66C-471E-ACAC-D0F298962842}"/>
               </a:ext>
             </a:extLst>
           </p:cNvPr>
@@ -7172,7 +7172,7 @@
           <p:cNvPr id="5" name="">
             <a:extLst xmlns:a="http://schemas.openxmlformats.org/drawingml/2006/main">
               <a:ext uri="{FF2B5EF4-FFF2-40B4-BE49-F238E27FC236}">
-                <a16:creationId xmlns:a16="http://schemas.microsoft.com/office/drawing/2014/main" id="{D127D02F-2A0A-424E-B835-A95C93194DC6}"/>
+                <a16:creationId xmlns:a16="http://schemas.microsoft.com/office/drawing/2014/main" id="{CFF919AD-9D70-49ED-8BAA-897340671675}"/>
               </a:ext>
             </a:extLst>
           </p:cNvPr>
@@ -7203,7 +7203,7 @@
           <p:cNvPr id="6" name="">
             <a:extLst xmlns:a="http://schemas.openxmlformats.org/drawingml/2006/main">
               <a:ext uri="{FF2B5EF4-FFF2-40B4-BE49-F238E27FC236}">
-                <a16:creationId xmlns:a16="http://schemas.microsoft.com/office/drawing/2014/main" id="{B4F5E32D-6501-451C-AD25-45475057E606}"/>
+                <a16:creationId xmlns:a16="http://schemas.microsoft.com/office/drawing/2014/main" id="{63A91553-1543-496D-8ED9-846A472D96F2}"/>
               </a:ext>
             </a:extLst>
           </p:cNvPr>
@@ -7248,7 +7248,7 @@
           <p:cNvPr id="7" name="">
             <a:extLst xmlns:a="http://schemas.openxmlformats.org/drawingml/2006/main">
               <a:ext uri="{FF2B5EF4-FFF2-40B4-BE49-F238E27FC236}">
-                <a16:creationId xmlns:a16="http://schemas.microsoft.com/office/drawing/2014/main" id="{848BA9EE-78BB-4EE5-9236-DAF6A0A90107}"/>
+                <a16:creationId xmlns:a16="http://schemas.microsoft.com/office/drawing/2014/main" id="{A2F97EF0-F67D-438F-AAA3-6DA4ED60902C}"/>
               </a:ext>
             </a:extLst>
           </p:cNvPr>
@@ -7293,7 +7293,7 @@
           <p:cNvPr id="8" name="">
             <a:extLst xmlns:a="http://schemas.openxmlformats.org/drawingml/2006/main">
               <a:ext uri="{FF2B5EF4-FFF2-40B4-BE49-F238E27FC236}">
-                <a16:creationId xmlns:a16="http://schemas.microsoft.com/office/drawing/2014/main" id="{72EC2D03-DB14-4BB2-8A5A-2E3AC51A4433}"/>
+                <a16:creationId xmlns:a16="http://schemas.microsoft.com/office/drawing/2014/main" id="{217BEA33-C7CA-43F0-8B4E-D2892E5098EC}"/>
               </a:ext>
             </a:extLst>
           </p:cNvPr>
@@ -7338,7 +7338,7 @@
           <p:cNvPr id="9" name="">
             <a:extLst xmlns:a="http://schemas.openxmlformats.org/drawingml/2006/main">
               <a:ext uri="{FF2B5EF4-FFF2-40B4-BE49-F238E27FC236}">
-                <a16:creationId xmlns:a16="http://schemas.microsoft.com/office/drawing/2014/main" id="{49CE0087-A27F-46BA-85FC-DDD036BA1A2A}"/>
+                <a16:creationId xmlns:a16="http://schemas.microsoft.com/office/drawing/2014/main" id="{0AFBCEF4-DCD5-4113-A5C9-097353D64BF6}"/>
               </a:ext>
             </a:extLst>
           </p:cNvPr>
@@ -7383,7 +7383,7 @@
           <p:cNvPr id="10" name="">
             <a:extLst xmlns:a="http://schemas.openxmlformats.org/drawingml/2006/main">
               <a:ext uri="{FF2B5EF4-FFF2-40B4-BE49-F238E27FC236}">
-                <a16:creationId xmlns:a16="http://schemas.microsoft.com/office/drawing/2014/main" id="{B5607177-A4F8-4A31-97A6-6A0E655C00B9}"/>
+                <a16:creationId xmlns:a16="http://schemas.microsoft.com/office/drawing/2014/main" id="{1F002B7D-4FA2-4F38-A0FD-2443E3BE6998}"/>
               </a:ext>
             </a:extLst>
           </p:cNvPr>
@@ -7414,7 +7414,7 @@
           <p:cNvPr id="11" name="">
             <a:extLst xmlns:a="http://schemas.openxmlformats.org/drawingml/2006/main">
               <a:ext uri="{FF2B5EF4-FFF2-40B4-BE49-F238E27FC236}">
-                <a16:creationId xmlns:a16="http://schemas.microsoft.com/office/drawing/2014/main" id="{8BA7474F-E91C-4969-93C8-51BB4E48317D}"/>
+                <a16:creationId xmlns:a16="http://schemas.microsoft.com/office/drawing/2014/main" id="{E08A6EE9-5850-467D-8352-17CDFDBB5065}"/>
               </a:ext>
             </a:extLst>
           </p:cNvPr>
@@ -7459,7 +7459,7 @@
           <p:cNvPr id="12" name="">
             <a:extLst xmlns:a="http://schemas.openxmlformats.org/drawingml/2006/main">
               <a:ext uri="{FF2B5EF4-FFF2-40B4-BE49-F238E27FC236}">
-                <a16:creationId xmlns:a16="http://schemas.microsoft.com/office/drawing/2014/main" id="{2B6E77B4-EFD5-416F-9904-D3B9BB4A8583}"/>
+                <a16:creationId xmlns:a16="http://schemas.microsoft.com/office/drawing/2014/main" id="{C67AC361-9875-4AD3-8348-805A2D1BB45F}"/>
               </a:ext>
             </a:extLst>
           </p:cNvPr>
@@ -7488,7 +7488,7 @@
           <p:cNvPr id="13" name="">
             <a:extLst xmlns:a="http://schemas.openxmlformats.org/drawingml/2006/main">
               <a:ext uri="{FF2B5EF4-FFF2-40B4-BE49-F238E27FC236}">
-                <a16:creationId xmlns:a16="http://schemas.microsoft.com/office/drawing/2014/main" id="{1CC3F3CF-2ED0-45FA-BB33-D7686A5B6520}"/>
+                <a16:creationId xmlns:a16="http://schemas.microsoft.com/office/drawing/2014/main" id="{061AFD56-533B-40A3-BCA4-5520F4F92DE5}"/>
               </a:ext>
             </a:extLst>
           </p:cNvPr>
@@ -7533,7 +7533,7 @@
           <p:cNvPr id="14" name="">
             <a:extLst xmlns:a="http://schemas.openxmlformats.org/drawingml/2006/main">
               <a:ext uri="{FF2B5EF4-FFF2-40B4-BE49-F238E27FC236}">
-                <a16:creationId xmlns:a16="http://schemas.microsoft.com/office/drawing/2014/main" id="{D54E2BC1-2E4F-4DE3-8EEF-A44225AB2743}"/>
+                <a16:creationId xmlns:a16="http://schemas.microsoft.com/office/drawing/2014/main" id="{7B612452-D9EC-4A50-89FE-90B1D7134FF5}"/>
               </a:ext>
             </a:extLst>
           </p:cNvPr>
@@ -7562,7 +7562,7 @@
           <p:cNvPr id="15" name="">
             <a:extLst xmlns:a="http://schemas.openxmlformats.org/drawingml/2006/main">
               <a:ext uri="{FF2B5EF4-FFF2-40B4-BE49-F238E27FC236}">
-                <a16:creationId xmlns:a16="http://schemas.microsoft.com/office/drawing/2014/main" id="{C7102C5B-6E0A-4414-87CD-2CD55AF46364}"/>
+                <a16:creationId xmlns:a16="http://schemas.microsoft.com/office/drawing/2014/main" id="{819BB25A-5606-49E5-9FA9-50414DBE8237}"/>
               </a:ext>
             </a:extLst>
           </p:cNvPr>
@@ -7607,7 +7607,7 @@
           <p:cNvPr id="16" name="">
             <a:extLst xmlns:a="http://schemas.openxmlformats.org/drawingml/2006/main">
               <a:ext uri="{FF2B5EF4-FFF2-40B4-BE49-F238E27FC236}">
-                <a16:creationId xmlns:a16="http://schemas.microsoft.com/office/drawing/2014/main" id="{BB792764-23DC-42FF-B920-E2646026A0B2}"/>
+                <a16:creationId xmlns:a16="http://schemas.microsoft.com/office/drawing/2014/main" id="{0941711A-3474-4B0D-8B34-7249D65399AA}"/>
               </a:ext>
             </a:extLst>
           </p:cNvPr>
@@ -7636,7 +7636,7 @@
           <p:cNvPr id="17" name="">
             <a:extLst xmlns:a="http://schemas.openxmlformats.org/drawingml/2006/main">
               <a:ext uri="{FF2B5EF4-FFF2-40B4-BE49-F238E27FC236}">
-                <a16:creationId xmlns:a16="http://schemas.microsoft.com/office/drawing/2014/main" id="{501F17A5-836C-4382-8349-F12A9B57B6E2}"/>
+                <a16:creationId xmlns:a16="http://schemas.microsoft.com/office/drawing/2014/main" id="{67F07E0C-6942-4A55-A455-4B7A4A7FFED1}"/>
               </a:ext>
             </a:extLst>
           </p:cNvPr>
@@ -7681,7 +7681,7 @@
           <p:cNvPr id="18" name="">
             <a:extLst xmlns:a="http://schemas.openxmlformats.org/drawingml/2006/main">
               <a:ext uri="{FF2B5EF4-FFF2-40B4-BE49-F238E27FC236}">
-                <a16:creationId xmlns:a16="http://schemas.microsoft.com/office/drawing/2014/main" id="{3FED028F-1DE4-411F-8457-50D8D439F6C5}"/>
+                <a16:creationId xmlns:a16="http://schemas.microsoft.com/office/drawing/2014/main" id="{4DBC050F-D88F-458E-9A5D-6BB62B57E270}"/>
               </a:ext>
             </a:extLst>
           </p:cNvPr>
@@ -7712,7 +7712,7 @@
           <p:cNvPr id="19" name="">
             <a:extLst xmlns:a="http://schemas.openxmlformats.org/drawingml/2006/main">
               <a:ext uri="{FF2B5EF4-FFF2-40B4-BE49-F238E27FC236}">
-                <a16:creationId xmlns:a16="http://schemas.microsoft.com/office/drawing/2014/main" id="{B762F4C9-09A0-4291-8C72-06D3F4DD3C90}"/>
+                <a16:creationId xmlns:a16="http://schemas.microsoft.com/office/drawing/2014/main" id="{B1D06651-7F75-4965-8749-D24635165EF4}"/>
               </a:ext>
             </a:extLst>
           </p:cNvPr>
@@ -7757,7 +7757,7 @@
           <p:cNvPr id="20" name="">
             <a:extLst xmlns:a="http://schemas.openxmlformats.org/drawingml/2006/main">
               <a:ext uri="{FF2B5EF4-FFF2-40B4-BE49-F238E27FC236}">
-                <a16:creationId xmlns:a16="http://schemas.microsoft.com/office/drawing/2014/main" id="{128AE8AB-879D-41D3-8B30-F7F4C372079C}"/>
+                <a16:creationId xmlns:a16="http://schemas.microsoft.com/office/drawing/2014/main" id="{18EAB79E-D399-4C50-997E-8B907FDE647E}"/>
               </a:ext>
             </a:extLst>
           </p:cNvPr>
@@ -7802,7 +7802,7 @@
           <p:cNvPr id="21" name="">
             <a:extLst xmlns:a="http://schemas.openxmlformats.org/drawingml/2006/main">
               <a:ext uri="{FF2B5EF4-FFF2-40B4-BE49-F238E27FC236}">
-                <a16:creationId xmlns:a16="http://schemas.microsoft.com/office/drawing/2014/main" id="{EEF01CCF-CAD6-41D5-9F59-9AD1A87CFC3C}"/>
+                <a16:creationId xmlns:a16="http://schemas.microsoft.com/office/drawing/2014/main" id="{C7EDAF36-71E1-4802-B6A4-CB9DC892561D}"/>
               </a:ext>
             </a:extLst>
           </p:cNvPr>
@@ -7847,7 +7847,7 @@
           <p:cNvPr id="22" name="">
             <a:extLst xmlns:a="http://schemas.openxmlformats.org/drawingml/2006/main">
               <a:ext uri="{FF2B5EF4-FFF2-40B4-BE49-F238E27FC236}">
-                <a16:creationId xmlns:a16="http://schemas.microsoft.com/office/drawing/2014/main" id="{86F69777-05E7-4421-85A5-86209D3771EC}"/>
+                <a16:creationId xmlns:a16="http://schemas.microsoft.com/office/drawing/2014/main" id="{7FDF98FE-5F0B-4CC5-AB6F-0D301AD0EB3F}"/>
               </a:ext>
             </a:extLst>
           </p:cNvPr>
@@ -7876,7 +7876,7 @@
           <p:cNvPr id="23" name="">
             <a:extLst xmlns:a="http://schemas.openxmlformats.org/drawingml/2006/main">
               <a:ext uri="{FF2B5EF4-FFF2-40B4-BE49-F238E27FC236}">
-                <a16:creationId xmlns:a16="http://schemas.microsoft.com/office/drawing/2014/main" id="{00BD0209-C597-42B6-B04A-BA6CA25FABDB}"/>
+                <a16:creationId xmlns:a16="http://schemas.microsoft.com/office/drawing/2014/main" id="{2A3FC59B-8701-42D0-A57E-70DE86EEC47C}"/>
               </a:ext>
             </a:extLst>
           </p:cNvPr>
@@ -7921,7 +7921,7 @@
           <p:cNvPr id="24" name="">
             <a:extLst xmlns:a="http://schemas.openxmlformats.org/drawingml/2006/main">
               <a:ext uri="{FF2B5EF4-FFF2-40B4-BE49-F238E27FC236}">
-                <a16:creationId xmlns:a16="http://schemas.microsoft.com/office/drawing/2014/main" id="{62E8FAFD-CB12-4FA7-B9D8-86DD6FD9ED1B}"/>
+                <a16:creationId xmlns:a16="http://schemas.microsoft.com/office/drawing/2014/main" id="{D032015A-C95C-4C86-BBCA-55128CDFBCC3}"/>
               </a:ext>
             </a:extLst>
           </p:cNvPr>
@@ -7950,7 +7950,7 @@
           <p:cNvPr id="25" name="">
             <a:extLst xmlns:a="http://schemas.openxmlformats.org/drawingml/2006/main">
               <a:ext uri="{FF2B5EF4-FFF2-40B4-BE49-F238E27FC236}">
-                <a16:creationId xmlns:a16="http://schemas.microsoft.com/office/drawing/2014/main" id="{0D41E453-5F0E-4CC7-8029-1252BA78BB14}"/>
+                <a16:creationId xmlns:a16="http://schemas.microsoft.com/office/drawing/2014/main" id="{234CFFF6-E095-440B-A199-7002383046DA}"/>
               </a:ext>
             </a:extLst>
           </p:cNvPr>
@@ -7995,7 +7995,7 @@
           <p:cNvPr id="26" name="">
             <a:extLst xmlns:a="http://schemas.openxmlformats.org/drawingml/2006/main">
               <a:ext uri="{FF2B5EF4-FFF2-40B4-BE49-F238E27FC236}">
-                <a16:creationId xmlns:a16="http://schemas.microsoft.com/office/drawing/2014/main" id="{276E673A-CA18-436A-B222-A1BA14919044}"/>
+                <a16:creationId xmlns:a16="http://schemas.microsoft.com/office/drawing/2014/main" id="{909D382F-ED99-4E8A-B670-3C371A9EF57E}"/>
               </a:ext>
             </a:extLst>
           </p:cNvPr>
@@ -8024,7 +8024,7 @@
           <p:cNvPr id="27" name="">
             <a:extLst xmlns:a="http://schemas.openxmlformats.org/drawingml/2006/main">
               <a:ext uri="{FF2B5EF4-FFF2-40B4-BE49-F238E27FC236}">
-                <a16:creationId xmlns:a16="http://schemas.microsoft.com/office/drawing/2014/main" id="{19C833CE-7216-415C-B820-7B30FEB4613E}"/>
+                <a16:creationId xmlns:a16="http://schemas.microsoft.com/office/drawing/2014/main" id="{A55021F1-F6C8-43E2-9F59-F645BC45C2C1}"/>
               </a:ext>
             </a:extLst>
           </p:cNvPr>
@@ -8069,7 +8069,7 @@
           <p:cNvPr id="28" name="">
             <a:extLst xmlns:a="http://schemas.openxmlformats.org/drawingml/2006/main">
               <a:ext uri="{FF2B5EF4-FFF2-40B4-BE49-F238E27FC236}">
-                <a16:creationId xmlns:a16="http://schemas.microsoft.com/office/drawing/2014/main" id="{795F136B-ECE8-4B56-98A8-9226BC100BA1}"/>
+                <a16:creationId xmlns:a16="http://schemas.microsoft.com/office/drawing/2014/main" id="{2B8C5B8E-B5D2-4CEE-88E8-5B81B4CCDC29}"/>
               </a:ext>
             </a:extLst>
           </p:cNvPr>
@@ -8098,7 +8098,7 @@
           <p:cNvPr id="29" name="">
             <a:extLst xmlns:a="http://schemas.openxmlformats.org/drawingml/2006/main">
               <a:ext uri="{FF2B5EF4-FFF2-40B4-BE49-F238E27FC236}">
-                <a16:creationId xmlns:a16="http://schemas.microsoft.com/office/drawing/2014/main" id="{A0E14541-9E87-4F59-ABB0-183868B8EF59}"/>
+                <a16:creationId xmlns:a16="http://schemas.microsoft.com/office/drawing/2014/main" id="{4BDB0BCE-06F9-4264-B643-30156E82E891}"/>
               </a:ext>
             </a:extLst>
           </p:cNvPr>
@@ -8143,7 +8143,7 @@
           <p:cNvPr id="30" name="">
             <a:extLst xmlns:a="http://schemas.openxmlformats.org/drawingml/2006/main">
               <a:ext uri="{FF2B5EF4-FFF2-40B4-BE49-F238E27FC236}">
-                <a16:creationId xmlns:a16="http://schemas.microsoft.com/office/drawing/2014/main" id="{83360990-422D-4684-A02C-39056F7CE82D}"/>
+                <a16:creationId xmlns:a16="http://schemas.microsoft.com/office/drawing/2014/main" id="{5C91092B-A24D-4724-A661-6EFE26CF00E8}"/>
               </a:ext>
             </a:extLst>
           </p:cNvPr>
@@ -8172,7 +8172,7 @@
           <p:cNvPr id="31" name="">
             <a:extLst xmlns:a="http://schemas.openxmlformats.org/drawingml/2006/main">
               <a:ext uri="{FF2B5EF4-FFF2-40B4-BE49-F238E27FC236}">
-                <a16:creationId xmlns:a16="http://schemas.microsoft.com/office/drawing/2014/main" id="{56E3A41F-3761-4F33-BFFF-76CFAA665A9F}"/>
+                <a16:creationId xmlns:a16="http://schemas.microsoft.com/office/drawing/2014/main" id="{CF70BCBB-A39C-4742-95B3-8C9D74A2090D}"/>
               </a:ext>
             </a:extLst>
           </p:cNvPr>
@@ -8217,7 +8217,7 @@
           <p:cNvPr id="32" name="">
             <a:extLst xmlns:a="http://schemas.openxmlformats.org/drawingml/2006/main">
               <a:ext uri="{FF2B5EF4-FFF2-40B4-BE49-F238E27FC236}">
-                <a16:creationId xmlns:a16="http://schemas.microsoft.com/office/drawing/2014/main" id="{E0C96373-1C4F-449E-8561-D33E4FE1D17E}"/>
+                <a16:creationId xmlns:a16="http://schemas.microsoft.com/office/drawing/2014/main" id="{785584A4-D04D-4031-863B-8B1EE0E5565D}"/>
               </a:ext>
             </a:extLst>
           </p:cNvPr>
@@ -8246,7 +8246,7 @@
           <p:cNvPr id="33" name="">
             <a:extLst xmlns:a="http://schemas.openxmlformats.org/drawingml/2006/main">
               <a:ext uri="{FF2B5EF4-FFF2-40B4-BE49-F238E27FC236}">
-                <a16:creationId xmlns:a16="http://schemas.microsoft.com/office/drawing/2014/main" id="{F7B15E44-AB1F-4154-9F3E-C98348EF7193}"/>
+                <a16:creationId xmlns:a16="http://schemas.microsoft.com/office/drawing/2014/main" id="{5E81A01F-A619-43B6-906B-0243D3521676}"/>
               </a:ext>
             </a:extLst>
           </p:cNvPr>
@@ -8291,7 +8291,7 @@
           <p:cNvPr id="34" name="">
             <a:extLst xmlns:a="http://schemas.openxmlformats.org/drawingml/2006/main">
               <a:ext uri="{FF2B5EF4-FFF2-40B4-BE49-F238E27FC236}">
-                <a16:creationId xmlns:a16="http://schemas.microsoft.com/office/drawing/2014/main" id="{D9A4CD63-FE45-40FE-ADE2-F555D249E92E}"/>
+                <a16:creationId xmlns:a16="http://schemas.microsoft.com/office/drawing/2014/main" id="{87AFF5BD-C831-41B2-9E85-E4971798E2E1}"/>
               </a:ext>
             </a:extLst>
           </p:cNvPr>
@@ -8320,7 +8320,7 @@
           <p:cNvPr id="35" name="">
             <a:extLst xmlns:a="http://schemas.openxmlformats.org/drawingml/2006/main">
               <a:ext uri="{FF2B5EF4-FFF2-40B4-BE49-F238E27FC236}">
-                <a16:creationId xmlns:a16="http://schemas.microsoft.com/office/drawing/2014/main" id="{64FA44B4-AE13-4DC4-8AD0-E85FE629F481}"/>
+                <a16:creationId xmlns:a16="http://schemas.microsoft.com/office/drawing/2014/main" id="{D46F3223-3A6C-406E-8EFF-67405D1EFC23}"/>
               </a:ext>
             </a:extLst>
           </p:cNvPr>
@@ -8365,7 +8365,7 @@
           <p:cNvPr id="36" name="">
             <a:extLst xmlns:a="http://schemas.openxmlformats.org/drawingml/2006/main">
               <a:ext uri="{FF2B5EF4-FFF2-40B4-BE49-F238E27FC236}">
-                <a16:creationId xmlns:a16="http://schemas.microsoft.com/office/drawing/2014/main" id="{D640E144-08EB-4F92-9FDD-7DF89149F0AE}"/>
+                <a16:creationId xmlns:a16="http://schemas.microsoft.com/office/drawing/2014/main" id="{493CE57C-142E-4C1D-ACDA-7143B4383BE0}"/>
               </a:ext>
             </a:extLst>
           </p:cNvPr>
@@ -8394,7 +8394,7 @@
           <p:cNvPr id="37" name="">
             <a:extLst xmlns:a="http://schemas.openxmlformats.org/drawingml/2006/main">
               <a:ext uri="{FF2B5EF4-FFF2-40B4-BE49-F238E27FC236}">
-                <a16:creationId xmlns:a16="http://schemas.microsoft.com/office/drawing/2014/main" id="{BEE80CC8-4281-41DA-844A-648B60D777A5}"/>
+                <a16:creationId xmlns:a16="http://schemas.microsoft.com/office/drawing/2014/main" id="{58460DCD-4AC4-4D1B-9615-C38FA6BFD5D5}"/>
               </a:ext>
             </a:extLst>
           </p:cNvPr>
@@ -8439,7 +8439,7 @@
           <p:cNvPr id="38" name="">
             <a:extLst xmlns:a="http://schemas.openxmlformats.org/drawingml/2006/main">
               <a:ext uri="{FF2B5EF4-FFF2-40B4-BE49-F238E27FC236}">
-                <a16:creationId xmlns:a16="http://schemas.microsoft.com/office/drawing/2014/main" id="{0A093A6B-5174-4D0B-9676-171F663236D5}"/>
+                <a16:creationId xmlns:a16="http://schemas.microsoft.com/office/drawing/2014/main" id="{75508144-3126-4C37-9FAF-A3C6F03396F6}"/>
               </a:ext>
             </a:extLst>
           </p:cNvPr>
@@ -8484,7 +8484,7 @@
           <p:cNvPr id="39" name="">
             <a:extLst xmlns:a="http://schemas.openxmlformats.org/drawingml/2006/main">
               <a:ext uri="{FF2B5EF4-FFF2-40B4-BE49-F238E27FC236}">
-                <a16:creationId xmlns:a16="http://schemas.microsoft.com/office/drawing/2014/main" id="{F6AD2DC0-8B3C-41B3-B6CB-180D405CDBDD}"/>
+                <a16:creationId xmlns:a16="http://schemas.microsoft.com/office/drawing/2014/main" id="{EAC3B1CC-4AC5-4D95-8C19-C458645F47B9}"/>
               </a:ext>
             </a:extLst>
           </p:cNvPr>
@@ -8527,7 +8527,7 @@
     </p:spTree>
     <p:extLst>
       <p:ext uri="{BB962C8B-B14F-4D97-AF65-F5344CB8AC3E}">
-        <p14:creationId xmlns:p14="http://schemas.microsoft.com/office/powerpoint/2010/main" val="135245246"/>
+        <p14:creationId xmlns:p14="http://schemas.microsoft.com/office/powerpoint/2010/main" val="1119353271"/>
       </p:ext>
     </p:extLst>
   </p:cSld>
@@ -8551,7 +8551,7 @@
           <p:cNvPr id="1" name="bg">
             <a:extLst xmlns:a="http://schemas.openxmlformats.org/drawingml/2006/main">
               <a:ext uri="{FF2B5EF4-FFF2-40B4-BE49-F238E27FC236}">
-                <a16:creationId xmlns:a16="http://schemas.microsoft.com/office/drawing/2014/main" id="{5D1D6BF2-E21F-47C6-B13A-60107C974BDE}"/>
+                <a16:creationId xmlns:a16="http://schemas.microsoft.com/office/drawing/2014/main" id="{AE4CC32E-6236-4064-B0D2-0E2242264F5D}"/>
               </a:ext>
             </a:extLst>
           </p:cNvPr>
@@ -8578,7 +8578,7 @@
           <p:cNvPr id="2" name="top-field">
             <a:extLst xmlns:a="http://schemas.openxmlformats.org/drawingml/2006/main">
               <a:ext uri="{FF2B5EF4-FFF2-40B4-BE49-F238E27FC236}">
-                <a16:creationId xmlns:a16="http://schemas.microsoft.com/office/drawing/2014/main" id="{5DC962E4-F788-4FB0-A431-693DC7FD2F56}"/>
+                <a16:creationId xmlns:a16="http://schemas.microsoft.com/office/drawing/2014/main" id="{C8C4828B-0625-4954-8EA7-3AEF26E23E90}"/>
               </a:ext>
             </a:extLst>
           </p:cNvPr>
@@ -8605,7 +8605,7 @@
           <p:cNvPr id="3" name="">
             <a:extLst xmlns:a="http://schemas.openxmlformats.org/drawingml/2006/main">
               <a:ext uri="{FF2B5EF4-FFF2-40B4-BE49-F238E27FC236}">
-                <a16:creationId xmlns:a16="http://schemas.microsoft.com/office/drawing/2014/main" id="{C1E83FD9-5F04-4784-8006-B8C962DAB82E}"/>
+                <a16:creationId xmlns:a16="http://schemas.microsoft.com/office/drawing/2014/main" id="{2D4AA3D2-779A-4690-ADE3-7B0DDDEFB187}"/>
               </a:ext>
             </a:extLst>
           </p:cNvPr>
@@ -8636,7 +8636,7 @@
           <p:cNvPr id="4" name="">
             <a:extLst xmlns:a="http://schemas.openxmlformats.org/drawingml/2006/main">
               <a:ext uri="{FF2B5EF4-FFF2-40B4-BE49-F238E27FC236}">
-                <a16:creationId xmlns:a16="http://schemas.microsoft.com/office/drawing/2014/main" id="{5D66D426-868B-4C20-8D00-17BD81C54D66}"/>
+                <a16:creationId xmlns:a16="http://schemas.microsoft.com/office/drawing/2014/main" id="{F29A307C-3506-4452-9A24-0C369F0C9437}"/>
               </a:ext>
             </a:extLst>
           </p:cNvPr>
@@ -8681,7 +8681,7 @@
           <p:cNvPr id="5" name="">
             <a:extLst xmlns:a="http://schemas.openxmlformats.org/drawingml/2006/main">
               <a:ext uri="{FF2B5EF4-FFF2-40B4-BE49-F238E27FC236}">
-                <a16:creationId xmlns:a16="http://schemas.microsoft.com/office/drawing/2014/main" id="{2887AEE2-B829-4FA6-9B38-0B5981EC4878}"/>
+                <a16:creationId xmlns:a16="http://schemas.microsoft.com/office/drawing/2014/main" id="{922EBE82-0125-4EC0-A62D-91B4742EFDB5}"/>
               </a:ext>
             </a:extLst>
           </p:cNvPr>
@@ -8712,7 +8712,7 @@
           <p:cNvPr id="6" name="">
             <a:extLst xmlns:a="http://schemas.openxmlformats.org/drawingml/2006/main">
               <a:ext uri="{FF2B5EF4-FFF2-40B4-BE49-F238E27FC236}">
-                <a16:creationId xmlns:a16="http://schemas.microsoft.com/office/drawing/2014/main" id="{FE5F76F1-37D0-4F2D-B58A-335E90EB3797}"/>
+                <a16:creationId xmlns:a16="http://schemas.microsoft.com/office/drawing/2014/main" id="{3630C72F-4507-458B-9EB2-EAA09CB04D2C}"/>
               </a:ext>
             </a:extLst>
           </p:cNvPr>
@@ -8757,7 +8757,7 @@
           <p:cNvPr id="7" name="">
             <a:extLst xmlns:a="http://schemas.openxmlformats.org/drawingml/2006/main">
               <a:ext uri="{FF2B5EF4-FFF2-40B4-BE49-F238E27FC236}">
-                <a16:creationId xmlns:a16="http://schemas.microsoft.com/office/drawing/2014/main" id="{A386DBAE-B6F8-4DA7-9AED-18B0051E0173}"/>
+                <a16:creationId xmlns:a16="http://schemas.microsoft.com/office/drawing/2014/main" id="{EE4D8C0A-A957-4DBB-96EE-79A57BEA7AB5}"/>
               </a:ext>
             </a:extLst>
           </p:cNvPr>
@@ -8802,7 +8802,7 @@
           <p:cNvPr id="8" name="">
             <a:extLst xmlns:a="http://schemas.openxmlformats.org/drawingml/2006/main">
               <a:ext uri="{FF2B5EF4-FFF2-40B4-BE49-F238E27FC236}">
-                <a16:creationId xmlns:a16="http://schemas.microsoft.com/office/drawing/2014/main" id="{8702924D-1C17-4C17-B4F1-D25AB2695E02}"/>
+                <a16:creationId xmlns:a16="http://schemas.microsoft.com/office/drawing/2014/main" id="{743E44B8-47CF-47DB-8ACB-190256A085DF}"/>
               </a:ext>
             </a:extLst>
           </p:cNvPr>
@@ -8847,7 +8847,7 @@
           <p:cNvPr id="9" name="">
             <a:extLst xmlns:a="http://schemas.openxmlformats.org/drawingml/2006/main">
               <a:ext uri="{FF2B5EF4-FFF2-40B4-BE49-F238E27FC236}">
-                <a16:creationId xmlns:a16="http://schemas.microsoft.com/office/drawing/2014/main" id="{38E0AE39-2959-41CC-AD9A-080C44478A0B}"/>
+                <a16:creationId xmlns:a16="http://schemas.microsoft.com/office/drawing/2014/main" id="{5F5F5C06-9606-4966-A557-D947535E01A3}"/>
               </a:ext>
             </a:extLst>
           </p:cNvPr>
@@ -8892,7 +8892,7 @@
           <p:cNvPr id="10" name="">
             <a:extLst xmlns:a="http://schemas.openxmlformats.org/drawingml/2006/main">
               <a:ext uri="{FF2B5EF4-FFF2-40B4-BE49-F238E27FC236}">
-                <a16:creationId xmlns:a16="http://schemas.microsoft.com/office/drawing/2014/main" id="{8148A287-9BF4-40BC-80D4-89FA4901A4F8}"/>
+                <a16:creationId xmlns:a16="http://schemas.microsoft.com/office/drawing/2014/main" id="{41A353F3-F66F-43C4-9888-072EA007FC6B}"/>
               </a:ext>
             </a:extLst>
           </p:cNvPr>
@@ -8937,7 +8937,7 @@
           <p:cNvPr id="11" name="">
             <a:extLst xmlns:a="http://schemas.openxmlformats.org/drawingml/2006/main">
               <a:ext uri="{FF2B5EF4-FFF2-40B4-BE49-F238E27FC236}">
-                <a16:creationId xmlns:a16="http://schemas.microsoft.com/office/drawing/2014/main" id="{07B695A2-032C-4B33-A6AC-B9E0F2CD5C9E}"/>
+                <a16:creationId xmlns:a16="http://schemas.microsoft.com/office/drawing/2014/main" id="{6BB3838F-D9C7-487F-A05D-E7368003A919}"/>
               </a:ext>
             </a:extLst>
           </p:cNvPr>
@@ -8982,7 +8982,7 @@
           <p:cNvPr id="12" name="">
             <a:extLst xmlns:a="http://schemas.openxmlformats.org/drawingml/2006/main">
               <a:ext uri="{FF2B5EF4-FFF2-40B4-BE49-F238E27FC236}">
-                <a16:creationId xmlns:a16="http://schemas.microsoft.com/office/drawing/2014/main" id="{48EAF321-6F0E-42DC-A0FF-82E12A02EBEA}"/>
+                <a16:creationId xmlns:a16="http://schemas.microsoft.com/office/drawing/2014/main" id="{BD5C0F61-CB9F-4B1A-9625-39CB02399B29}"/>
               </a:ext>
             </a:extLst>
           </p:cNvPr>
@@ -9011,7 +9011,7 @@
           <p:cNvPr id="13" name="">
             <a:extLst xmlns:a="http://schemas.openxmlformats.org/drawingml/2006/main">
               <a:ext uri="{FF2B5EF4-FFF2-40B4-BE49-F238E27FC236}">
-                <a16:creationId xmlns:a16="http://schemas.microsoft.com/office/drawing/2014/main" id="{C981CA27-467A-4944-A803-A4EFFB156E53}"/>
+                <a16:creationId xmlns:a16="http://schemas.microsoft.com/office/drawing/2014/main" id="{0AA33253-2E05-4F1B-A32A-0097FA866E06}"/>
               </a:ext>
             </a:extLst>
           </p:cNvPr>
@@ -9056,7 +9056,7 @@
           <p:cNvPr id="14" name="">
             <a:extLst xmlns:a="http://schemas.openxmlformats.org/drawingml/2006/main">
               <a:ext uri="{FF2B5EF4-FFF2-40B4-BE49-F238E27FC236}">
-                <a16:creationId xmlns:a16="http://schemas.microsoft.com/office/drawing/2014/main" id="{6EF21756-BBB6-491F-B780-812D1433B75B}"/>
+                <a16:creationId xmlns:a16="http://schemas.microsoft.com/office/drawing/2014/main" id="{ED1CBDA4-CDF2-40F5-A381-698E78F501C4}"/>
               </a:ext>
             </a:extLst>
           </p:cNvPr>
@@ -9087,7 +9087,7 @@
           <p:cNvPr id="15" name="">
             <a:extLst xmlns:a="http://schemas.openxmlformats.org/drawingml/2006/main">
               <a:ext uri="{FF2B5EF4-FFF2-40B4-BE49-F238E27FC236}">
-                <a16:creationId xmlns:a16="http://schemas.microsoft.com/office/drawing/2014/main" id="{00EBEB38-BCF4-4035-BE8E-0DFF022D12A0}"/>
+                <a16:creationId xmlns:a16="http://schemas.microsoft.com/office/drawing/2014/main" id="{8E862242-D2A7-4D03-AEA7-DD22B471A6A9}"/>
               </a:ext>
             </a:extLst>
           </p:cNvPr>
@@ -9132,7 +9132,7 @@
           <p:cNvPr id="16" name="">
             <a:extLst xmlns:a="http://schemas.openxmlformats.org/drawingml/2006/main">
               <a:ext uri="{FF2B5EF4-FFF2-40B4-BE49-F238E27FC236}">
-                <a16:creationId xmlns:a16="http://schemas.microsoft.com/office/drawing/2014/main" id="{29A88C55-138B-4A7A-86B9-2EF87BD7142E}"/>
+                <a16:creationId xmlns:a16="http://schemas.microsoft.com/office/drawing/2014/main" id="{550D9402-A752-4B78-9B20-7EF38918F087}"/>
               </a:ext>
             </a:extLst>
           </p:cNvPr>
@@ -9177,7 +9177,7 @@
           <p:cNvPr id="17" name="">
             <a:extLst xmlns:a="http://schemas.openxmlformats.org/drawingml/2006/main">
               <a:ext uri="{FF2B5EF4-FFF2-40B4-BE49-F238E27FC236}">
-                <a16:creationId xmlns:a16="http://schemas.microsoft.com/office/drawing/2014/main" id="{964BDB1F-B7BA-4705-A2B1-BA593AC916AA}"/>
+                <a16:creationId xmlns:a16="http://schemas.microsoft.com/office/drawing/2014/main" id="{290AC4DB-A72E-4C00-A4E3-DDDFB2A39CC2}"/>
               </a:ext>
             </a:extLst>
           </p:cNvPr>
@@ -9208,7 +9208,7 @@
           <p:cNvPr id="18" name="">
             <a:extLst xmlns:a="http://schemas.openxmlformats.org/drawingml/2006/main">
               <a:ext uri="{FF2B5EF4-FFF2-40B4-BE49-F238E27FC236}">
-                <a16:creationId xmlns:a16="http://schemas.microsoft.com/office/drawing/2014/main" id="{188D33C8-A4DB-4129-B353-22548981152A}"/>
+                <a16:creationId xmlns:a16="http://schemas.microsoft.com/office/drawing/2014/main" id="{6F2B1903-445D-49EF-819B-4C588F01EB6A}"/>
               </a:ext>
             </a:extLst>
           </p:cNvPr>
@@ -9253,7 +9253,7 @@
           <p:cNvPr id="19" name="">
             <a:extLst xmlns:a="http://schemas.openxmlformats.org/drawingml/2006/main">
               <a:ext uri="{FF2B5EF4-FFF2-40B4-BE49-F238E27FC236}">
-                <a16:creationId xmlns:a16="http://schemas.microsoft.com/office/drawing/2014/main" id="{3E4ACE13-8BD1-4F57-B251-EEB7589D6F10}"/>
+                <a16:creationId xmlns:a16="http://schemas.microsoft.com/office/drawing/2014/main" id="{22E63F5E-5165-4384-9884-F99816C3F735}"/>
               </a:ext>
             </a:extLst>
           </p:cNvPr>
@@ -9298,7 +9298,7 @@
           <p:cNvPr id="20" name="">
             <a:extLst xmlns:a="http://schemas.openxmlformats.org/drawingml/2006/main">
               <a:ext uri="{FF2B5EF4-FFF2-40B4-BE49-F238E27FC236}">
-                <a16:creationId xmlns:a16="http://schemas.microsoft.com/office/drawing/2014/main" id="{D004BC8E-C209-4724-A174-BBC1F21195DA}"/>
+                <a16:creationId xmlns:a16="http://schemas.microsoft.com/office/drawing/2014/main" id="{28116E2D-FA78-4039-B7E5-44BE214ED045}"/>
               </a:ext>
             </a:extLst>
           </p:cNvPr>
@@ -9329,7 +9329,7 @@
           <p:cNvPr id="21" name="">
             <a:extLst xmlns:a="http://schemas.openxmlformats.org/drawingml/2006/main">
               <a:ext uri="{FF2B5EF4-FFF2-40B4-BE49-F238E27FC236}">
-                <a16:creationId xmlns:a16="http://schemas.microsoft.com/office/drawing/2014/main" id="{23D533E7-5652-4553-ACD9-27672B4AB852}"/>
+                <a16:creationId xmlns:a16="http://schemas.microsoft.com/office/drawing/2014/main" id="{A94E214D-580D-4535-AA8C-DA905354EA7B}"/>
               </a:ext>
             </a:extLst>
           </p:cNvPr>
@@ -9374,7 +9374,7 @@
           <p:cNvPr id="22" name="">
             <a:extLst xmlns:a="http://schemas.openxmlformats.org/drawingml/2006/main">
               <a:ext uri="{FF2B5EF4-FFF2-40B4-BE49-F238E27FC236}">
-                <a16:creationId xmlns:a16="http://schemas.microsoft.com/office/drawing/2014/main" id="{1B377D5E-A438-4927-882C-74D8D652C2A9}"/>
+                <a16:creationId xmlns:a16="http://schemas.microsoft.com/office/drawing/2014/main" id="{6D8B23CB-9959-40A5-AC0B-57BF207EDA69}"/>
               </a:ext>
             </a:extLst>
           </p:cNvPr>
@@ -9419,7 +9419,7 @@
           <p:cNvPr id="23" name="">
             <a:extLst xmlns:a="http://schemas.openxmlformats.org/drawingml/2006/main">
               <a:ext uri="{FF2B5EF4-FFF2-40B4-BE49-F238E27FC236}">
-                <a16:creationId xmlns:a16="http://schemas.microsoft.com/office/drawing/2014/main" id="{5435A015-5D2C-4CD7-8A07-9BA9A5658AB5}"/>
+                <a16:creationId xmlns:a16="http://schemas.microsoft.com/office/drawing/2014/main" id="{99393C04-38F4-4176-9A17-6D16CC1DF3B4}"/>
               </a:ext>
             </a:extLst>
           </p:cNvPr>
@@ -9450,7 +9450,7 @@
           <p:cNvPr id="24" name="">
             <a:extLst xmlns:a="http://schemas.openxmlformats.org/drawingml/2006/main">
               <a:ext uri="{FF2B5EF4-FFF2-40B4-BE49-F238E27FC236}">
-                <a16:creationId xmlns:a16="http://schemas.microsoft.com/office/drawing/2014/main" id="{ACFB887C-CFEC-4EE2-A88A-B8D01BC8140D}"/>
+                <a16:creationId xmlns:a16="http://schemas.microsoft.com/office/drawing/2014/main" id="{B491D97B-723F-4A8A-8ED1-A9B0F129327F}"/>
               </a:ext>
             </a:extLst>
           </p:cNvPr>
@@ -9495,7 +9495,7 @@
           <p:cNvPr id="25" name="">
             <a:extLst xmlns:a="http://schemas.openxmlformats.org/drawingml/2006/main">
               <a:ext uri="{FF2B5EF4-FFF2-40B4-BE49-F238E27FC236}">
-                <a16:creationId xmlns:a16="http://schemas.microsoft.com/office/drawing/2014/main" id="{6A9A144F-0389-4907-8B4D-296999BB1ADE}"/>
+                <a16:creationId xmlns:a16="http://schemas.microsoft.com/office/drawing/2014/main" id="{C936D1F1-CD4F-4C02-8D8C-D8CC58CA5A27}"/>
               </a:ext>
             </a:extLst>
           </p:cNvPr>
@@ -9540,7 +9540,7 @@
           <p:cNvPr id="26" name="">
             <a:extLst xmlns:a="http://schemas.openxmlformats.org/drawingml/2006/main">
               <a:ext uri="{FF2B5EF4-FFF2-40B4-BE49-F238E27FC236}">
-                <a16:creationId xmlns:a16="http://schemas.microsoft.com/office/drawing/2014/main" id="{E8A664A1-0E7E-4E57-ACF6-9A67D2F66073}"/>
+                <a16:creationId xmlns:a16="http://schemas.microsoft.com/office/drawing/2014/main" id="{8307D4B2-ECD1-4049-B93D-7446F31927F1}"/>
               </a:ext>
             </a:extLst>
           </p:cNvPr>
@@ -9571,7 +9571,7 @@
           <p:cNvPr id="27" name="">
             <a:extLst xmlns:a="http://schemas.openxmlformats.org/drawingml/2006/main">
               <a:ext uri="{FF2B5EF4-FFF2-40B4-BE49-F238E27FC236}">
-                <a16:creationId xmlns:a16="http://schemas.microsoft.com/office/drawing/2014/main" id="{A406B10F-2EEA-432C-8A9A-0A3598C05431}"/>
+                <a16:creationId xmlns:a16="http://schemas.microsoft.com/office/drawing/2014/main" id="{00247CEC-6B8B-455A-A58A-71BDEC31629C}"/>
               </a:ext>
             </a:extLst>
           </p:cNvPr>
@@ -9616,7 +9616,7 @@
           <p:cNvPr id="28" name="">
             <a:extLst xmlns:a="http://schemas.openxmlformats.org/drawingml/2006/main">
               <a:ext uri="{FF2B5EF4-FFF2-40B4-BE49-F238E27FC236}">
-                <a16:creationId xmlns:a16="http://schemas.microsoft.com/office/drawing/2014/main" id="{214188D9-0DAC-4B76-90AA-FCCADB8652BF}"/>
+                <a16:creationId xmlns:a16="http://schemas.microsoft.com/office/drawing/2014/main" id="{3511950F-87E4-4713-A19C-77EBF71B8588}"/>
               </a:ext>
             </a:extLst>
           </p:cNvPr>
@@ -9661,7 +9661,7 @@
           <p:cNvPr id="29" name="">
             <a:extLst xmlns:a="http://schemas.openxmlformats.org/drawingml/2006/main">
               <a:ext uri="{FF2B5EF4-FFF2-40B4-BE49-F238E27FC236}">
-                <a16:creationId xmlns:a16="http://schemas.microsoft.com/office/drawing/2014/main" id="{52E50EE3-9F2A-44D5-8A2E-3FB2151598E9}"/>
+                <a16:creationId xmlns:a16="http://schemas.microsoft.com/office/drawing/2014/main" id="{7111C6BA-83C9-4316-914C-4E74A834828F}"/>
               </a:ext>
             </a:extLst>
           </p:cNvPr>
@@ -9706,7 +9706,7 @@
           <p:cNvPr id="30" name="">
             <a:extLst xmlns:a="http://schemas.openxmlformats.org/drawingml/2006/main">
               <a:ext uri="{FF2B5EF4-FFF2-40B4-BE49-F238E27FC236}">
-                <a16:creationId xmlns:a16="http://schemas.microsoft.com/office/drawing/2014/main" id="{C00A850C-1313-41A0-9AC9-1D5A30605290}"/>
+                <a16:creationId xmlns:a16="http://schemas.microsoft.com/office/drawing/2014/main" id="{EF00DF07-D0E3-46E3-9569-60568E9E8B57}"/>
               </a:ext>
             </a:extLst>
           </p:cNvPr>
@@ -9749,7 +9749,7 @@
     </p:spTree>
     <p:extLst>
       <p:ext uri="{BB962C8B-B14F-4D97-AF65-F5344CB8AC3E}">
-        <p14:creationId xmlns:p14="http://schemas.microsoft.com/office/powerpoint/2010/main" val="936666850"/>
+        <p14:creationId xmlns:p14="http://schemas.microsoft.com/office/powerpoint/2010/main" val="1775652823"/>
       </p:ext>
     </p:extLst>
   </p:cSld>
@@ -9773,7 +9773,7 @@
           <p:cNvPr id="1" name="bg">
             <a:extLst xmlns:a="http://schemas.openxmlformats.org/drawingml/2006/main">
               <a:ext uri="{FF2B5EF4-FFF2-40B4-BE49-F238E27FC236}">
-                <a16:creationId xmlns:a16="http://schemas.microsoft.com/office/drawing/2014/main" id="{10AD20D8-E31D-468B-B70B-574C4DD80047}"/>
+                <a16:creationId xmlns:a16="http://schemas.microsoft.com/office/drawing/2014/main" id="{074272B4-40B2-4437-A6EC-4C5A2F2B681E}"/>
               </a:ext>
             </a:extLst>
           </p:cNvPr>
@@ -9800,7 +9800,7 @@
           <p:cNvPr id="2" name="top-field">
             <a:extLst xmlns:a="http://schemas.openxmlformats.org/drawingml/2006/main">
               <a:ext uri="{FF2B5EF4-FFF2-40B4-BE49-F238E27FC236}">
-                <a16:creationId xmlns:a16="http://schemas.microsoft.com/office/drawing/2014/main" id="{D76F10CC-A137-4628-8B1C-E99F60A3F85A}"/>
+                <a16:creationId xmlns:a16="http://schemas.microsoft.com/office/drawing/2014/main" id="{549C19F1-0782-4CB5-B921-D6CF1685718F}"/>
               </a:ext>
             </a:extLst>
           </p:cNvPr>
@@ -9827,7 +9827,7 @@
           <p:cNvPr id="3" name="">
             <a:extLst xmlns:a="http://schemas.openxmlformats.org/drawingml/2006/main">
               <a:ext uri="{FF2B5EF4-FFF2-40B4-BE49-F238E27FC236}">
-                <a16:creationId xmlns:a16="http://schemas.microsoft.com/office/drawing/2014/main" id="{36E4A109-F11D-4116-A31E-DB4A60B23283}"/>
+                <a16:creationId xmlns:a16="http://schemas.microsoft.com/office/drawing/2014/main" id="{5CCB85DC-6BCF-4DA8-AE6D-CA217C4081F1}"/>
               </a:ext>
             </a:extLst>
           </p:cNvPr>
@@ -9858,7 +9858,7 @@
           <p:cNvPr id="4" name="">
             <a:extLst xmlns:a="http://schemas.openxmlformats.org/drawingml/2006/main">
               <a:ext uri="{FF2B5EF4-FFF2-40B4-BE49-F238E27FC236}">
-                <a16:creationId xmlns:a16="http://schemas.microsoft.com/office/drawing/2014/main" id="{C11EC908-5CAB-495B-ACC1-C81061310827}"/>
+                <a16:creationId xmlns:a16="http://schemas.microsoft.com/office/drawing/2014/main" id="{D0D4C91F-033B-4CC6-B977-3E865E019C6D}"/>
               </a:ext>
             </a:extLst>
           </p:cNvPr>
@@ -9903,7 +9903,7 @@
           <p:cNvPr id="5" name="">
             <a:extLst xmlns:a="http://schemas.openxmlformats.org/drawingml/2006/main">
               <a:ext uri="{FF2B5EF4-FFF2-40B4-BE49-F238E27FC236}">
-                <a16:creationId xmlns:a16="http://schemas.microsoft.com/office/drawing/2014/main" id="{4CF2C9B1-53DB-4F0B-BD15-40D59C263817}"/>
+                <a16:creationId xmlns:a16="http://schemas.microsoft.com/office/drawing/2014/main" id="{54FEA2F9-1757-4F55-9A43-2B4CB5C1AC40}"/>
               </a:ext>
             </a:extLst>
           </p:cNvPr>
@@ -9934,7 +9934,7 @@
           <p:cNvPr id="6" name="">
             <a:extLst xmlns:a="http://schemas.openxmlformats.org/drawingml/2006/main">
               <a:ext uri="{FF2B5EF4-FFF2-40B4-BE49-F238E27FC236}">
-                <a16:creationId xmlns:a16="http://schemas.microsoft.com/office/drawing/2014/main" id="{D90F848D-97F0-4CAD-B4AC-1197EAD84BCB}"/>
+                <a16:creationId xmlns:a16="http://schemas.microsoft.com/office/drawing/2014/main" id="{AC7FA013-707A-4F82-80DF-3DDC988C286E}"/>
               </a:ext>
             </a:extLst>
           </p:cNvPr>
@@ -9979,7 +9979,7 @@
           <p:cNvPr id="7" name="">
             <a:extLst xmlns:a="http://schemas.openxmlformats.org/drawingml/2006/main">
               <a:ext uri="{FF2B5EF4-FFF2-40B4-BE49-F238E27FC236}">
-                <a16:creationId xmlns:a16="http://schemas.microsoft.com/office/drawing/2014/main" id="{3A4B8B10-7D93-45F3-856B-6F556D7BA02B}"/>
+                <a16:creationId xmlns:a16="http://schemas.microsoft.com/office/drawing/2014/main" id="{7195591C-B38B-4C8C-A9BF-3F0CF2B5C2D8}"/>
               </a:ext>
             </a:extLst>
           </p:cNvPr>
@@ -10024,7 +10024,7 @@
           <p:cNvPr id="8" name="">
             <a:extLst xmlns:a="http://schemas.openxmlformats.org/drawingml/2006/main">
               <a:ext uri="{FF2B5EF4-FFF2-40B4-BE49-F238E27FC236}">
-                <a16:creationId xmlns:a16="http://schemas.microsoft.com/office/drawing/2014/main" id="{1FD0E0EE-6B80-4EE1-9A13-A8908682A692}"/>
+                <a16:creationId xmlns:a16="http://schemas.microsoft.com/office/drawing/2014/main" id="{98219A7A-5919-42EB-B3AA-E39F7B75AD6A}"/>
               </a:ext>
             </a:extLst>
           </p:cNvPr>
@@ -10069,7 +10069,7 @@
           <p:cNvPr id="9" name="">
             <a:extLst xmlns:a="http://schemas.openxmlformats.org/drawingml/2006/main">
               <a:ext uri="{FF2B5EF4-FFF2-40B4-BE49-F238E27FC236}">
-                <a16:creationId xmlns:a16="http://schemas.microsoft.com/office/drawing/2014/main" id="{5B3D295A-FF84-4605-81F9-8928BED8230F}"/>
+                <a16:creationId xmlns:a16="http://schemas.microsoft.com/office/drawing/2014/main" id="{626C27D3-3A32-4164-9824-78200FAA41FA}"/>
               </a:ext>
             </a:extLst>
           </p:cNvPr>
@@ -10114,7 +10114,7 @@
           <p:cNvPr id="10" name="">
             <a:extLst xmlns:a="http://schemas.openxmlformats.org/drawingml/2006/main">
               <a:ext uri="{FF2B5EF4-FFF2-40B4-BE49-F238E27FC236}">
-                <a16:creationId xmlns:a16="http://schemas.microsoft.com/office/drawing/2014/main" id="{AF6F8A7C-C194-425E-9C28-E9E15A6B518F}"/>
+                <a16:creationId xmlns:a16="http://schemas.microsoft.com/office/drawing/2014/main" id="{3B144004-7381-4C12-A9C6-483FF53B769D}"/>
               </a:ext>
             </a:extLst>
           </p:cNvPr>
@@ -10143,7 +10143,7 @@
           <p:cNvPr id="11" name="">
             <a:extLst xmlns:a="http://schemas.openxmlformats.org/drawingml/2006/main">
               <a:ext uri="{FF2B5EF4-FFF2-40B4-BE49-F238E27FC236}">
-                <a16:creationId xmlns:a16="http://schemas.microsoft.com/office/drawing/2014/main" id="{B5105979-3309-4E0D-900B-F2F8811E0481}"/>
+                <a16:creationId xmlns:a16="http://schemas.microsoft.com/office/drawing/2014/main" id="{7ECCA044-AD2F-477B-B4E9-21ECAE8B0139}"/>
               </a:ext>
             </a:extLst>
           </p:cNvPr>
@@ -10188,7 +10188,7 @@
           <p:cNvPr id="12" name="">
             <a:extLst xmlns:a="http://schemas.openxmlformats.org/drawingml/2006/main">
               <a:ext uri="{FF2B5EF4-FFF2-40B4-BE49-F238E27FC236}">
-                <a16:creationId xmlns:a16="http://schemas.microsoft.com/office/drawing/2014/main" id="{C34A302B-22C1-4B20-989A-174585FE0F3C}"/>
+                <a16:creationId xmlns:a16="http://schemas.microsoft.com/office/drawing/2014/main" id="{AD6025F5-816A-49C9-B20D-453046BEB887}"/>
               </a:ext>
             </a:extLst>
           </p:cNvPr>
@@ -10233,7 +10233,7 @@
           <p:cNvPr id="13" name="">
             <a:extLst xmlns:a="http://schemas.openxmlformats.org/drawingml/2006/main">
               <a:ext uri="{FF2B5EF4-FFF2-40B4-BE49-F238E27FC236}">
-                <a16:creationId xmlns:a16="http://schemas.microsoft.com/office/drawing/2014/main" id="{DD15BE14-2313-443E-BD0C-1250CF5FD7A7}"/>
+                <a16:creationId xmlns:a16="http://schemas.microsoft.com/office/drawing/2014/main" id="{05F595E4-F667-425A-9F38-00B53DC61FF6}"/>
               </a:ext>
             </a:extLst>
           </p:cNvPr>
@@ -10266,7 +10266,7 @@
           <p:cNvPr id="14" name="">
             <a:extLst xmlns:a="http://schemas.openxmlformats.org/drawingml/2006/main">
               <a:ext uri="{FF2B5EF4-FFF2-40B4-BE49-F238E27FC236}">
-                <a16:creationId xmlns:a16="http://schemas.microsoft.com/office/drawing/2014/main" id="{AAC2433F-9A56-441F-9141-B8816188B232}"/>
+                <a16:creationId xmlns:a16="http://schemas.microsoft.com/office/drawing/2014/main" id="{6D06C8CD-EE03-47DE-B51C-956F1D12A369}"/>
               </a:ext>
             </a:extLst>
           </p:cNvPr>
@@ -10311,7 +10311,7 @@
           <p:cNvPr id="15" name="">
             <a:extLst xmlns:a="http://schemas.openxmlformats.org/drawingml/2006/main">
               <a:ext uri="{FF2B5EF4-FFF2-40B4-BE49-F238E27FC236}">
-                <a16:creationId xmlns:a16="http://schemas.microsoft.com/office/drawing/2014/main" id="{7CA16769-0AD8-470A-A099-1E3984F4BE25}"/>
+                <a16:creationId xmlns:a16="http://schemas.microsoft.com/office/drawing/2014/main" id="{7F21B0D4-3A19-4851-95B8-900C84B11561}"/>
               </a:ext>
             </a:extLst>
           </p:cNvPr>
@@ -10340,7 +10340,7 @@
           <p:cNvPr id="16" name="">
             <a:extLst xmlns:a="http://schemas.openxmlformats.org/drawingml/2006/main">
               <a:ext uri="{FF2B5EF4-FFF2-40B4-BE49-F238E27FC236}">
-                <a16:creationId xmlns:a16="http://schemas.microsoft.com/office/drawing/2014/main" id="{825BE7B7-F05D-43D9-812E-EC3C8414661D}"/>
+                <a16:creationId xmlns:a16="http://schemas.microsoft.com/office/drawing/2014/main" id="{92B13998-999D-43FB-AE7A-8DE257457B58}"/>
               </a:ext>
             </a:extLst>
           </p:cNvPr>
@@ -10385,7 +10385,7 @@
           <p:cNvPr id="17" name="">
             <a:extLst xmlns:a="http://schemas.openxmlformats.org/drawingml/2006/main">
               <a:ext uri="{FF2B5EF4-FFF2-40B4-BE49-F238E27FC236}">
-                <a16:creationId xmlns:a16="http://schemas.microsoft.com/office/drawing/2014/main" id="{82D1CB35-E104-487C-A482-DC23E19DFFC3}"/>
+                <a16:creationId xmlns:a16="http://schemas.microsoft.com/office/drawing/2014/main" id="{4939DC23-892C-4EBA-A336-E7C6F33A9395}"/>
               </a:ext>
             </a:extLst>
           </p:cNvPr>
@@ -10430,7 +10430,7 @@
           <p:cNvPr id="18" name="">
             <a:extLst xmlns:a="http://schemas.openxmlformats.org/drawingml/2006/main">
               <a:ext uri="{FF2B5EF4-FFF2-40B4-BE49-F238E27FC236}">
-                <a16:creationId xmlns:a16="http://schemas.microsoft.com/office/drawing/2014/main" id="{9D332C5F-E9FD-478C-B2E1-95F50EA029A8}"/>
+                <a16:creationId xmlns:a16="http://schemas.microsoft.com/office/drawing/2014/main" id="{FD25339F-984D-4DC8-A9D2-4453711581B1}"/>
               </a:ext>
             </a:extLst>
           </p:cNvPr>
@@ -10463,7 +10463,7 @@
           <p:cNvPr id="19" name="">
             <a:extLst xmlns:a="http://schemas.openxmlformats.org/drawingml/2006/main">
               <a:ext uri="{FF2B5EF4-FFF2-40B4-BE49-F238E27FC236}">
-                <a16:creationId xmlns:a16="http://schemas.microsoft.com/office/drawing/2014/main" id="{837DEF1D-C5B4-4B68-BEB5-97A79B58D073}"/>
+                <a16:creationId xmlns:a16="http://schemas.microsoft.com/office/drawing/2014/main" id="{A95600EB-A96E-4453-93FA-9143E2C26297}"/>
               </a:ext>
             </a:extLst>
           </p:cNvPr>
@@ -10508,7 +10508,7 @@
           <p:cNvPr id="20" name="">
             <a:extLst xmlns:a="http://schemas.openxmlformats.org/drawingml/2006/main">
               <a:ext uri="{FF2B5EF4-FFF2-40B4-BE49-F238E27FC236}">
-                <a16:creationId xmlns:a16="http://schemas.microsoft.com/office/drawing/2014/main" id="{BA9FBB03-6442-4C2C-BB11-E83BFDC47C9F}"/>
+                <a16:creationId xmlns:a16="http://schemas.microsoft.com/office/drawing/2014/main" id="{DF9CE13C-B6A1-43AA-AA60-4391067DFB07}"/>
               </a:ext>
             </a:extLst>
           </p:cNvPr>
@@ -10537,7 +10537,7 @@
           <p:cNvPr id="21" name="">
             <a:extLst xmlns:a="http://schemas.openxmlformats.org/drawingml/2006/main">
               <a:ext uri="{FF2B5EF4-FFF2-40B4-BE49-F238E27FC236}">
-                <a16:creationId xmlns:a16="http://schemas.microsoft.com/office/drawing/2014/main" id="{8EF5933A-D2F3-44CB-A2B4-F34BE60E82CD}"/>
+                <a16:creationId xmlns:a16="http://schemas.microsoft.com/office/drawing/2014/main" id="{336E5CA7-7F17-4779-9116-9D09497162E8}"/>
               </a:ext>
             </a:extLst>
           </p:cNvPr>
@@ -10582,7 +10582,7 @@
           <p:cNvPr id="22" name="">
             <a:extLst xmlns:a="http://schemas.openxmlformats.org/drawingml/2006/main">
               <a:ext uri="{FF2B5EF4-FFF2-40B4-BE49-F238E27FC236}">
-                <a16:creationId xmlns:a16="http://schemas.microsoft.com/office/drawing/2014/main" id="{05A95A94-4ECB-4697-9E95-2FD3A466D77A}"/>
+                <a16:creationId xmlns:a16="http://schemas.microsoft.com/office/drawing/2014/main" id="{8EA01D36-2FE5-4251-9ECE-66FFC565D877}"/>
               </a:ext>
             </a:extLst>
           </p:cNvPr>
@@ -10627,7 +10627,7 @@
           <p:cNvPr id="23" name="">
             <a:extLst xmlns:a="http://schemas.openxmlformats.org/drawingml/2006/main">
               <a:ext uri="{FF2B5EF4-FFF2-40B4-BE49-F238E27FC236}">
-                <a16:creationId xmlns:a16="http://schemas.microsoft.com/office/drawing/2014/main" id="{63491C0E-D288-4CA8-AADF-92D5D21E7FB3}"/>
+                <a16:creationId xmlns:a16="http://schemas.microsoft.com/office/drawing/2014/main" id="{D08F43BD-8F2D-4EB9-92BE-176EC962E288}"/>
               </a:ext>
             </a:extLst>
           </p:cNvPr>
@@ -10660,7 +10660,7 @@
           <p:cNvPr id="24" name="">
             <a:extLst xmlns:a="http://schemas.openxmlformats.org/drawingml/2006/main">
               <a:ext uri="{FF2B5EF4-FFF2-40B4-BE49-F238E27FC236}">
-                <a16:creationId xmlns:a16="http://schemas.microsoft.com/office/drawing/2014/main" id="{C4338A9F-BB6A-440D-ADCD-BFA34F49EBC9}"/>
+                <a16:creationId xmlns:a16="http://schemas.microsoft.com/office/drawing/2014/main" id="{0CEA531B-33B6-4240-8643-71B849B8BD2B}"/>
               </a:ext>
             </a:extLst>
           </p:cNvPr>
@@ -10705,7 +10705,7 @@
           <p:cNvPr id="25" name="">
             <a:extLst xmlns:a="http://schemas.openxmlformats.org/drawingml/2006/main">
               <a:ext uri="{FF2B5EF4-FFF2-40B4-BE49-F238E27FC236}">
-                <a16:creationId xmlns:a16="http://schemas.microsoft.com/office/drawing/2014/main" id="{FE44F4A1-CE77-412B-B10C-CDF2464C8B28}"/>
+                <a16:creationId xmlns:a16="http://schemas.microsoft.com/office/drawing/2014/main" id="{B33EA327-78BA-4159-AD06-87C66036073F}"/>
               </a:ext>
             </a:extLst>
           </p:cNvPr>
@@ -10734,7 +10734,7 @@
           <p:cNvPr id="26" name="">
             <a:extLst xmlns:a="http://schemas.openxmlformats.org/drawingml/2006/main">
               <a:ext uri="{FF2B5EF4-FFF2-40B4-BE49-F238E27FC236}">
-                <a16:creationId xmlns:a16="http://schemas.microsoft.com/office/drawing/2014/main" id="{13F235FD-8833-475F-9147-D64920EEE2B3}"/>
+                <a16:creationId xmlns:a16="http://schemas.microsoft.com/office/drawing/2014/main" id="{D9CA3D06-E321-4798-8E37-D20DFDC59C25}"/>
               </a:ext>
             </a:extLst>
           </p:cNvPr>
@@ -10779,7 +10779,7 @@
           <p:cNvPr id="27" name="">
             <a:extLst xmlns:a="http://schemas.openxmlformats.org/drawingml/2006/main">
               <a:ext uri="{FF2B5EF4-FFF2-40B4-BE49-F238E27FC236}">
-                <a16:creationId xmlns:a16="http://schemas.microsoft.com/office/drawing/2014/main" id="{35311B3C-3DF1-4D04-969A-0429DD82A18D}"/>
+                <a16:creationId xmlns:a16="http://schemas.microsoft.com/office/drawing/2014/main" id="{61070AF4-D06C-428D-B8AD-CCA4CA9019FE}"/>
               </a:ext>
             </a:extLst>
           </p:cNvPr>
@@ -10824,7 +10824,7 @@
           <p:cNvPr id="28" name="">
             <a:extLst xmlns:a="http://schemas.openxmlformats.org/drawingml/2006/main">
               <a:ext uri="{FF2B5EF4-FFF2-40B4-BE49-F238E27FC236}">
-                <a16:creationId xmlns:a16="http://schemas.microsoft.com/office/drawing/2014/main" id="{218F4954-E402-4CE7-B60A-574CE139F25B}"/>
+                <a16:creationId xmlns:a16="http://schemas.microsoft.com/office/drawing/2014/main" id="{8E8F49C8-B2B8-4FB4-9DC4-687E902036D7}"/>
               </a:ext>
             </a:extLst>
           </p:cNvPr>
@@ -10857,7 +10857,7 @@
           <p:cNvPr id="29" name="">
             <a:extLst xmlns:a="http://schemas.openxmlformats.org/drawingml/2006/main">
               <a:ext uri="{FF2B5EF4-FFF2-40B4-BE49-F238E27FC236}">
-                <a16:creationId xmlns:a16="http://schemas.microsoft.com/office/drawing/2014/main" id="{462C015D-E6EB-4B9E-B3EB-9B423E40CD9E}"/>
+                <a16:creationId xmlns:a16="http://schemas.microsoft.com/office/drawing/2014/main" id="{D2165FFA-5817-4130-BE7E-EAF066D6E8FA}"/>
               </a:ext>
             </a:extLst>
           </p:cNvPr>
@@ -10902,7 +10902,7 @@
           <p:cNvPr id="30" name="">
             <a:extLst xmlns:a="http://schemas.openxmlformats.org/drawingml/2006/main">
               <a:ext uri="{FF2B5EF4-FFF2-40B4-BE49-F238E27FC236}">
-                <a16:creationId xmlns:a16="http://schemas.microsoft.com/office/drawing/2014/main" id="{ECA3F062-56ED-4AC0-ACED-2B1E13AD692B}"/>
+                <a16:creationId xmlns:a16="http://schemas.microsoft.com/office/drawing/2014/main" id="{AA8BFBCC-B192-4145-AA8F-D2D14FFA3419}"/>
               </a:ext>
             </a:extLst>
           </p:cNvPr>
@@ -10947,7 +10947,7 @@
           <p:cNvPr id="31" name="">
             <a:extLst xmlns:a="http://schemas.openxmlformats.org/drawingml/2006/main">
               <a:ext uri="{FF2B5EF4-FFF2-40B4-BE49-F238E27FC236}">
-                <a16:creationId xmlns:a16="http://schemas.microsoft.com/office/drawing/2014/main" id="{C6AA2C4B-62F4-4830-A53B-839B2EF8E26A}"/>
+                <a16:creationId xmlns:a16="http://schemas.microsoft.com/office/drawing/2014/main" id="{4980BC8B-D606-4C01-A64B-A1A0F21C89B9}"/>
               </a:ext>
             </a:extLst>
           </p:cNvPr>
@@ -10990,7 +10990,7 @@
     </p:spTree>
     <p:extLst>
       <p:ext uri="{BB962C8B-B14F-4D97-AF65-F5344CB8AC3E}">
-        <p14:creationId xmlns:p14="http://schemas.microsoft.com/office/powerpoint/2010/main" val="805933855"/>
+        <p14:creationId xmlns:p14="http://schemas.microsoft.com/office/powerpoint/2010/main" val="1415641341"/>
       </p:ext>
     </p:extLst>
   </p:cSld>
@@ -11014,7 +11014,7 @@
           <p:cNvPr id="1" name="bg">
             <a:extLst xmlns:a="http://schemas.openxmlformats.org/drawingml/2006/main">
               <a:ext uri="{FF2B5EF4-FFF2-40B4-BE49-F238E27FC236}">
-                <a16:creationId xmlns:a16="http://schemas.microsoft.com/office/drawing/2014/main" id="{FFAA3F74-8F64-4A5E-A54A-F6ED6FD4D453}"/>
+                <a16:creationId xmlns:a16="http://schemas.microsoft.com/office/drawing/2014/main" id="{EC0BDFB3-4518-43B8-BC7D-6E6F02C7082F}"/>
               </a:ext>
             </a:extLst>
           </p:cNvPr>
@@ -11041,7 +11041,7 @@
           <p:cNvPr id="2" name="top-field">
             <a:extLst xmlns:a="http://schemas.openxmlformats.org/drawingml/2006/main">
               <a:ext uri="{FF2B5EF4-FFF2-40B4-BE49-F238E27FC236}">
-                <a16:creationId xmlns:a16="http://schemas.microsoft.com/office/drawing/2014/main" id="{5BB9B2B8-FA00-4E3C-9981-5CC05800397F}"/>
+                <a16:creationId xmlns:a16="http://schemas.microsoft.com/office/drawing/2014/main" id="{75B05E13-3165-475A-968F-34D1B09C16F4}"/>
               </a:ext>
             </a:extLst>
           </p:cNvPr>
@@ -11068,7 +11068,7 @@
           <p:cNvPr id="3" name="">
             <a:extLst xmlns:a="http://schemas.openxmlformats.org/drawingml/2006/main">
               <a:ext uri="{FF2B5EF4-FFF2-40B4-BE49-F238E27FC236}">
-                <a16:creationId xmlns:a16="http://schemas.microsoft.com/office/drawing/2014/main" id="{E856AB2E-C9DE-4617-ACD5-E007A0DD5E79}"/>
+                <a16:creationId xmlns:a16="http://schemas.microsoft.com/office/drawing/2014/main" id="{A6C5D5E1-FE54-4C05-A669-F78EA902C612}"/>
               </a:ext>
             </a:extLst>
           </p:cNvPr>
@@ -11099,7 +11099,7 @@
           <p:cNvPr id="4" name="">
             <a:extLst xmlns:a="http://schemas.openxmlformats.org/drawingml/2006/main">
               <a:ext uri="{FF2B5EF4-FFF2-40B4-BE49-F238E27FC236}">
-                <a16:creationId xmlns:a16="http://schemas.microsoft.com/office/drawing/2014/main" id="{3EF0D687-12A0-435F-91FA-1FC91AEE4D78}"/>
+                <a16:creationId xmlns:a16="http://schemas.microsoft.com/office/drawing/2014/main" id="{1F00DD1B-D13D-4406-BE27-B5C9E3D9CE99}"/>
               </a:ext>
             </a:extLst>
           </p:cNvPr>
@@ -11144,7 +11144,7 @@
           <p:cNvPr id="5" name="">
             <a:extLst xmlns:a="http://schemas.openxmlformats.org/drawingml/2006/main">
               <a:ext uri="{FF2B5EF4-FFF2-40B4-BE49-F238E27FC236}">
-                <a16:creationId xmlns:a16="http://schemas.microsoft.com/office/drawing/2014/main" id="{6CF6BA7D-44BD-41EF-89E3-F669201688B7}"/>
+                <a16:creationId xmlns:a16="http://schemas.microsoft.com/office/drawing/2014/main" id="{3CFCE0CA-0E40-4A42-8F41-56DB79F7B10F}"/>
               </a:ext>
             </a:extLst>
           </p:cNvPr>
@@ -11175,7 +11175,7 @@
           <p:cNvPr id="6" name="">
             <a:extLst xmlns:a="http://schemas.openxmlformats.org/drawingml/2006/main">
               <a:ext uri="{FF2B5EF4-FFF2-40B4-BE49-F238E27FC236}">
-                <a16:creationId xmlns:a16="http://schemas.microsoft.com/office/drawing/2014/main" id="{17ACB0ED-D7FE-42C6-B610-402889FF3DF4}"/>
+                <a16:creationId xmlns:a16="http://schemas.microsoft.com/office/drawing/2014/main" id="{570426EA-DE3F-4E7C-B0B5-85C102D2451A}"/>
               </a:ext>
             </a:extLst>
           </p:cNvPr>
@@ -11220,7 +11220,7 @@
           <p:cNvPr id="7" name="">
             <a:extLst xmlns:a="http://schemas.openxmlformats.org/drawingml/2006/main">
               <a:ext uri="{FF2B5EF4-FFF2-40B4-BE49-F238E27FC236}">
-                <a16:creationId xmlns:a16="http://schemas.microsoft.com/office/drawing/2014/main" id="{297A3AA0-EC96-4AED-B07D-3FCEE266098D}"/>
+                <a16:creationId xmlns:a16="http://schemas.microsoft.com/office/drawing/2014/main" id="{01A39FBA-CE64-417A-A6AC-C794F281C589}"/>
               </a:ext>
             </a:extLst>
           </p:cNvPr>
@@ -11265,7 +11265,7 @@
           <p:cNvPr id="8" name="">
             <a:extLst xmlns:a="http://schemas.openxmlformats.org/drawingml/2006/main">
               <a:ext uri="{FF2B5EF4-FFF2-40B4-BE49-F238E27FC236}">
-                <a16:creationId xmlns:a16="http://schemas.microsoft.com/office/drawing/2014/main" id="{FBCDE0CC-816E-4301-AABD-4392BACBAC77}"/>
+                <a16:creationId xmlns:a16="http://schemas.microsoft.com/office/drawing/2014/main" id="{9D1E93BB-8713-4080-A996-624B0129B5E9}"/>
               </a:ext>
             </a:extLst>
           </p:cNvPr>
@@ -11310,7 +11310,7 @@
           <p:cNvPr id="9" name="">
             <a:extLst xmlns:a="http://schemas.openxmlformats.org/drawingml/2006/main">
               <a:ext uri="{FF2B5EF4-FFF2-40B4-BE49-F238E27FC236}">
-                <a16:creationId xmlns:a16="http://schemas.microsoft.com/office/drawing/2014/main" id="{D660FE63-61E7-4D32-AD76-F2E51777A5A0}"/>
+                <a16:creationId xmlns:a16="http://schemas.microsoft.com/office/drawing/2014/main" id="{36117C8A-F11C-474D-9175-F9B63D71D640}"/>
               </a:ext>
             </a:extLst>
           </p:cNvPr>
@@ -11355,7 +11355,7 @@
           <p:cNvPr id="10" name="">
             <a:extLst xmlns:a="http://schemas.openxmlformats.org/drawingml/2006/main">
               <a:ext uri="{FF2B5EF4-FFF2-40B4-BE49-F238E27FC236}">
-                <a16:creationId xmlns:a16="http://schemas.microsoft.com/office/drawing/2014/main" id="{8ABE3181-584A-4A5C-B239-B23A647ED64F}"/>
+                <a16:creationId xmlns:a16="http://schemas.microsoft.com/office/drawing/2014/main" id="{8CB5C0A3-7D27-4A66-88FC-9F16D058FBFB}"/>
               </a:ext>
             </a:extLst>
           </p:cNvPr>
@@ -11400,7 +11400,7 @@
           <p:cNvPr id="11" name="">
             <a:extLst xmlns:a="http://schemas.openxmlformats.org/drawingml/2006/main">
               <a:ext uri="{FF2B5EF4-FFF2-40B4-BE49-F238E27FC236}">
-                <a16:creationId xmlns:a16="http://schemas.microsoft.com/office/drawing/2014/main" id="{4D9647A0-E749-4EBE-86F0-353EE16CBF65}"/>
+                <a16:creationId xmlns:a16="http://schemas.microsoft.com/office/drawing/2014/main" id="{64EF835A-2A92-44FF-881B-9B68B3CBA774}"/>
               </a:ext>
             </a:extLst>
           </p:cNvPr>
@@ -11445,7 +11445,7 @@
           <p:cNvPr id="12" name="">
             <a:extLst xmlns:a="http://schemas.openxmlformats.org/drawingml/2006/main">
               <a:ext uri="{FF2B5EF4-FFF2-40B4-BE49-F238E27FC236}">
-                <a16:creationId xmlns:a16="http://schemas.microsoft.com/office/drawing/2014/main" id="{C933A833-6147-4C54-92E8-37D7B620D324}"/>
+                <a16:creationId xmlns:a16="http://schemas.microsoft.com/office/drawing/2014/main" id="{E89010AC-14E5-4D08-AC61-A539C2C4BC72}"/>
               </a:ext>
             </a:extLst>
           </p:cNvPr>
@@ -11490,7 +11490,7 @@
           <p:cNvPr id="13" name="">
             <a:extLst xmlns:a="http://schemas.openxmlformats.org/drawingml/2006/main">
               <a:ext uri="{FF2B5EF4-FFF2-40B4-BE49-F238E27FC236}">
-                <a16:creationId xmlns:a16="http://schemas.microsoft.com/office/drawing/2014/main" id="{82018646-FA03-4C5F-B15D-4932E3812344}"/>
+                <a16:creationId xmlns:a16="http://schemas.microsoft.com/office/drawing/2014/main" id="{CCC968D2-A438-4120-AD08-77A4E83167EE}"/>
               </a:ext>
             </a:extLst>
           </p:cNvPr>
@@ -11535,7 +11535,7 @@
           <p:cNvPr id="14" name="">
             <a:extLst xmlns:a="http://schemas.openxmlformats.org/drawingml/2006/main">
               <a:ext uri="{FF2B5EF4-FFF2-40B4-BE49-F238E27FC236}">
-                <a16:creationId xmlns:a16="http://schemas.microsoft.com/office/drawing/2014/main" id="{6D1DEA05-419C-4C6A-9B87-00D8AFA3304C}"/>
+                <a16:creationId xmlns:a16="http://schemas.microsoft.com/office/drawing/2014/main" id="{5AFE6AF9-CCB1-4870-8A5E-9D65643D6369}"/>
               </a:ext>
             </a:extLst>
           </p:cNvPr>
@@ -11580,7 +11580,7 @@
           <p:cNvPr id="15" name="">
             <a:extLst xmlns:a="http://schemas.openxmlformats.org/drawingml/2006/main">
               <a:ext uri="{FF2B5EF4-FFF2-40B4-BE49-F238E27FC236}">
-                <a16:creationId xmlns:a16="http://schemas.microsoft.com/office/drawing/2014/main" id="{27BE4001-5FBF-4A64-9B46-9E77F35FDE4F}"/>
+                <a16:creationId xmlns:a16="http://schemas.microsoft.com/office/drawing/2014/main" id="{B8AB3545-8A91-4AD4-9C27-5ABD4C8A094A}"/>
               </a:ext>
             </a:extLst>
           </p:cNvPr>
@@ -11625,7 +11625,7 @@
           <p:cNvPr id="16" name="">
             <a:extLst xmlns:a="http://schemas.openxmlformats.org/drawingml/2006/main">
               <a:ext uri="{FF2B5EF4-FFF2-40B4-BE49-F238E27FC236}">
-                <a16:creationId xmlns:a16="http://schemas.microsoft.com/office/drawing/2014/main" id="{7D801858-4D20-4226-8CFF-E3B0E6350820}"/>
+                <a16:creationId xmlns:a16="http://schemas.microsoft.com/office/drawing/2014/main" id="{AFF89E25-F581-4700-BAFF-2F9EE38098AE}"/>
               </a:ext>
             </a:extLst>
           </p:cNvPr>
@@ -11670,7 +11670,7 @@
           <p:cNvPr id="17" name="">
             <a:extLst xmlns:a="http://schemas.openxmlformats.org/drawingml/2006/main">
               <a:ext uri="{FF2B5EF4-FFF2-40B4-BE49-F238E27FC236}">
-                <a16:creationId xmlns:a16="http://schemas.microsoft.com/office/drawing/2014/main" id="{C815E76A-235B-487D-AE41-3787A7ED5573}"/>
+                <a16:creationId xmlns:a16="http://schemas.microsoft.com/office/drawing/2014/main" id="{D3EB0704-9586-4588-9238-226AD0682FDA}"/>
               </a:ext>
             </a:extLst>
           </p:cNvPr>
@@ -11715,7 +11715,7 @@
           <p:cNvPr id="18" name="">
             <a:extLst xmlns:a="http://schemas.openxmlformats.org/drawingml/2006/main">
               <a:ext uri="{FF2B5EF4-FFF2-40B4-BE49-F238E27FC236}">
-                <a16:creationId xmlns:a16="http://schemas.microsoft.com/office/drawing/2014/main" id="{8B9C39B7-06B4-40B0-98AB-B2C162969F24}"/>
+                <a16:creationId xmlns:a16="http://schemas.microsoft.com/office/drawing/2014/main" id="{8786137D-EA56-40E2-A67D-0085C3E9340C}"/>
               </a:ext>
             </a:extLst>
           </p:cNvPr>
@@ -11760,7 +11760,7 @@
           <p:cNvPr id="19" name="">
             <a:extLst xmlns:a="http://schemas.openxmlformats.org/drawingml/2006/main">
               <a:ext uri="{FF2B5EF4-FFF2-40B4-BE49-F238E27FC236}">
-                <a16:creationId xmlns:a16="http://schemas.microsoft.com/office/drawing/2014/main" id="{785D2C0F-1B73-4F6B-8920-C6D384E2D95B}"/>
+                <a16:creationId xmlns:a16="http://schemas.microsoft.com/office/drawing/2014/main" id="{1F985FF6-1649-4D54-8878-3B340D97C93E}"/>
               </a:ext>
             </a:extLst>
           </p:cNvPr>
@@ -11805,7 +11805,7 @@
           <p:cNvPr id="20" name="">
             <a:extLst xmlns:a="http://schemas.openxmlformats.org/drawingml/2006/main">
               <a:ext uri="{FF2B5EF4-FFF2-40B4-BE49-F238E27FC236}">
-                <a16:creationId xmlns:a16="http://schemas.microsoft.com/office/drawing/2014/main" id="{84DBC044-A84E-4833-97B1-EB750B5C7D87}"/>
+                <a16:creationId xmlns:a16="http://schemas.microsoft.com/office/drawing/2014/main" id="{2430D695-07CF-466A-ADF8-40AEBE6B2CBB}"/>
               </a:ext>
             </a:extLst>
           </p:cNvPr>
@@ -11850,7 +11850,7 @@
           <p:cNvPr id="21" name="">
             <a:extLst xmlns:a="http://schemas.openxmlformats.org/drawingml/2006/main">
               <a:ext uri="{FF2B5EF4-FFF2-40B4-BE49-F238E27FC236}">
-                <a16:creationId xmlns:a16="http://schemas.microsoft.com/office/drawing/2014/main" id="{8BCB1705-4740-49B4-B78E-AA183CF3D69F}"/>
+                <a16:creationId xmlns:a16="http://schemas.microsoft.com/office/drawing/2014/main" id="{F52A6C07-0920-4F48-AEF5-1FA9E332AD77}"/>
               </a:ext>
             </a:extLst>
           </p:cNvPr>
@@ -11895,7 +11895,7 @@
           <p:cNvPr id="22" name="">
             <a:extLst xmlns:a="http://schemas.openxmlformats.org/drawingml/2006/main">
               <a:ext uri="{FF2B5EF4-FFF2-40B4-BE49-F238E27FC236}">
-                <a16:creationId xmlns:a16="http://schemas.microsoft.com/office/drawing/2014/main" id="{70BA6682-B4A1-48A4-B9F4-832DDB135CF7}"/>
+                <a16:creationId xmlns:a16="http://schemas.microsoft.com/office/drawing/2014/main" id="{D524810D-88B4-4868-B0CD-94C99687F6F6}"/>
               </a:ext>
             </a:extLst>
           </p:cNvPr>
@@ -11940,7 +11940,7 @@
           <p:cNvPr id="23" name="">
             <a:extLst xmlns:a="http://schemas.openxmlformats.org/drawingml/2006/main">
               <a:ext uri="{FF2B5EF4-FFF2-40B4-BE49-F238E27FC236}">
-                <a16:creationId xmlns:a16="http://schemas.microsoft.com/office/drawing/2014/main" id="{2329AD12-E373-4FFF-ABB9-616BB01CA556}"/>
+                <a16:creationId xmlns:a16="http://schemas.microsoft.com/office/drawing/2014/main" id="{A73AE6E3-3E41-4C7D-A88B-F0631E7407AF}"/>
               </a:ext>
             </a:extLst>
           </p:cNvPr>
@@ -11985,7 +11985,7 @@
           <p:cNvPr id="24" name="">
             <a:extLst xmlns:a="http://schemas.openxmlformats.org/drawingml/2006/main">
               <a:ext uri="{FF2B5EF4-FFF2-40B4-BE49-F238E27FC236}">
-                <a16:creationId xmlns:a16="http://schemas.microsoft.com/office/drawing/2014/main" id="{6EB035F2-9830-4AED-B653-1D950A424966}"/>
+                <a16:creationId xmlns:a16="http://schemas.microsoft.com/office/drawing/2014/main" id="{022EF443-837C-4C12-8508-2D5CCF622BE3}"/>
               </a:ext>
             </a:extLst>
           </p:cNvPr>
@@ -12030,7 +12030,7 @@
           <p:cNvPr id="25" name="">
             <a:extLst xmlns:a="http://schemas.openxmlformats.org/drawingml/2006/main">
               <a:ext uri="{FF2B5EF4-FFF2-40B4-BE49-F238E27FC236}">
-                <a16:creationId xmlns:a16="http://schemas.microsoft.com/office/drawing/2014/main" id="{BB9FE80A-6039-4F46-A348-D8C8FFD3E294}"/>
+                <a16:creationId xmlns:a16="http://schemas.microsoft.com/office/drawing/2014/main" id="{78D333AA-0105-4BD3-A2D5-294FFE91EFEE}"/>
               </a:ext>
             </a:extLst>
           </p:cNvPr>
@@ -12073,7 +12073,7 @@
     </p:spTree>
     <p:extLst>
       <p:ext uri="{BB962C8B-B14F-4D97-AF65-F5344CB8AC3E}">
-        <p14:creationId xmlns:p14="http://schemas.microsoft.com/office/powerpoint/2010/main" val="1549254838"/>
+        <p14:creationId xmlns:p14="http://schemas.microsoft.com/office/powerpoint/2010/main" val="2026067593"/>
       </p:ext>
     </p:extLst>
   </p:cSld>
@@ -12097,7 +12097,7 @@
           <p:cNvPr id="1" name="bg">
             <a:extLst xmlns:a="http://schemas.openxmlformats.org/drawingml/2006/main">
               <a:ext uri="{FF2B5EF4-FFF2-40B4-BE49-F238E27FC236}">
-                <a16:creationId xmlns:a16="http://schemas.microsoft.com/office/drawing/2014/main" id="{3CF80600-C966-4FF5-89CC-7CF07F43D4DC}"/>
+                <a16:creationId xmlns:a16="http://schemas.microsoft.com/office/drawing/2014/main" id="{52E60E10-D57D-4E6F-B237-99ADF58ED8E4}"/>
               </a:ext>
             </a:extLst>
           </p:cNvPr>
@@ -12124,7 +12124,7 @@
           <p:cNvPr id="2" name="top-field">
             <a:extLst xmlns:a="http://schemas.openxmlformats.org/drawingml/2006/main">
               <a:ext uri="{FF2B5EF4-FFF2-40B4-BE49-F238E27FC236}">
-                <a16:creationId xmlns:a16="http://schemas.microsoft.com/office/drawing/2014/main" id="{6D5344BB-CF93-45DC-A48F-C074148D3B8E}"/>
+                <a16:creationId xmlns:a16="http://schemas.microsoft.com/office/drawing/2014/main" id="{F730A628-6657-4E7C-A887-69DEE3430255}"/>
               </a:ext>
             </a:extLst>
           </p:cNvPr>
@@ -12151,7 +12151,7 @@
           <p:cNvPr id="3" name="">
             <a:extLst xmlns:a="http://schemas.openxmlformats.org/drawingml/2006/main">
               <a:ext uri="{FF2B5EF4-FFF2-40B4-BE49-F238E27FC236}">
-                <a16:creationId xmlns:a16="http://schemas.microsoft.com/office/drawing/2014/main" id="{CEF88023-4AF1-4574-88E5-98BFDF64E3E0}"/>
+                <a16:creationId xmlns:a16="http://schemas.microsoft.com/office/drawing/2014/main" id="{31848743-67E8-4CF6-B261-A5B249B89AE7}"/>
               </a:ext>
             </a:extLst>
           </p:cNvPr>
@@ -12182,7 +12182,7 @@
           <p:cNvPr id="4" name="">
             <a:extLst xmlns:a="http://schemas.openxmlformats.org/drawingml/2006/main">
               <a:ext uri="{FF2B5EF4-FFF2-40B4-BE49-F238E27FC236}">
-                <a16:creationId xmlns:a16="http://schemas.microsoft.com/office/drawing/2014/main" id="{C37A1647-A790-4755-90C5-0A83AAA6E2E6}"/>
+                <a16:creationId xmlns:a16="http://schemas.microsoft.com/office/drawing/2014/main" id="{3EBDC5C8-474D-4F27-BE46-0AB843BA75A8}"/>
               </a:ext>
             </a:extLst>
           </p:cNvPr>
@@ -12227,7 +12227,7 @@
           <p:cNvPr id="5" name="">
             <a:extLst xmlns:a="http://schemas.openxmlformats.org/drawingml/2006/main">
               <a:ext uri="{FF2B5EF4-FFF2-40B4-BE49-F238E27FC236}">
-                <a16:creationId xmlns:a16="http://schemas.microsoft.com/office/drawing/2014/main" id="{DE56BA60-9FBD-4121-8BCD-8DB6155C24BE}"/>
+                <a16:creationId xmlns:a16="http://schemas.microsoft.com/office/drawing/2014/main" id="{58F526E9-B872-4899-A14F-32143CC09905}"/>
               </a:ext>
             </a:extLst>
           </p:cNvPr>
@@ -12258,7 +12258,7 @@
           <p:cNvPr id="6" name="">
             <a:extLst xmlns:a="http://schemas.openxmlformats.org/drawingml/2006/main">
               <a:ext uri="{FF2B5EF4-FFF2-40B4-BE49-F238E27FC236}">
-                <a16:creationId xmlns:a16="http://schemas.microsoft.com/office/drawing/2014/main" id="{637DD7C6-BA4F-4328-953A-E4B285F916D9}"/>
+                <a16:creationId xmlns:a16="http://schemas.microsoft.com/office/drawing/2014/main" id="{D377B75C-60BD-4D85-B6CC-8FD6B95A95EC}"/>
               </a:ext>
             </a:extLst>
           </p:cNvPr>
@@ -12303,7 +12303,7 @@
           <p:cNvPr id="7" name="">
             <a:extLst xmlns:a="http://schemas.openxmlformats.org/drawingml/2006/main">
               <a:ext uri="{FF2B5EF4-FFF2-40B4-BE49-F238E27FC236}">
-                <a16:creationId xmlns:a16="http://schemas.microsoft.com/office/drawing/2014/main" id="{F6DBA8F5-1DFA-4068-9AFF-BAD22EFCFE2B}"/>
+                <a16:creationId xmlns:a16="http://schemas.microsoft.com/office/drawing/2014/main" id="{58DFE537-63B2-48C3-90CA-8452F824539B}"/>
               </a:ext>
             </a:extLst>
           </p:cNvPr>
@@ -12348,7 +12348,7 @@
           <p:cNvPr id="8" name="">
             <a:extLst xmlns:a="http://schemas.openxmlformats.org/drawingml/2006/main">
               <a:ext uri="{FF2B5EF4-FFF2-40B4-BE49-F238E27FC236}">
-                <a16:creationId xmlns:a16="http://schemas.microsoft.com/office/drawing/2014/main" id="{38EBA2D5-8D6F-4840-AB46-0195234A323F}"/>
+                <a16:creationId xmlns:a16="http://schemas.microsoft.com/office/drawing/2014/main" id="{DB0C53FB-A17D-445E-B179-DBE53021602C}"/>
               </a:ext>
             </a:extLst>
           </p:cNvPr>
@@ -12393,7 +12393,7 @@
           <p:cNvPr id="9" name="">
             <a:extLst xmlns:a="http://schemas.openxmlformats.org/drawingml/2006/main">
               <a:ext uri="{FF2B5EF4-FFF2-40B4-BE49-F238E27FC236}">
-                <a16:creationId xmlns:a16="http://schemas.microsoft.com/office/drawing/2014/main" id="{5EF7F733-5C95-4334-BB25-04FE1E0238F6}"/>
+                <a16:creationId xmlns:a16="http://schemas.microsoft.com/office/drawing/2014/main" id="{331434AB-B44F-46F6-A664-1174A5D72030}"/>
               </a:ext>
             </a:extLst>
           </p:cNvPr>
@@ -12438,7 +12438,7 @@
           <p:cNvPr id="10" name="">
             <a:extLst xmlns:a="http://schemas.openxmlformats.org/drawingml/2006/main">
               <a:ext uri="{FF2B5EF4-FFF2-40B4-BE49-F238E27FC236}">
-                <a16:creationId xmlns:a16="http://schemas.microsoft.com/office/drawing/2014/main" id="{BD47AADC-46E4-4347-9E1F-3EA9712B5747}"/>
+                <a16:creationId xmlns:a16="http://schemas.microsoft.com/office/drawing/2014/main" id="{68C39CC0-0552-4416-9121-297495BE83B4}"/>
               </a:ext>
             </a:extLst>
           </p:cNvPr>
@@ -12483,7 +12483,7 @@
           <p:cNvPr id="11" name="">
             <a:extLst xmlns:a="http://schemas.openxmlformats.org/drawingml/2006/main">
               <a:ext uri="{FF2B5EF4-FFF2-40B4-BE49-F238E27FC236}">
-                <a16:creationId xmlns:a16="http://schemas.microsoft.com/office/drawing/2014/main" id="{9477CB91-684F-45CA-9370-67AA9A7B2A87}"/>
+                <a16:creationId xmlns:a16="http://schemas.microsoft.com/office/drawing/2014/main" id="{DB43F75D-A3FE-4752-BB4B-A36C3E4F8F90}"/>
               </a:ext>
             </a:extLst>
           </p:cNvPr>
@@ -12528,7 +12528,7 @@
           <p:cNvPr id="12" name="">
             <a:extLst xmlns:a="http://schemas.openxmlformats.org/drawingml/2006/main">
               <a:ext uri="{FF2B5EF4-FFF2-40B4-BE49-F238E27FC236}">
-                <a16:creationId xmlns:a16="http://schemas.microsoft.com/office/drawing/2014/main" id="{1ECDEA53-4D74-45AD-A3C5-F879D5A607AE}"/>
+                <a16:creationId xmlns:a16="http://schemas.microsoft.com/office/drawing/2014/main" id="{5BF85A21-BAF1-4938-A848-651680F88FA8}"/>
               </a:ext>
             </a:extLst>
           </p:cNvPr>
@@ -12557,7 +12557,7 @@
           <p:cNvPr id="13" name="">
             <a:extLst xmlns:a="http://schemas.openxmlformats.org/drawingml/2006/main">
               <a:ext uri="{FF2B5EF4-FFF2-40B4-BE49-F238E27FC236}">
-                <a16:creationId xmlns:a16="http://schemas.microsoft.com/office/drawing/2014/main" id="{6CC19C0C-0377-4CE9-9FC6-FE050A84248D}"/>
+                <a16:creationId xmlns:a16="http://schemas.microsoft.com/office/drawing/2014/main" id="{373F08F4-D3CB-44D2-85B4-EE1338864C9A}"/>
               </a:ext>
             </a:extLst>
           </p:cNvPr>
@@ -12602,7 +12602,7 @@
           <p:cNvPr id="14" name="">
             <a:extLst xmlns:a="http://schemas.openxmlformats.org/drawingml/2006/main">
               <a:ext uri="{FF2B5EF4-FFF2-40B4-BE49-F238E27FC236}">
-                <a16:creationId xmlns:a16="http://schemas.microsoft.com/office/drawing/2014/main" id="{DF1EF693-D39C-4478-87DC-93B9170C7C29}"/>
+                <a16:creationId xmlns:a16="http://schemas.microsoft.com/office/drawing/2014/main" id="{3FC13740-D4C9-40EE-9D65-D4A396762998}"/>
               </a:ext>
             </a:extLst>
           </p:cNvPr>
@@ -12647,7 +12647,7 @@
           <p:cNvPr id="15" name="">
             <a:extLst xmlns:a="http://schemas.openxmlformats.org/drawingml/2006/main">
               <a:ext uri="{FF2B5EF4-FFF2-40B4-BE49-F238E27FC236}">
-                <a16:creationId xmlns:a16="http://schemas.microsoft.com/office/drawing/2014/main" id="{9E8A6EEC-6053-46CA-B666-A311F473DD19}"/>
+                <a16:creationId xmlns:a16="http://schemas.microsoft.com/office/drawing/2014/main" id="{A8400EF4-B582-48FC-9406-46B92E5179C5}"/>
               </a:ext>
             </a:extLst>
           </p:cNvPr>
@@ -12676,7 +12676,7 @@
           <p:cNvPr id="16" name="">
             <a:extLst xmlns:a="http://schemas.openxmlformats.org/drawingml/2006/main">
               <a:ext uri="{FF2B5EF4-FFF2-40B4-BE49-F238E27FC236}">
-                <a16:creationId xmlns:a16="http://schemas.microsoft.com/office/drawing/2014/main" id="{DFF07B3A-81F0-4EFC-8631-9317FAD0753D}"/>
+                <a16:creationId xmlns:a16="http://schemas.microsoft.com/office/drawing/2014/main" id="{2C7C59C8-C7C0-40EB-A487-4975F0FA4889}"/>
               </a:ext>
             </a:extLst>
           </p:cNvPr>
@@ -12721,7 +12721,7 @@
           <p:cNvPr id="17" name="">
             <a:extLst xmlns:a="http://schemas.openxmlformats.org/drawingml/2006/main">
               <a:ext uri="{FF2B5EF4-FFF2-40B4-BE49-F238E27FC236}">
-                <a16:creationId xmlns:a16="http://schemas.microsoft.com/office/drawing/2014/main" id="{939F034B-58C3-420B-86F0-52E110F9156F}"/>
+                <a16:creationId xmlns:a16="http://schemas.microsoft.com/office/drawing/2014/main" id="{8EDEC512-F00A-4068-B2B8-7F7477C65D0D}"/>
               </a:ext>
             </a:extLst>
           </p:cNvPr>
@@ -12766,7 +12766,7 @@
           <p:cNvPr id="18" name="">
             <a:extLst xmlns:a="http://schemas.openxmlformats.org/drawingml/2006/main">
               <a:ext uri="{FF2B5EF4-FFF2-40B4-BE49-F238E27FC236}">
-                <a16:creationId xmlns:a16="http://schemas.microsoft.com/office/drawing/2014/main" id="{AB2ABB33-7F07-4385-8D90-4C72C5CFB145}"/>
+                <a16:creationId xmlns:a16="http://schemas.microsoft.com/office/drawing/2014/main" id="{B4D064B7-0711-4193-942C-F425D7C7A8B1}"/>
               </a:ext>
             </a:extLst>
           </p:cNvPr>
@@ -12795,7 +12795,7 @@
           <p:cNvPr id="19" name="">
             <a:extLst xmlns:a="http://schemas.openxmlformats.org/drawingml/2006/main">
               <a:ext uri="{FF2B5EF4-FFF2-40B4-BE49-F238E27FC236}">
-                <a16:creationId xmlns:a16="http://schemas.microsoft.com/office/drawing/2014/main" id="{2DEA51B1-23B7-4F02-9FD9-EE9191F2C658}"/>
+                <a16:creationId xmlns:a16="http://schemas.microsoft.com/office/drawing/2014/main" id="{CC7E8E68-415F-4BEB-A389-88415741AC91}"/>
               </a:ext>
             </a:extLst>
           </p:cNvPr>
@@ -12840,7 +12840,7 @@
           <p:cNvPr id="20" name="">
             <a:extLst xmlns:a="http://schemas.openxmlformats.org/drawingml/2006/main">
               <a:ext uri="{FF2B5EF4-FFF2-40B4-BE49-F238E27FC236}">
-                <a16:creationId xmlns:a16="http://schemas.microsoft.com/office/drawing/2014/main" id="{2979B16D-2F8F-4C41-9D27-16C1D0A9A910}"/>
+                <a16:creationId xmlns:a16="http://schemas.microsoft.com/office/drawing/2014/main" id="{04455C83-7E24-401C-8D4B-054698D0F0E8}"/>
               </a:ext>
             </a:extLst>
           </p:cNvPr>
@@ -12885,7 +12885,7 @@
           <p:cNvPr id="21" name="">
             <a:extLst xmlns:a="http://schemas.openxmlformats.org/drawingml/2006/main">
               <a:ext uri="{FF2B5EF4-FFF2-40B4-BE49-F238E27FC236}">
-                <a16:creationId xmlns:a16="http://schemas.microsoft.com/office/drawing/2014/main" id="{22CA078F-C892-4764-AAA8-EC87D9FAC9AD}"/>
+                <a16:creationId xmlns:a16="http://schemas.microsoft.com/office/drawing/2014/main" id="{07ED6EDC-C6BA-4192-8295-2462D304549D}"/>
               </a:ext>
             </a:extLst>
           </p:cNvPr>
@@ -12914,7 +12914,7 @@
           <p:cNvPr id="22" name="">
             <a:extLst xmlns:a="http://schemas.openxmlformats.org/drawingml/2006/main">
               <a:ext uri="{FF2B5EF4-FFF2-40B4-BE49-F238E27FC236}">
-                <a16:creationId xmlns:a16="http://schemas.microsoft.com/office/drawing/2014/main" id="{982CA877-0A67-497B-8496-BDEC837D8F41}"/>
+                <a16:creationId xmlns:a16="http://schemas.microsoft.com/office/drawing/2014/main" id="{7E6F2848-BD05-4F6C-8C1A-A0122A317F56}"/>
               </a:ext>
             </a:extLst>
           </p:cNvPr>
@@ -12959,7 +12959,7 @@
           <p:cNvPr id="23" name="">
             <a:extLst xmlns:a="http://schemas.openxmlformats.org/drawingml/2006/main">
               <a:ext uri="{FF2B5EF4-FFF2-40B4-BE49-F238E27FC236}">
-                <a16:creationId xmlns:a16="http://schemas.microsoft.com/office/drawing/2014/main" id="{FCB00711-3D0D-40A3-8A0A-35E0E338954E}"/>
+                <a16:creationId xmlns:a16="http://schemas.microsoft.com/office/drawing/2014/main" id="{F3D72E8C-56F1-49FE-A9FE-D0EAE0685A7A}"/>
               </a:ext>
             </a:extLst>
           </p:cNvPr>
@@ -13004,7 +13004,7 @@
           <p:cNvPr id="24" name="">
             <a:extLst xmlns:a="http://schemas.openxmlformats.org/drawingml/2006/main">
               <a:ext uri="{FF2B5EF4-FFF2-40B4-BE49-F238E27FC236}">
-                <a16:creationId xmlns:a16="http://schemas.microsoft.com/office/drawing/2014/main" id="{00A5EFCE-18D1-4D80-92BF-C49DA23E0860}"/>
+                <a16:creationId xmlns:a16="http://schemas.microsoft.com/office/drawing/2014/main" id="{EBEF0E78-D86B-4104-90C5-3EDB3988FD3A}"/>
               </a:ext>
             </a:extLst>
           </p:cNvPr>
@@ -13033,7 +13033,7 @@
           <p:cNvPr id="25" name="">
             <a:extLst xmlns:a="http://schemas.openxmlformats.org/drawingml/2006/main">
               <a:ext uri="{FF2B5EF4-FFF2-40B4-BE49-F238E27FC236}">
-                <a16:creationId xmlns:a16="http://schemas.microsoft.com/office/drawing/2014/main" id="{86EF07BF-473F-4C16-8C5B-F490BD333146}"/>
+                <a16:creationId xmlns:a16="http://schemas.microsoft.com/office/drawing/2014/main" id="{A583F5C3-66D4-49E3-8E87-133F885C383F}"/>
               </a:ext>
             </a:extLst>
           </p:cNvPr>
@@ -13078,7 +13078,7 @@
           <p:cNvPr id="26" name="">
             <a:extLst xmlns:a="http://schemas.openxmlformats.org/drawingml/2006/main">
               <a:ext uri="{FF2B5EF4-FFF2-40B4-BE49-F238E27FC236}">
-                <a16:creationId xmlns:a16="http://schemas.microsoft.com/office/drawing/2014/main" id="{EA5EA3D2-15A3-4247-BAED-A276021FC929}"/>
+                <a16:creationId xmlns:a16="http://schemas.microsoft.com/office/drawing/2014/main" id="{243F4A83-CB7E-4357-A439-918104C99C92}"/>
               </a:ext>
             </a:extLst>
           </p:cNvPr>
@@ -13123,7 +13123,7 @@
           <p:cNvPr id="27" name="">
             <a:extLst xmlns:a="http://schemas.openxmlformats.org/drawingml/2006/main">
               <a:ext uri="{FF2B5EF4-FFF2-40B4-BE49-F238E27FC236}">
-                <a16:creationId xmlns:a16="http://schemas.microsoft.com/office/drawing/2014/main" id="{ED24E207-92AF-4F52-A2D6-D910E546BEAD}"/>
+                <a16:creationId xmlns:a16="http://schemas.microsoft.com/office/drawing/2014/main" id="{5B177F17-7783-46DA-84DC-51E896C67E6D}"/>
               </a:ext>
             </a:extLst>
           </p:cNvPr>
@@ -13168,7 +13168,7 @@
           <p:cNvPr id="28" name="">
             <a:extLst xmlns:a="http://schemas.openxmlformats.org/drawingml/2006/main">
               <a:ext uri="{FF2B5EF4-FFF2-40B4-BE49-F238E27FC236}">
-                <a16:creationId xmlns:a16="http://schemas.microsoft.com/office/drawing/2014/main" id="{F570B61E-BB5E-4E18-BE03-A52A6A5ABC0A}"/>
+                <a16:creationId xmlns:a16="http://schemas.microsoft.com/office/drawing/2014/main" id="{CC49D48C-29B5-40A3-98D9-B34175F6C7E5}"/>
               </a:ext>
             </a:extLst>
           </p:cNvPr>
@@ -13211,7 +13211,7 @@
     </p:spTree>
     <p:extLst>
       <p:ext uri="{BB962C8B-B14F-4D97-AF65-F5344CB8AC3E}">
-        <p14:creationId xmlns:p14="http://schemas.microsoft.com/office/powerpoint/2010/main" val="940959912"/>
+        <p14:creationId xmlns:p14="http://schemas.microsoft.com/office/powerpoint/2010/main" val="302766205"/>
       </p:ext>
     </p:extLst>
   </p:cSld>

</xml_diff>